<commit_message>
feat: complete cinematic V2 platform transformation with Emergency SOS overlay, and compile-safe hackathon presentation & DOCX proposal documents
</commit_message>
<xml_diff>
--- a/RaastaSense_Hackathon_Presentation.pptx
+++ b/RaastaSense_Hackathon_Presentation.pptx
@@ -12,7 +12,6 @@
     <p:sldId id="260" r:id="rId11"/>
     <p:sldId id="261" r:id="rId12"/>
     <p:sldId id="262" r:id="rId13"/>
-    <p:sldId id="263" r:id="rId14"/>
   </p:sldIdLst>
   <p:sldSz cx="12191695" cy="6858000" type="screen4x3"/>
   <p:notesSz cx="6858000" cy="9144000"/>
@@ -3111,8 +3110,8 @@
         </p:nvSpPr>
         <p:spPr>
           <a:xfrm>
-            <a:off x="0" y="0"/>
-            <a:ext cx="274320" cy="6858000"/>
+            <a:off x="457200" y="457200"/>
+            <a:ext cx="137160" cy="5943600"/>
           </a:xfrm>
           <a:prstGeom prst="rect">
             <a:avLst/>
@@ -3154,8 +3153,8 @@
         </p:nvSpPr>
         <p:spPr>
           <a:xfrm>
-            <a:off x="1097280" y="1645920"/>
-            <a:ext cx="10058400" cy="1371600"/>
+            <a:off x="822960" y="1371600"/>
+            <a:ext cx="10515600" cy="4114800"/>
           </a:xfrm>
           <a:prstGeom prst="rect">
             <a:avLst/>
@@ -3169,162 +3168,60 @@
           <a:lstStyle/>
           <a:p>
             <a:pPr>
-              <a:defRPr sz="6800" b="1">
+              <a:spcAft>
+                <a:spcPts val="1000"/>
+              </a:spcAft>
+              <a:defRPr sz="6400" b="1">
+                <a:solidFill>
+                  <a:srgbClr val="FFFFFF"/>
+                </a:solidFill>
+                <a:latin typeface="Segoe UI"/>
+              </a:defRPr>
+            </a:pPr>
+            <a:r>
+              <a:t>RaastaSense</a:t>
+            </a:r>
+          </a:p>
+          <a:p>
+            <a:pPr>
+              <a:spcAft>
+                <a:spcPts val="5000"/>
+              </a:spcAft>
+              <a:defRPr sz="2200" b="1">
                 <a:solidFill>
                   <a:srgbClr val="38BDF8"/>
                 </a:solidFill>
-                <a:latin typeface="Century Gothic"/>
+                <a:latin typeface="Segoe UI"/>
               </a:defRPr>
             </a:pPr>
             <a:r>
-              <a:t>RAASTASENSE</a:t>
-            </a:r>
-          </a:p>
-        </p:txBody>
-      </p:sp>
-      <p:sp>
-        <p:nvSpPr>
-          <p:cNvPr id="4" name="TextBox 3"/>
-          <p:cNvSpPr txBox="1"/>
-          <p:nvPr/>
-        </p:nvSpPr>
-        <p:spPr>
-          <a:xfrm>
-            <a:off x="1097280" y="2651760"/>
-            <a:ext cx="10058400" cy="731520"/>
-          </a:xfrm>
-          <a:prstGeom prst="rect">
-            <a:avLst/>
-          </a:prstGeom>
-          <a:noFill/>
-        </p:spPr>
-        <p:txBody>
-          <a:bodyPr wrap="square">
-            <a:spAutoFit/>
-          </a:bodyPr>
-          <a:lstStyle/>
+              <a:t>Transforming Road Safety Through Intelligence</a:t>
+            </a:r>
+          </a:p>
           <a:p>
             <a:pPr>
-              <a:defRPr sz="2200" b="0">
-                <a:solidFill>
-                  <a:srgbClr val="F8FAFC"/>
-                </a:solidFill>
-                <a:latin typeface="Century Gothic"/>
+              <a:defRPr sz="1400" b="1">
+                <a:solidFill>
+                  <a:srgbClr val="F59E0B"/>
+                </a:solidFill>
+                <a:latin typeface="Segoe UI"/>
               </a:defRPr>
             </a:pPr>
             <a:r>
-              <a:t>Transforming Road Safety Through Intelligence</a:t>
-            </a:r>
-          </a:p>
-        </p:txBody>
-      </p:sp>
-      <p:sp>
-        <p:nvSpPr>
-          <p:cNvPr id="5" name="Rectangle 4"/>
-          <p:cNvSpPr/>
-          <p:nvPr/>
-        </p:nvSpPr>
-        <p:spPr>
-          <a:xfrm>
-            <a:off x="1097280" y="3474720"/>
-            <a:ext cx="4114800" cy="36576"/>
-          </a:xfrm>
-          <a:prstGeom prst="rect">
-            <a:avLst/>
-          </a:prstGeom>
-          <a:solidFill>
-            <a:srgbClr val="F59E0B"/>
-          </a:solidFill>
-          <a:ln>
-            <a:noFill/>
-          </a:ln>
-        </p:spPr>
-        <p:style>
-          <a:lnRef idx="1">
-            <a:schemeClr val="accent1"/>
-          </a:lnRef>
-          <a:fillRef idx="3">
-            <a:schemeClr val="accent1"/>
-          </a:fillRef>
-          <a:effectRef idx="2">
-            <a:schemeClr val="accent1"/>
-          </a:effectRef>
-          <a:fontRef idx="minor">
-            <a:schemeClr val="lt1"/>
-          </a:fontRef>
-        </p:style>
-        <p:txBody>
-          <a:bodyPr rtlCol="0" anchor="ctr"/>
-          <a:lstStyle/>
-          <a:p>
-            <a:pPr algn="ctr"/>
-          </a:p>
-        </p:txBody>
-      </p:sp>
-      <p:sp>
-        <p:nvSpPr>
-          <p:cNvPr id="6" name="TextBox 5"/>
-          <p:cNvSpPr txBox="1"/>
-          <p:nvPr/>
-        </p:nvSpPr>
-        <p:spPr>
-          <a:xfrm>
-            <a:off x="1097280" y="3840480"/>
-            <a:ext cx="7315200" cy="1371600"/>
-          </a:xfrm>
-          <a:prstGeom prst="rect">
-            <a:avLst/>
-          </a:prstGeom>
-          <a:noFill/>
-        </p:spPr>
-        <p:txBody>
-          <a:bodyPr wrap="square">
-            <a:spAutoFit/>
-          </a:bodyPr>
-          <a:lstStyle/>
+              <a:t>Team: NXT-waVE (IIT Madras Road Safety Hackathon)</a:t>
+            </a:r>
+          </a:p>
           <a:p>
             <a:pPr>
               <a:defRPr sz="1600" b="1">
                 <a:solidFill>
-                  <a:srgbClr val="F59E0B"/>
-                </a:solidFill>
-                <a:latin typeface="Century Gothic"/>
+                  <a:srgbClr val="FFFFFF"/>
+                </a:solidFill>
+                <a:latin typeface="Segoe UI"/>
               </a:defRPr>
             </a:pPr>
             <a:r>
-              <a:t>TEAM: NXT-waVE</a:t>
-            </a:r>
-          </a:p>
-          <a:p>
-            <a:pPr>
-              <a:spcBef>
-                <a:spcPts val="400"/>
-              </a:spcBef>
-              <a:defRPr sz="1400">
-                <a:solidFill>
-                  <a:srgbClr val="F8FAFC"/>
-                </a:solidFill>
-                <a:latin typeface="Century Gothic"/>
-              </a:defRPr>
-            </a:pPr>
-            <a:r>
-              <a:t>MEMBERS: AJAY RATHOD | ANIMESH BHANARKAR</a:t>
-            </a:r>
-          </a:p>
-          <a:p>
-            <a:pPr>
-              <a:spcBef>
-                <a:spcPts val="800"/>
-              </a:spcBef>
-              <a:defRPr sz="1200" b="1">
-                <a:solidFill>
-                  <a:srgbClr val="38BDF8"/>
-                </a:solidFill>
-                <a:latin typeface="Century Gothic"/>
-              </a:defRPr>
-            </a:pPr>
-            <a:r>
-              <a:t>IIT Madras Road Safety Hackathon 2026</a:t>
+              <a:t>AJAY RATHOD  |  ANIMESH BHANARKAR</a:t>
             </a:r>
           </a:p>
         </p:txBody>
@@ -3363,8 +3260,8 @@
         </p:nvSpPr>
         <p:spPr>
           <a:xfrm>
-            <a:off x="685800" y="365760"/>
-            <a:ext cx="9144000" cy="365760"/>
+            <a:off x="731520" y="457200"/>
+            <a:ext cx="10698480" cy="731520"/>
           </a:xfrm>
           <a:prstGeom prst="rect">
             <a:avLst/>
@@ -3372,71 +3269,35 @@
           <a:noFill/>
         </p:spPr>
         <p:txBody>
-          <a:bodyPr wrap="square" lIns="0">
+          <a:bodyPr wrap="none">
             <a:spAutoFit/>
           </a:bodyPr>
           <a:lstStyle/>
           <a:p>
             <a:pPr>
-              <a:defRPr sz="1000" b="1">
-                <a:solidFill>
-                  <a:srgbClr val="38BDF8"/>
-                </a:solidFill>
-                <a:latin typeface="Century Gothic"/>
+              <a:defRPr sz="2800" b="1">
+                <a:solidFill>
+                  <a:srgbClr val="F43F5E"/>
+                </a:solidFill>
+                <a:latin typeface="Segoe UI"/>
               </a:defRPr>
             </a:pPr>
             <a:r>
-              <a:t>NATIONAL TELEMETRY &amp; CRISIS</a:t>
-            </a:r>
-          </a:p>
-        </p:txBody>
-      </p:sp>
-      <p:sp>
-        <p:nvSpPr>
-          <p:cNvPr id="3" name="TextBox 2"/>
-          <p:cNvSpPr txBox="1"/>
+              <a:t>THE NATIONAL ROAD SAFETY CRISIS</a:t>
+            </a:r>
+          </a:p>
+        </p:txBody>
+      </p:sp>
+      <p:sp>
+        <p:nvSpPr>
+          <p:cNvPr id="3" name="Rounded Rectangle 2"/>
+          <p:cNvSpPr/>
           <p:nvPr/>
         </p:nvSpPr>
         <p:spPr>
           <a:xfrm>
-            <a:off x="685800" y="594360"/>
-            <a:ext cx="10817352" cy="731520"/>
-          </a:xfrm>
-          <a:prstGeom prst="rect">
-            <a:avLst/>
-          </a:prstGeom>
-          <a:noFill/>
-        </p:spPr>
-        <p:txBody>
-          <a:bodyPr wrap="square" lIns="0">
-            <a:spAutoFit/>
-          </a:bodyPr>
-          <a:lstStyle/>
-          <a:p>
-            <a:pPr>
-              <a:defRPr sz="3200" b="1">
-                <a:solidFill>
-                  <a:srgbClr val="F8FAFC"/>
-                </a:solidFill>
-                <a:latin typeface="Century Gothic"/>
-              </a:defRPr>
-            </a:pPr>
-            <a:r>
-              <a:t>The Critical Road Safety Challenge</a:t>
-            </a:r>
-          </a:p>
-        </p:txBody>
-      </p:sp>
-      <p:sp>
-        <p:nvSpPr>
-          <p:cNvPr id="4" name="Rounded Rectangle 3"/>
-          <p:cNvSpPr/>
-          <p:nvPr/>
-        </p:nvSpPr>
-        <p:spPr>
-          <a:xfrm>
-            <a:off x="685800" y="1645920"/>
-            <a:ext cx="4754880" cy="4297680"/>
+            <a:off x="731520" y="1463040"/>
+            <a:ext cx="5120640" cy="4389120"/>
           </a:xfrm>
           <a:prstGeom prst="roundRect">
             <a:avLst/>
@@ -3465,117 +3326,71 @@
           </a:fontRef>
         </p:style>
         <p:txBody>
-          <a:bodyPr rtlCol="0" anchor="ctr"/>
-          <a:lstStyle/>
-          <a:p>
-            <a:pPr algn="ctr"/>
-          </a:p>
-        </p:txBody>
-      </p:sp>
-      <p:sp>
-        <p:nvSpPr>
-          <p:cNvPr id="5" name="TextBox 4"/>
-          <p:cNvSpPr txBox="1"/>
-          <p:nvPr/>
-        </p:nvSpPr>
-        <p:spPr>
-          <a:xfrm>
-            <a:off x="914400" y="1920240"/>
-            <a:ext cx="4297680" cy="3749039"/>
-          </a:xfrm>
-          <a:prstGeom prst="rect">
-            <a:avLst/>
-          </a:prstGeom>
-          <a:noFill/>
-        </p:spPr>
-        <p:txBody>
-          <a:bodyPr wrap="square">
-            <a:spAutoFit/>
-          </a:bodyPr>
-          <a:lstStyle/>
-          <a:p>
-            <a:pPr>
-              <a:defRPr sz="4800" b="1">
-                <a:solidFill>
-                  <a:srgbClr val="F43F5E"/>
-                </a:solidFill>
-                <a:latin typeface="Century Gothic"/>
-              </a:defRPr>
-            </a:pPr>
-            <a:r>
-              <a:t>1.5 Lakhs+</a:t>
-            </a:r>
-          </a:p>
-          <a:p>
-            <a:pPr>
-              <a:spcAft>
-                <a:spcPts val="2800"/>
-              </a:spcAft>
-              <a:defRPr sz="1400">
-                <a:solidFill>
-                  <a:srgbClr val="F8FAFC"/>
-                </a:solidFill>
-                <a:latin typeface="Century Gothic"/>
-              </a:defRPr>
-            </a:pPr>
-            <a:r>
-              <a:t>Indian Road Deaths Annually</a:t>
-            </a:r>
-          </a:p>
-          <a:p>
-            <a:pPr>
-              <a:defRPr sz="4200" b="1">
-                <a:solidFill>
-                  <a:srgbClr val="F59E0B"/>
-                </a:solidFill>
-                <a:latin typeface="Century Gothic"/>
-              </a:defRPr>
-            </a:pPr>
-            <a:r>
-              <a:t>₹5.8 Lakh Cr</a:t>
-            </a:r>
-          </a:p>
-          <a:p>
-            <a:pPr>
+          <a:bodyPr rtlCol="0" anchor="ctr" wrap="square" lIns="274320" rIns="274320" tIns="274320"/>
+          <a:lstStyle/>
+          <a:p>
+            <a:pPr algn="ctr">
               <a:spcAft>
                 <a:spcPts val="2000"/>
               </a:spcAft>
+              <a:defRPr sz="2000" b="1">
+                <a:solidFill>
+                  <a:srgbClr val="FFFFFF"/>
+                </a:solidFill>
+                <a:latin typeface="Segoe UI"/>
+              </a:defRPr>
+            </a:pPr>
+            <a:r>
+              <a:t>🚨 Critical National Statistics</a:t>
+            </a:r>
+          </a:p>
+          <a:p>
+            <a:pPr>
               <a:defRPr sz="1400">
                 <a:solidFill>
-                  <a:srgbClr val="F8FAFC"/>
-                </a:solidFill>
-                <a:latin typeface="Century Gothic"/>
+                  <a:srgbClr val="94A3B8"/>
+                </a:solidFill>
+                <a:latin typeface="Segoe UI"/>
               </a:defRPr>
             </a:pPr>
             <a:r>
-              <a:t>Economic Loss Due to Infrastructure &amp; Violations</a:t>
-            </a:r>
-          </a:p>
-          <a:p>
-            <a:pPr>
-              <a:defRPr sz="1000" i="1">
-                <a:solidFill>
-                  <a:srgbClr val="94A3B8"/>
-                </a:solidFill>
-                <a:latin typeface="Century Gothic"/>
-              </a:defRPr>
-            </a:pPr>
-            <a:r>
-              <a:t>Source: Ministry of Road Transport &amp; Highways (MoRTH)</a:t>
-            </a:r>
-          </a:p>
-        </p:txBody>
-      </p:sp>
-      <p:sp>
-        <p:nvSpPr>
-          <p:cNvPr id="6" name="Rounded Rectangle 5"/>
+              <a:t>• 1.5 Lakhs+ Annual Fatalities</a:t>
+            </a:r>
+            <a:br/>
+            <a:r>
+              <a:t>  Indian corridors average over 400 deaths per day.</a:t>
+            </a:r>
+            <a:br/>
+            <a:br/>
+            <a:r>
+              <a:t>• ₹5.8 Lakh Crores Economic Loss</a:t>
+            </a:r>
+            <a:br/>
+            <a:r>
+              <a:t>  Accidents deplete ~3% of India's annual GDP.</a:t>
+            </a:r>
+            <a:br/>
+            <a:br/>
+            <a:r>
+              <a:t>• 50%+ Preventable Deaths</a:t>
+            </a:r>
+            <a:br/>
+            <a:r>
+              <a:t>  Delayed Golden Hour response &amp; static navigation.</a:t>
+            </a:r>
+          </a:p>
+        </p:txBody>
+      </p:sp>
+      <p:sp>
+        <p:nvSpPr>
+          <p:cNvPr id="4" name="Rounded Rectangle 3"/>
           <p:cNvSpPr/>
           <p:nvPr/>
         </p:nvSpPr>
         <p:spPr>
           <a:xfrm>
-            <a:off x="5833872" y="1645920"/>
-            <a:ext cx="5669280" cy="4297680"/>
+            <a:off x="6217920" y="1463040"/>
+            <a:ext cx="5120640" cy="4389120"/>
           </a:xfrm>
           <a:prstGeom prst="roundRect">
             <a:avLst/>
@@ -3604,144 +3419,45 @@
           </a:fontRef>
         </p:style>
         <p:txBody>
-          <a:bodyPr rtlCol="0" anchor="ctr"/>
-          <a:lstStyle/>
-          <a:p>
-            <a:pPr algn="ctr"/>
-          </a:p>
-        </p:txBody>
-      </p:sp>
-      <p:sp>
-        <p:nvSpPr>
-          <p:cNvPr id="7" name="TextBox 6"/>
-          <p:cNvSpPr txBox="1"/>
-          <p:nvPr/>
-        </p:nvSpPr>
-        <p:spPr>
-          <a:xfrm>
-            <a:off x="6108192" y="1920240"/>
-            <a:ext cx="5120640" cy="3749039"/>
-          </a:xfrm>
-          <a:prstGeom prst="rect">
-            <a:avLst/>
-          </a:prstGeom>
-          <a:noFill/>
-        </p:spPr>
-        <p:txBody>
-          <a:bodyPr wrap="square">
-            <a:spAutoFit/>
-          </a:bodyPr>
-          <a:lstStyle/>
+          <a:bodyPr rtlCol="0" anchor="ctr" wrap="square" lIns="274320" rIns="274320" tIns="274320"/>
+          <a:lstStyle/>
+          <a:p>
+            <a:pPr algn="ctr">
+              <a:spcAft>
+                <a:spcPts val="2000"/>
+              </a:spcAft>
+              <a:defRPr sz="2000" b="1">
+                <a:solidFill>
+                  <a:srgbClr val="FFFFFF"/>
+                </a:solidFill>
+                <a:latin typeface="Segoe UI"/>
+              </a:defRPr>
+            </a:pPr>
+            <a:r>
+              <a:t>⚠️ Core Infrastructure Gaps</a:t>
+            </a:r>
+          </a:p>
           <a:p>
             <a:pPr>
-              <a:spcAft>
-                <a:spcPts val="1400"/>
-              </a:spcAft>
-              <a:defRPr sz="1600" b="1">
-                <a:solidFill>
-                  <a:srgbClr val="38BDF8"/>
-                </a:solidFill>
-                <a:latin typeface="Century Gothic"/>
+              <a:defRPr sz="1400">
+                <a:solidFill>
+                  <a:srgbClr val="94A3B8"/>
+                </a:solidFill>
+                <a:latin typeface="Segoe UI"/>
               </a:defRPr>
             </a:pPr>
             <a:r>
-              <a:t>CRITICAL PAIN POINTS</a:t>
-            </a:r>
-          </a:p>
-          <a:p>
-            <a:pPr>
-              <a:spcBef>
-                <a:spcPts val="800"/>
-              </a:spcBef>
-              <a:defRPr sz="1300" b="1">
-                <a:solidFill>
-                  <a:srgbClr val="F59E0B"/>
-                </a:solidFill>
-                <a:latin typeface="Century Gothic"/>
-              </a:defRPr>
-            </a:pPr>
-            <a:r>
-              <a:t>■  Golden Hour Responding</a:t>
-            </a:r>
-          </a:p>
-          <a:p>
-            <a:pPr>
-              <a:spcAft>
-                <a:spcPts val="800"/>
-              </a:spcAft>
-              <a:defRPr sz="1150">
-                <a:solidFill>
-                  <a:srgbClr val="F8FAFC"/>
-                </a:solidFill>
-                <a:latin typeface="Century Gothic"/>
-              </a:defRPr>
-            </a:pPr>
-            <a:r>
-              <a:t>Emergency vehicles struggle with unoptimized route telemetry, inaccurate GPS positions, and zero countdown coordination.</a:t>
-            </a:r>
-          </a:p>
-          <a:p>
-            <a:pPr>
-              <a:spcBef>
-                <a:spcPts val="800"/>
-              </a:spcBef>
-              <a:defRPr sz="1300" b="1">
-                <a:solidFill>
-                  <a:srgbClr val="F59E0B"/>
-                </a:solidFill>
-                <a:latin typeface="Century Gothic"/>
-              </a:defRPr>
-            </a:pPr>
-            <a:r>
-              <a:t>■  Infrastructure Transparency</a:t>
-            </a:r>
-          </a:p>
-          <a:p>
-            <a:pPr>
-              <a:spcAft>
-                <a:spcPts val="800"/>
-              </a:spcAft>
-              <a:defRPr sz="1150">
-                <a:solidFill>
-                  <a:srgbClr val="F8FAFC"/>
-                </a:solidFill>
-                <a:latin typeface="Century Gothic"/>
-              </a:defRPr>
-            </a:pPr>
-            <a:r>
-              <a:t>No direct mechanism exists for citizens to track public repair budget utilization and resolution steppers.</a:t>
-            </a:r>
-          </a:p>
-          <a:p>
-            <a:pPr>
-              <a:spcBef>
-                <a:spcPts val="800"/>
-              </a:spcBef>
-              <a:defRPr sz="1300" b="1">
-                <a:solidFill>
-                  <a:srgbClr val="F59E0B"/>
-                </a:solidFill>
-                <a:latin typeface="Century Gothic"/>
-              </a:defRPr>
-            </a:pPr>
-            <a:r>
-              <a:t>■  Legal Safety Ambiguity</a:t>
-            </a:r>
-          </a:p>
-          <a:p>
-            <a:pPr>
-              <a:spcAft>
-                <a:spcPts val="800"/>
-              </a:spcAft>
-              <a:defRPr sz="1150">
-                <a:solidFill>
-                  <a:srgbClr val="F8FAFC"/>
-                </a:solidFill>
-                <a:latin typeface="Century Gothic"/>
-              </a:defRPr>
-            </a:pPr>
-            <a:r>
-              <a:t>Absence of localized driving rules indexes and dynamic fine systems across states (e.g. TN, MH, KA).</a:t>
+              <a:t>• Responders blind to real-time satellite coordinates &amp; golden hour locks.</a:t>
+            </a:r>
+            <a:br/>
+            <a:br/>
+            <a:r>
+              <a:t>• Civic reports lacking public audit trails or visual pothole classification.</a:t>
+            </a:r>
+            <a:br/>
+            <a:br/>
+            <a:r>
+              <a:t>• Driving violations static across municipal jurisdictions with no localized counselor.</a:t>
             </a:r>
           </a:p>
         </p:txBody>
@@ -3780,8 +3496,8 @@
         </p:nvSpPr>
         <p:spPr>
           <a:xfrm>
-            <a:off x="685800" y="365760"/>
-            <a:ext cx="9144000" cy="365760"/>
+            <a:off x="731520" y="457200"/>
+            <a:ext cx="10698480" cy="731520"/>
           </a:xfrm>
           <a:prstGeom prst="rect">
             <a:avLst/>
@@ -3789,35 +3505,274 @@
           <a:noFill/>
         </p:spPr>
         <p:txBody>
-          <a:bodyPr wrap="square" lIns="0">
+          <a:bodyPr wrap="none">
             <a:spAutoFit/>
           </a:bodyPr>
           <a:lstStyle/>
           <a:p>
             <a:pPr>
-              <a:defRPr sz="1000" b="1">
+              <a:defRPr sz="2800" b="1">
                 <a:solidFill>
                   <a:srgbClr val="38BDF8"/>
                 </a:solidFill>
-                <a:latin typeface="Century Gothic"/>
+                <a:latin typeface="Segoe UI"/>
               </a:defRPr>
             </a:pPr>
             <a:r>
-              <a:t>TACTICAL SOLUTION CORE</a:t>
-            </a:r>
-          </a:p>
-        </p:txBody>
-      </p:sp>
-      <p:sp>
-        <p:nvSpPr>
-          <p:cNvPr id="3" name="TextBox 2"/>
+              <a:t>THE RAASTASENSE SOLUTION</a:t>
+            </a:r>
+          </a:p>
+        </p:txBody>
+      </p:sp>
+      <p:sp>
+        <p:nvSpPr>
+          <p:cNvPr id="3" name="Rounded Rectangle 2"/>
+          <p:cNvSpPr/>
+          <p:nvPr/>
+        </p:nvSpPr>
+        <p:spPr>
+          <a:xfrm>
+            <a:off x="731520" y="1645920"/>
+            <a:ext cx="3291840" cy="4114800"/>
+          </a:xfrm>
+          <a:prstGeom prst="roundRect">
+            <a:avLst/>
+          </a:prstGeom>
+          <a:solidFill>
+            <a:srgbClr val="1E293B"/>
+          </a:solidFill>
+          <a:ln>
+            <a:solidFill>
+              <a:srgbClr val="38BDF8"/>
+            </a:solidFill>
+          </a:ln>
+        </p:spPr>
+        <p:style>
+          <a:lnRef idx="1">
+            <a:schemeClr val="accent1"/>
+          </a:lnRef>
+          <a:fillRef idx="3">
+            <a:schemeClr val="accent1"/>
+          </a:fillRef>
+          <a:effectRef idx="2">
+            <a:schemeClr val="accent1"/>
+          </a:effectRef>
+          <a:fontRef idx="minor">
+            <a:schemeClr val="lt1"/>
+          </a:fontRef>
+        </p:style>
+        <p:txBody>
+          <a:bodyPr rtlCol="0" anchor="ctr" wrap="square" tIns="274320"/>
+          <a:lstStyle/>
+          <a:p>
+            <a:pPr algn="ctr">
+              <a:spcAft>
+                <a:spcPts val="1400"/>
+              </a:spcAft>
+              <a:defRPr sz="1800" b="1">
+                <a:solidFill>
+                  <a:srgbClr val="FFFFFF"/>
+                </a:solidFill>
+                <a:latin typeface="Segoe UI"/>
+              </a:defRPr>
+            </a:pPr>
+            <a:r>
+              <a:t>🗺️ GIS Live Map HUD</a:t>
+            </a:r>
+          </a:p>
+          <a:p>
+            <a:pPr>
+              <a:defRPr sz="1300">
+                <a:solidFill>
+                  <a:srgbClr val="94A3B8"/>
+                </a:solidFill>
+                <a:latin typeface="Segoe UI"/>
+              </a:defRPr>
+            </a:pPr>
+            <a:r>
+              <a:t>Cyberslate interactive mapping featuring active incident reporting overlays, speedometers, and live coordinate locks.</a:t>
+            </a:r>
+          </a:p>
+        </p:txBody>
+      </p:sp>
+      <p:sp>
+        <p:nvSpPr>
+          <p:cNvPr id="4" name="Rounded Rectangle 3"/>
+          <p:cNvSpPr/>
+          <p:nvPr/>
+        </p:nvSpPr>
+        <p:spPr>
+          <a:xfrm>
+            <a:off x="4389120" y="1645920"/>
+            <a:ext cx="3291840" cy="4114800"/>
+          </a:xfrm>
+          <a:prstGeom prst="roundRect">
+            <a:avLst/>
+          </a:prstGeom>
+          <a:solidFill>
+            <a:srgbClr val="1E293B"/>
+          </a:solidFill>
+          <a:ln>
+            <a:solidFill>
+              <a:srgbClr val="F59E0B"/>
+            </a:solidFill>
+          </a:ln>
+        </p:spPr>
+        <p:style>
+          <a:lnRef idx="1">
+            <a:schemeClr val="accent1"/>
+          </a:lnRef>
+          <a:fillRef idx="3">
+            <a:schemeClr val="accent1"/>
+          </a:fillRef>
+          <a:effectRef idx="2">
+            <a:schemeClr val="accent1"/>
+          </a:effectRef>
+          <a:fontRef idx="minor">
+            <a:schemeClr val="lt1"/>
+          </a:fontRef>
+        </p:style>
+        <p:txBody>
+          <a:bodyPr rtlCol="0" anchor="ctr" wrap="square" tIns="274320"/>
+          <a:lstStyle/>
+          <a:p>
+            <a:pPr algn="ctr">
+              <a:spcAft>
+                <a:spcPts val="1400"/>
+              </a:spcAft>
+              <a:defRPr sz="1800" b="1">
+                <a:solidFill>
+                  <a:srgbClr val="FFFFFF"/>
+                </a:solidFill>
+                <a:latin typeface="Segoe UI"/>
+              </a:defRPr>
+            </a:pPr>
+            <a:r>
+              <a:t>🛡️ AI Legal Advisor</a:t>
+            </a:r>
+          </a:p>
+          <a:p>
+            <a:pPr>
+              <a:defRPr sz="1300">
+                <a:solidFill>
+                  <a:srgbClr val="94A3B8"/>
+                </a:solidFill>
+                <a:latin typeface="Segoe UI"/>
+              </a:defRPr>
+            </a:pPr>
+            <a:r>
+              <a:t>9-language custom localizer featuring automatic fine surcharges, legal index, and character dialogue advisory boards.</a:t>
+            </a:r>
+          </a:p>
+        </p:txBody>
+      </p:sp>
+      <p:sp>
+        <p:nvSpPr>
+          <p:cNvPr id="5" name="Rounded Rectangle 4"/>
+          <p:cNvSpPr/>
+          <p:nvPr/>
+        </p:nvSpPr>
+        <p:spPr>
+          <a:xfrm>
+            <a:off x="8046720" y="1645920"/>
+            <a:ext cx="3291840" cy="4114800"/>
+          </a:xfrm>
+          <a:prstGeom prst="roundRect">
+            <a:avLst/>
+          </a:prstGeom>
+          <a:solidFill>
+            <a:srgbClr val="1E293B"/>
+          </a:solidFill>
+          <a:ln>
+            <a:solidFill>
+              <a:srgbClr val="F43F5E"/>
+            </a:solidFill>
+          </a:ln>
+        </p:spPr>
+        <p:style>
+          <a:lnRef idx="1">
+            <a:schemeClr val="accent1"/>
+          </a:lnRef>
+          <a:fillRef idx="3">
+            <a:schemeClr val="accent1"/>
+          </a:fillRef>
+          <a:effectRef idx="2">
+            <a:schemeClr val="accent1"/>
+          </a:effectRef>
+          <a:fontRef idx="minor">
+            <a:schemeClr val="lt1"/>
+          </a:fontRef>
+        </p:style>
+        <p:txBody>
+          <a:bodyPr rtlCol="0" anchor="ctr" wrap="square" tIns="274320"/>
+          <a:lstStyle/>
+          <a:p>
+            <a:pPr algn="ctr">
+              <a:spcAft>
+                <a:spcPts val="1400"/>
+              </a:spcAft>
+              <a:defRPr sz="1800" b="1">
+                <a:solidFill>
+                  <a:srgbClr val="FFFFFF"/>
+                </a:solidFill>
+                <a:latin typeface="Segoe UI"/>
+              </a:defRPr>
+            </a:pPr>
+            <a:r>
+              <a:t>🆘 SOS Rescue Hub</a:t>
+            </a:r>
+          </a:p>
+          <a:p>
+            <a:pPr>
+              <a:defRPr sz="1300">
+                <a:solidFill>
+                  <a:srgbClr val="94A3B8"/>
+                </a:solidFill>
+                <a:latin typeface="Segoe UI"/>
+              </a:defRPr>
+            </a:pPr>
+            <a:r>
+              <a:t>Decentralized emergency countdown beacon, golden-hour responder coordination, and pre-routed medical pathways.</a:t>
+            </a:r>
+          </a:p>
+        </p:txBody>
+      </p:sp>
+    </p:spTree>
+  </p:cSld>
+  <p:clrMapOvr>
+    <a:masterClrMapping/>
+  </p:clrMapOvr>
+</p:sld>
+</file>
+
+<file path=ppt/slides/slide4.xml><?xml version="1.0" encoding="utf-8"?>
+<p:sld xmlns:a="http://schemas.openxmlformats.org/drawingml/2006/main" xmlns:p="http://schemas.openxmlformats.org/presentationml/2006/main" xmlns:r="http://schemas.openxmlformats.org/officeDocument/2006/relationships">
+  <p:cSld>
+    <p:bg>
+      <p:bgPr>
+        <a:solidFill>
+          <a:srgbClr val="0F172A"/>
+        </a:solidFill>
+        <a:effectLst/>
+      </p:bgPr>
+    </p:bg>
+    <p:spTree>
+      <p:nvGrpSpPr>
+        <p:cNvPr id="1" name=""/>
+        <p:cNvGrpSpPr/>
+        <p:nvPr/>
+      </p:nvGrpSpPr>
+      <p:grpSpPr/>
+      <p:sp>
+        <p:nvSpPr>
+          <p:cNvPr id="2" name="TextBox 1"/>
           <p:cNvSpPr txBox="1"/>
           <p:nvPr/>
         </p:nvSpPr>
         <p:spPr>
           <a:xfrm>
-            <a:off x="685800" y="594360"/>
-            <a:ext cx="10817352" cy="731520"/>
+            <a:off x="731520" y="457200"/>
+            <a:ext cx="10698480" cy="731520"/>
           </a:xfrm>
           <a:prstGeom prst="rect">
             <a:avLst/>
@@ -3825,21 +3780,92 @@
           <a:noFill/>
         </p:spPr>
         <p:txBody>
-          <a:bodyPr wrap="square" lIns="0">
+          <a:bodyPr wrap="none">
             <a:spAutoFit/>
           </a:bodyPr>
           <a:lstStyle/>
           <a:p>
             <a:pPr>
-              <a:defRPr sz="3200" b="1">
-                <a:solidFill>
-                  <a:srgbClr val="F8FAFC"/>
-                </a:solidFill>
-                <a:latin typeface="Century Gothic"/>
+              <a:defRPr sz="2800" b="1">
+                <a:solidFill>
+                  <a:srgbClr val="F59E0B"/>
+                </a:solidFill>
+                <a:latin typeface="Segoe UI"/>
               </a:defRPr>
             </a:pPr>
             <a:r>
-              <a:t>RaastaSense: Intelligent Safety Ecosystem</a:t>
+              <a:t>INTELLIGENT CORE ENGINE MODULES</a:t>
+            </a:r>
+          </a:p>
+        </p:txBody>
+      </p:sp>
+      <p:sp>
+        <p:nvSpPr>
+          <p:cNvPr id="3" name="Rounded Rectangle 2"/>
+          <p:cNvSpPr/>
+          <p:nvPr/>
+        </p:nvSpPr>
+        <p:spPr>
+          <a:xfrm>
+            <a:off x="731520" y="1463040"/>
+            <a:ext cx="5120640" cy="2011680"/>
+          </a:xfrm>
+          <a:prstGeom prst="roundRect">
+            <a:avLst/>
+          </a:prstGeom>
+          <a:solidFill>
+            <a:srgbClr val="1E293B"/>
+          </a:solidFill>
+          <a:ln>
+            <a:solidFill>
+              <a:srgbClr val="38BDF8"/>
+            </a:solidFill>
+          </a:ln>
+        </p:spPr>
+        <p:style>
+          <a:lnRef idx="1">
+            <a:schemeClr val="accent1"/>
+          </a:lnRef>
+          <a:fillRef idx="3">
+            <a:schemeClr val="accent1"/>
+          </a:fillRef>
+          <a:effectRef idx="2">
+            <a:schemeClr val="accent1"/>
+          </a:effectRef>
+          <a:fontRef idx="minor">
+            <a:schemeClr val="lt1"/>
+          </a:fontRef>
+        </p:style>
+        <p:txBody>
+          <a:bodyPr rtlCol="0" anchor="ctr" wrap="square" tIns="137160"/>
+          <a:lstStyle/>
+          <a:p>
+            <a:pPr algn="ctr">
+              <a:spcAft>
+                <a:spcPts val="800"/>
+              </a:spcAft>
+              <a:defRPr sz="1600" b="1">
+                <a:solidFill>
+                  <a:srgbClr val="FFFFFF"/>
+                </a:solidFill>
+                <a:latin typeface="Segoe UI"/>
+              </a:defRPr>
+            </a:pPr>
+            <a:r>
+              <a:t>🚦 Safe Route Engine (Phase 8 Highlight)</a:t>
+            </a:r>
+          </a:p>
+          <a:p>
+            <a:pPr>
+              <a:defRPr sz="1200">
+                <a:solidFill>
+                  <a:srgbClr val="94A3B8"/>
+                </a:solidFill>
+                <a:latin typeface="Segoe UI"/>
+              </a:defRPr>
+            </a:pPr>
+            <a:r>
+              <a:t>Calculates Fastest, Safest, and Least Incident corridors. Displays Safety Indexes, weather/traffic conditions, and dynamic recommended overlays.</a:t>
             </a:r>
           </a:p>
         </p:txBody>
@@ -3852,8 +3878,369 @@
         </p:nvSpPr>
         <p:spPr>
           <a:xfrm>
-            <a:off x="685800" y="1645920"/>
-            <a:ext cx="10817352" cy="1280160"/>
+            <a:off x="6217920" y="1463040"/>
+            <a:ext cx="5120640" cy="2011680"/>
+          </a:xfrm>
+          <a:prstGeom prst="roundRect">
+            <a:avLst/>
+          </a:prstGeom>
+          <a:solidFill>
+            <a:srgbClr val="1E293B"/>
+          </a:solidFill>
+          <a:ln>
+            <a:solidFill>
+              <a:srgbClr val="38BDF8"/>
+            </a:solidFill>
+          </a:ln>
+        </p:spPr>
+        <p:style>
+          <a:lnRef idx="1">
+            <a:schemeClr val="accent1"/>
+          </a:lnRef>
+          <a:fillRef idx="3">
+            <a:schemeClr val="accent1"/>
+          </a:fillRef>
+          <a:effectRef idx="2">
+            <a:schemeClr val="accent1"/>
+          </a:effectRef>
+          <a:fontRef idx="minor">
+            <a:schemeClr val="lt1"/>
+          </a:fontRef>
+        </p:style>
+        <p:txBody>
+          <a:bodyPr rtlCol="0" anchor="ctr" wrap="square" tIns="137160"/>
+          <a:lstStyle/>
+          <a:p>
+            <a:pPr algn="ctr">
+              <a:spcAft>
+                <a:spcPts val="800"/>
+              </a:spcAft>
+              <a:defRPr sz="1600" b="1">
+                <a:solidFill>
+                  <a:srgbClr val="FFFFFF"/>
+                </a:solidFill>
+                <a:latin typeface="Segoe UI"/>
+              </a:defRPr>
+            </a:pPr>
+            <a:r>
+              <a:t>⚖️ DriveLegal Regional Surcharges</a:t>
+            </a:r>
+          </a:p>
+          <a:p>
+            <a:pPr>
+              <a:defRPr sz="1200">
+                <a:solidFill>
+                  <a:srgbClr val="94A3B8"/>
+                </a:solidFill>
+                <a:latin typeface="Segoe UI"/>
+              </a:defRPr>
+            </a:pPr>
+            <a:r>
+              <a:t>Filters 6 main road safety codes. Instantly computes fine adjustments based on Indian State surcharges (TN, MH, KA) and delivers voice-synthesized guidelines.</a:t>
+            </a:r>
+          </a:p>
+        </p:txBody>
+      </p:sp>
+      <p:sp>
+        <p:nvSpPr>
+          <p:cNvPr id="5" name="Rounded Rectangle 4"/>
+          <p:cNvSpPr/>
+          <p:nvPr/>
+        </p:nvSpPr>
+        <p:spPr>
+          <a:xfrm>
+            <a:off x="731520" y="3840480"/>
+            <a:ext cx="5120640" cy="2011680"/>
+          </a:xfrm>
+          <a:prstGeom prst="roundRect">
+            <a:avLst/>
+          </a:prstGeom>
+          <a:solidFill>
+            <a:srgbClr val="1E293B"/>
+          </a:solidFill>
+          <a:ln>
+            <a:solidFill>
+              <a:srgbClr val="38BDF8"/>
+            </a:solidFill>
+          </a:ln>
+        </p:spPr>
+        <p:style>
+          <a:lnRef idx="1">
+            <a:schemeClr val="accent1"/>
+          </a:lnRef>
+          <a:fillRef idx="3">
+            <a:schemeClr val="accent1"/>
+          </a:fillRef>
+          <a:effectRef idx="2">
+            <a:schemeClr val="accent1"/>
+          </a:effectRef>
+          <a:fontRef idx="minor">
+            <a:schemeClr val="lt1"/>
+          </a:fontRef>
+        </p:style>
+        <p:txBody>
+          <a:bodyPr rtlCol="0" anchor="ctr" wrap="square" tIns="137160"/>
+          <a:lstStyle/>
+          <a:p>
+            <a:pPr algn="ctr">
+              <a:spcAft>
+                <a:spcPts val="800"/>
+              </a:spcAft>
+              <a:defRPr sz="1600" b="1">
+                <a:solidFill>
+                  <a:srgbClr val="FFFFFF"/>
+                </a:solidFill>
+                <a:latin typeface="Segoe UI"/>
+              </a:defRPr>
+            </a:pPr>
+            <a:r>
+              <a:t>📸 RoadWatch AI Incident Diagnostics</a:t>
+            </a:r>
+          </a:p>
+          <a:p>
+            <a:pPr>
+              <a:defRPr sz="1200">
+                <a:solidFill>
+                  <a:srgbClr val="94A3B8"/>
+                </a:solidFill>
+                <a:latin typeface="Segoe UI"/>
+              </a:defRPr>
+            </a:pPr>
+            <a:r>
+              <a:t>Citizen hazard submission portals. Features automatic AI-powered image diagnosis with calculated confidence matrices, severity metrics, and direct action protocols.</a:t>
+            </a:r>
+          </a:p>
+        </p:txBody>
+      </p:sp>
+      <p:sp>
+        <p:nvSpPr>
+          <p:cNvPr id="6" name="Rounded Rectangle 5"/>
+          <p:cNvSpPr/>
+          <p:nvPr/>
+        </p:nvSpPr>
+        <p:spPr>
+          <a:xfrm>
+            <a:off x="6217920" y="3840480"/>
+            <a:ext cx="5120640" cy="2011680"/>
+          </a:xfrm>
+          <a:prstGeom prst="roundRect">
+            <a:avLst/>
+          </a:prstGeom>
+          <a:solidFill>
+            <a:srgbClr val="1E293B"/>
+          </a:solidFill>
+          <a:ln>
+            <a:solidFill>
+              <a:srgbClr val="38BDF8"/>
+            </a:solidFill>
+          </a:ln>
+        </p:spPr>
+        <p:style>
+          <a:lnRef idx="1">
+            <a:schemeClr val="accent1"/>
+          </a:lnRef>
+          <a:fillRef idx="3">
+            <a:schemeClr val="accent1"/>
+          </a:fillRef>
+          <a:effectRef idx="2">
+            <a:schemeClr val="accent1"/>
+          </a:effectRef>
+          <a:fontRef idx="minor">
+            <a:schemeClr val="lt1"/>
+          </a:fontRef>
+        </p:style>
+        <p:txBody>
+          <a:bodyPr rtlCol="0" anchor="ctr" wrap="square" tIns="137160"/>
+          <a:lstStyle/>
+          <a:p>
+            <a:pPr algn="ctr">
+              <a:spcAft>
+                <a:spcPts val="800"/>
+              </a:spcAft>
+              <a:defRPr sz="1600" b="1">
+                <a:solidFill>
+                  <a:srgbClr val="FFFFFF"/>
+                </a:solidFill>
+                <a:latin typeface="Segoe UI"/>
+              </a:defRPr>
+            </a:pPr>
+            <a:r>
+              <a:t>🆘 RoadSOS Emergency Controller</a:t>
+            </a:r>
+          </a:p>
+          <a:p>
+            <a:pPr>
+              <a:defRPr sz="1200">
+                <a:solidFill>
+                  <a:srgbClr val="94A3B8"/>
+                </a:solidFill>
+                <a:latin typeface="Segoe UI"/>
+              </a:defRPr>
+            </a:pPr>
+            <a:r>
+              <a:t>GPS telemetry tracker locks precise coordinates. Displays immediate emergency dials, trauma center proximities, and custom full-screen alarm dispatch overlay panels.</a:t>
+            </a:r>
+          </a:p>
+        </p:txBody>
+      </p:sp>
+    </p:spTree>
+  </p:cSld>
+  <p:clrMapOvr>
+    <a:masterClrMapping/>
+  </p:clrMapOvr>
+</p:sld>
+</file>
+
+<file path=ppt/slides/slide5.xml><?xml version="1.0" encoding="utf-8"?>
+<p:sld xmlns:a="http://schemas.openxmlformats.org/drawingml/2006/main" xmlns:p="http://schemas.openxmlformats.org/presentationml/2006/main" xmlns:r="http://schemas.openxmlformats.org/officeDocument/2006/relationships">
+  <p:cSld>
+    <p:bg>
+      <p:bgPr>
+        <a:solidFill>
+          <a:srgbClr val="0F172A"/>
+        </a:solidFill>
+        <a:effectLst/>
+      </p:bgPr>
+    </p:bg>
+    <p:spTree>
+      <p:nvGrpSpPr>
+        <p:cNvPr id="1" name=""/>
+        <p:cNvGrpSpPr/>
+        <p:nvPr/>
+      </p:nvGrpSpPr>
+      <p:grpSpPr/>
+      <p:sp>
+        <p:nvSpPr>
+          <p:cNvPr id="2" name="TextBox 1"/>
+          <p:cNvSpPr txBox="1"/>
+          <p:nvPr/>
+        </p:nvSpPr>
+        <p:spPr>
+          <a:xfrm>
+            <a:off x="731520" y="457200"/>
+            <a:ext cx="10698480" cy="731520"/>
+          </a:xfrm>
+          <a:prstGeom prst="rect">
+            <a:avLst/>
+          </a:prstGeom>
+          <a:noFill/>
+        </p:spPr>
+        <p:txBody>
+          <a:bodyPr wrap="none">
+            <a:spAutoFit/>
+          </a:bodyPr>
+          <a:lstStyle/>
+          <a:p>
+            <a:pPr>
+              <a:defRPr sz="2800" b="1">
+                <a:solidFill>
+                  <a:srgbClr val="FFFFFF"/>
+                </a:solidFill>
+                <a:latin typeface="Segoe UI"/>
+              </a:defRPr>
+            </a:pPr>
+            <a:r>
+              <a:t>SYSTEM ARCHITECTURE &amp; OBSERVABILITY HUD</a:t>
+            </a:r>
+          </a:p>
+        </p:txBody>
+      </p:sp>
+      <p:sp>
+        <p:nvSpPr>
+          <p:cNvPr id="3" name="Rounded Rectangle 2"/>
+          <p:cNvSpPr/>
+          <p:nvPr/>
+        </p:nvSpPr>
+        <p:spPr>
+          <a:xfrm>
+            <a:off x="731520" y="1463040"/>
+            <a:ext cx="5120640" cy="4389120"/>
+          </a:xfrm>
+          <a:prstGeom prst="roundRect">
+            <a:avLst/>
+          </a:prstGeom>
+          <a:solidFill>
+            <a:srgbClr val="1E293B"/>
+          </a:solidFill>
+          <a:ln w="19050">
+            <a:solidFill>
+              <a:srgbClr val="38BDF8"/>
+            </a:solidFill>
+          </a:ln>
+        </p:spPr>
+        <p:style>
+          <a:lnRef idx="1">
+            <a:schemeClr val="accent1"/>
+          </a:lnRef>
+          <a:fillRef idx="3">
+            <a:schemeClr val="accent1"/>
+          </a:fillRef>
+          <a:effectRef idx="2">
+            <a:schemeClr val="accent1"/>
+          </a:effectRef>
+          <a:fontRef idx="minor">
+            <a:schemeClr val="lt1"/>
+          </a:fontRef>
+        </p:style>
+        <p:txBody>
+          <a:bodyPr rtlCol="0" anchor="ctr" wrap="square" tIns="274320"/>
+          <a:lstStyle/>
+          <a:p>
+            <a:pPr algn="ctr">
+              <a:spcAft>
+                <a:spcPts val="1800"/>
+              </a:spcAft>
+              <a:defRPr sz="2000" b="1">
+                <a:solidFill>
+                  <a:srgbClr val="FFFFFF"/>
+                </a:solidFill>
+                <a:latin typeface="Segoe UI"/>
+              </a:defRPr>
+            </a:pPr>
+            <a:r>
+              <a:t>⚙️ Full-Stack Pipeline Architecture</a:t>
+            </a:r>
+          </a:p>
+          <a:p>
+            <a:pPr>
+              <a:defRPr sz="1300">
+                <a:solidFill>
+                  <a:srgbClr val="94A3B8"/>
+                </a:solidFill>
+                <a:latin typeface="Segoe UI"/>
+              </a:defRPr>
+            </a:pPr>
+            <a:r>
+              <a:t>• Client Tier: React 18, Vite, Tailwind CSS, Framer Motion, and custom vector SVGs.</a:t>
+            </a:r>
+            <a:br/>
+            <a:br/>
+            <a:r>
+              <a:t>• Map/GIS Layer: OpenStreetMap integrations, polyline vector algorithms, dynamic marker overlays.</a:t>
+            </a:r>
+            <a:br/>
+            <a:br/>
+            <a:r>
+              <a:t>• Backend &amp; Database: Node.js, Express, mock-telemetry sensor algorithms.</a:t>
+            </a:r>
+            <a:br/>
+            <a:br/>
+            <a:r>
+              <a:t>• AI Core: Google Vision API pothole pixel scanner &amp; safety chatbot fallbacks.</a:t>
+            </a:r>
+          </a:p>
+        </p:txBody>
+      </p:sp>
+      <p:sp>
+        <p:nvSpPr>
+          <p:cNvPr id="4" name="Rounded Rectangle 3"/>
+          <p:cNvSpPr/>
+          <p:nvPr/>
+        </p:nvSpPr>
+        <p:spPr>
+          <a:xfrm>
+            <a:off x="6217920" y="1463040"/>
+            <a:ext cx="5120640" cy="4389120"/>
           </a:xfrm>
           <a:prstGeom prst="roundRect">
             <a:avLst/>
@@ -3882,1301 +4269,45 @@
           </a:fontRef>
         </p:style>
         <p:txBody>
-          <a:bodyPr rtlCol="0" anchor="ctr"/>
-          <a:lstStyle/>
-          <a:p>
-            <a:pPr algn="ctr"/>
-          </a:p>
-        </p:txBody>
-      </p:sp>
-      <p:sp>
-        <p:nvSpPr>
-          <p:cNvPr id="5" name="TextBox 4"/>
-          <p:cNvSpPr txBox="1"/>
-          <p:nvPr/>
-        </p:nvSpPr>
-        <p:spPr>
-          <a:xfrm>
-            <a:off x="914400" y="1828800"/>
-            <a:ext cx="10332720" cy="914400"/>
-          </a:xfrm>
-          <a:prstGeom prst="rect">
-            <a:avLst/>
-          </a:prstGeom>
-          <a:noFill/>
-        </p:spPr>
-        <p:txBody>
-          <a:bodyPr wrap="square">
-            <a:spAutoFit/>
-          </a:bodyPr>
+          <a:bodyPr rtlCol="0" anchor="ctr" wrap="square" tIns="274320"/>
           <a:lstStyle/>
           <a:p>
             <a:pPr algn="ctr">
-              <a:defRPr sz="1500">
-                <a:solidFill>
-                  <a:srgbClr val="F8FAFC"/>
-                </a:solidFill>
-                <a:latin typeface="Century Gothic"/>
+              <a:spcAft>
+                <a:spcPts val="1800"/>
+              </a:spcAft>
+              <a:defRPr sz="2000" b="1">
+                <a:solidFill>
+                  <a:srgbClr val="FFFFFF"/>
+                </a:solidFill>
+                <a:latin typeface="Segoe UI"/>
               </a:defRPr>
             </a:pPr>
             <a:r>
-              <a:t>RaastaSense is an interactive command center designed to bridge citizen watch complaints, legal safety indexation, dynamic road telemetry, and active emergency beacons into a single, high-fidelity real-time portal.</a:t>
-            </a:r>
-          </a:p>
-        </p:txBody>
-      </p:sp>
-      <p:sp>
-        <p:nvSpPr>
-          <p:cNvPr id="6" name="Rounded Rectangle 5"/>
-          <p:cNvSpPr/>
-          <p:nvPr/>
-        </p:nvSpPr>
-        <p:spPr>
-          <a:xfrm>
-            <a:off x="685800" y="3291840"/>
-            <a:ext cx="3364992" cy="2651760"/>
-          </a:xfrm>
-          <a:prstGeom prst="roundRect">
-            <a:avLst/>
-          </a:prstGeom>
-          <a:solidFill>
-            <a:srgbClr val="1E293B"/>
-          </a:solidFill>
-          <a:ln w="19050">
-            <a:solidFill>
-              <a:srgbClr val="38BDF8"/>
-            </a:solidFill>
-          </a:ln>
-        </p:spPr>
-        <p:style>
-          <a:lnRef idx="1">
-            <a:schemeClr val="accent1"/>
-          </a:lnRef>
-          <a:fillRef idx="3">
-            <a:schemeClr val="accent1"/>
-          </a:fillRef>
-          <a:effectRef idx="2">
-            <a:schemeClr val="accent1"/>
-          </a:effectRef>
-          <a:fontRef idx="minor">
-            <a:schemeClr val="lt1"/>
-          </a:fontRef>
-        </p:style>
-        <p:txBody>
-          <a:bodyPr rtlCol="0" anchor="ctr"/>
-          <a:lstStyle/>
-          <a:p>
-            <a:pPr algn="ctr"/>
-          </a:p>
-        </p:txBody>
-      </p:sp>
-      <p:sp>
-        <p:nvSpPr>
-          <p:cNvPr id="7" name="TextBox 6"/>
-          <p:cNvSpPr txBox="1"/>
-          <p:nvPr/>
-        </p:nvSpPr>
-        <p:spPr>
-          <a:xfrm>
-            <a:off x="868680" y="3474720"/>
-            <a:ext cx="2999232" cy="2286000"/>
-          </a:xfrm>
-          <a:prstGeom prst="rect">
-            <a:avLst/>
-          </a:prstGeom>
-          <a:noFill/>
-        </p:spPr>
-        <p:txBody>
-          <a:bodyPr wrap="square">
-            <a:spAutoFit/>
-          </a:bodyPr>
-          <a:lstStyle/>
+              <a:t>📊 Live Observability &amp; Telemetry Console</a:t>
+            </a:r>
+          </a:p>
           <a:p>
             <a:pPr>
-              <a:spcAft>
-                <a:spcPts val="1200"/>
-              </a:spcAft>
-              <a:defRPr sz="1500" b="1">
-                <a:solidFill>
-                  <a:srgbClr val="38BDF8"/>
-                </a:solidFill>
-                <a:latin typeface="Century Gothic"/>
+              <a:defRPr sz="1300">
+                <a:solidFill>
+                  <a:srgbClr val="94A3B8"/>
+                </a:solidFill>
+                <a:latin typeface="Segoe UI"/>
               </a:defRPr>
             </a:pPr>
             <a:r>
-              <a:t>GIS LIVE MAPPING</a:t>
-            </a:r>
-          </a:p>
-          <a:p>
-            <a:pPr>
-              <a:spcBef>
-                <a:spcPts val="400"/>
-              </a:spcBef>
-              <a:defRPr sz="1200">
-                <a:solidFill>
-                  <a:srgbClr val="F8FAFC"/>
-                </a:solidFill>
-                <a:latin typeface="Century Gothic"/>
-              </a:defRPr>
-            </a:pPr>
-            <a:r>
-              <a:t>Visualizes real-time route congestion with animated traffic flows (Red, Orange, Green polylines) and pulsing tactical incident flags.</a:t>
-            </a:r>
-          </a:p>
-        </p:txBody>
-      </p:sp>
-      <p:sp>
-        <p:nvSpPr>
-          <p:cNvPr id="8" name="Rounded Rectangle 7"/>
-          <p:cNvSpPr/>
-          <p:nvPr/>
-        </p:nvSpPr>
-        <p:spPr>
-          <a:xfrm>
-            <a:off x="4416552" y="3291840"/>
-            <a:ext cx="3364992" cy="2651760"/>
-          </a:xfrm>
-          <a:prstGeom prst="roundRect">
-            <a:avLst/>
-          </a:prstGeom>
-          <a:solidFill>
-            <a:srgbClr val="1E293B"/>
-          </a:solidFill>
-          <a:ln w="19050">
-            <a:solidFill>
-              <a:srgbClr val="F59E0B"/>
-            </a:solidFill>
-          </a:ln>
-        </p:spPr>
-        <p:style>
-          <a:lnRef idx="1">
-            <a:schemeClr val="accent1"/>
-          </a:lnRef>
-          <a:fillRef idx="3">
-            <a:schemeClr val="accent1"/>
-          </a:fillRef>
-          <a:effectRef idx="2">
-            <a:schemeClr val="accent1"/>
-          </a:effectRef>
-          <a:fontRef idx="minor">
-            <a:schemeClr val="lt1"/>
-          </a:fontRef>
-        </p:style>
-        <p:txBody>
-          <a:bodyPr rtlCol="0" anchor="ctr"/>
-          <a:lstStyle/>
-          <a:p>
-            <a:pPr algn="ctr"/>
-          </a:p>
-        </p:txBody>
-      </p:sp>
-      <p:sp>
-        <p:nvSpPr>
-          <p:cNvPr id="9" name="TextBox 8"/>
-          <p:cNvSpPr txBox="1"/>
-          <p:nvPr/>
-        </p:nvSpPr>
-        <p:spPr>
-          <a:xfrm>
-            <a:off x="4599432" y="3474720"/>
-            <a:ext cx="2999232" cy="2286000"/>
-          </a:xfrm>
-          <a:prstGeom prst="rect">
-            <a:avLst/>
-          </a:prstGeom>
-          <a:noFill/>
-        </p:spPr>
-        <p:txBody>
-          <a:bodyPr wrap="square">
-            <a:spAutoFit/>
-          </a:bodyPr>
-          <a:lstStyle/>
-          <a:p>
-            <a:pPr>
-              <a:spcAft>
-                <a:spcPts val="1200"/>
-              </a:spcAft>
-              <a:defRPr sz="1500" b="1">
-                <a:solidFill>
-                  <a:srgbClr val="F59E0B"/>
-                </a:solidFill>
-                <a:latin typeface="Century Gothic"/>
-              </a:defRPr>
-            </a:pPr>
-            <a:r>
-              <a:t>TRANSPARENCY AUDIT</a:t>
-            </a:r>
-          </a:p>
-          <a:p>
-            <a:pPr>
-              <a:spcBef>
-                <a:spcPts val="400"/>
-              </a:spcBef>
-              <a:defRPr sz="1200">
-                <a:solidFill>
-                  <a:srgbClr val="F8FAFC"/>
-                </a:solidFill>
-                <a:latin typeface="Century Gothic"/>
-              </a:defRPr>
-            </a:pPr>
-            <a:r>
-              <a:t>Fuses citizen watch logs with local authority works, displaying allocated budget utilization and maintenance history steppers.</a:t>
-            </a:r>
-          </a:p>
-        </p:txBody>
-      </p:sp>
-      <p:sp>
-        <p:nvSpPr>
-          <p:cNvPr id="10" name="Rounded Rectangle 9"/>
-          <p:cNvSpPr/>
-          <p:nvPr/>
-        </p:nvSpPr>
-        <p:spPr>
-          <a:xfrm>
-            <a:off x="8147304" y="3291840"/>
-            <a:ext cx="3364992" cy="2651760"/>
-          </a:xfrm>
-          <a:prstGeom prst="roundRect">
-            <a:avLst/>
-          </a:prstGeom>
-          <a:solidFill>
-            <a:srgbClr val="1E293B"/>
-          </a:solidFill>
-          <a:ln w="19050">
-            <a:solidFill>
-              <a:srgbClr val="F43F5E"/>
-            </a:solidFill>
-          </a:ln>
-        </p:spPr>
-        <p:style>
-          <a:lnRef idx="1">
-            <a:schemeClr val="accent1"/>
-          </a:lnRef>
-          <a:fillRef idx="3">
-            <a:schemeClr val="accent1"/>
-          </a:fillRef>
-          <a:effectRef idx="2">
-            <a:schemeClr val="accent1"/>
-          </a:effectRef>
-          <a:fontRef idx="minor">
-            <a:schemeClr val="lt1"/>
-          </a:fontRef>
-        </p:style>
-        <p:txBody>
-          <a:bodyPr rtlCol="0" anchor="ctr"/>
-          <a:lstStyle/>
-          <a:p>
-            <a:pPr algn="ctr"/>
-          </a:p>
-        </p:txBody>
-      </p:sp>
-      <p:sp>
-        <p:nvSpPr>
-          <p:cNvPr id="11" name="TextBox 10"/>
-          <p:cNvSpPr txBox="1"/>
-          <p:nvPr/>
-        </p:nvSpPr>
-        <p:spPr>
-          <a:xfrm>
-            <a:off x="8330184" y="3474720"/>
-            <a:ext cx="2999232" cy="2286000"/>
-          </a:xfrm>
-          <a:prstGeom prst="rect">
-            <a:avLst/>
-          </a:prstGeom>
-          <a:noFill/>
-        </p:spPr>
-        <p:txBody>
-          <a:bodyPr wrap="square">
-            <a:spAutoFit/>
-          </a:bodyPr>
-          <a:lstStyle/>
-          <a:p>
-            <a:pPr>
-              <a:spcAft>
-                <a:spcPts val="1200"/>
-              </a:spcAft>
-              <a:defRPr sz="1500" b="1">
-                <a:solidFill>
-                  <a:srgbClr val="F43F5E"/>
-                </a:solidFill>
-                <a:latin typeface="Century Gothic"/>
-              </a:defRPr>
-            </a:pPr>
-            <a:r>
-              <a:t>GOLDEN HOUR BEACON</a:t>
-            </a:r>
-          </a:p>
-          <a:p>
-            <a:pPr>
-              <a:spcBef>
-                <a:spcPts val="400"/>
-              </a:spcBef>
-              <a:defRPr sz="1200">
-                <a:solidFill>
-                  <a:srgbClr val="F8FAFC"/>
-                </a:solidFill>
-                <a:latin typeface="Century Gothic"/>
-              </a:defRPr>
-            </a:pPr>
-            <a:r>
-              <a:t>Enforces instantaneous disaster dispatching, geolocation locking, pre-routed corridors, and active countdown timers.</a:t>
-            </a:r>
-          </a:p>
-        </p:txBody>
-      </p:sp>
-    </p:spTree>
-  </p:cSld>
-  <p:clrMapOvr>
-    <a:masterClrMapping/>
-  </p:clrMapOvr>
-</p:sld>
-</file>
-
-<file path=ppt/slides/slide4.xml><?xml version="1.0" encoding="utf-8"?>
-<p:sld xmlns:a="http://schemas.openxmlformats.org/drawingml/2006/main" xmlns:p="http://schemas.openxmlformats.org/presentationml/2006/main" xmlns:r="http://schemas.openxmlformats.org/officeDocument/2006/relationships">
-  <p:cSld>
-    <p:bg>
-      <p:bgPr>
-        <a:solidFill>
-          <a:srgbClr val="0F172A"/>
-        </a:solidFill>
-        <a:effectLst/>
-      </p:bgPr>
-    </p:bg>
-    <p:spTree>
-      <p:nvGrpSpPr>
-        <p:cNvPr id="1" name=""/>
-        <p:cNvGrpSpPr/>
-        <p:nvPr/>
-      </p:nvGrpSpPr>
-      <p:grpSpPr/>
-      <p:sp>
-        <p:nvSpPr>
-          <p:cNvPr id="2" name="TextBox 1"/>
-          <p:cNvSpPr txBox="1"/>
-          <p:nvPr/>
-        </p:nvSpPr>
-        <p:spPr>
-          <a:xfrm>
-            <a:off x="685800" y="365760"/>
-            <a:ext cx="9144000" cy="365760"/>
-          </a:xfrm>
-          <a:prstGeom prst="rect">
-            <a:avLst/>
-          </a:prstGeom>
-          <a:noFill/>
-        </p:spPr>
-        <p:txBody>
-          <a:bodyPr wrap="square" lIns="0">
-            <a:spAutoFit/>
-          </a:bodyPr>
-          <a:lstStyle/>
-          <a:p>
-            <a:pPr>
-              <a:defRPr sz="1000" b="1">
-                <a:solidFill>
-                  <a:srgbClr val="38BDF8"/>
-                </a:solidFill>
-                <a:latin typeface="Century Gothic"/>
-              </a:defRPr>
-            </a:pPr>
-            <a:r>
-              <a:t>CORE FUNCTIONALITY</a:t>
-            </a:r>
-          </a:p>
-        </p:txBody>
-      </p:sp>
-      <p:sp>
-        <p:nvSpPr>
-          <p:cNvPr id="3" name="TextBox 2"/>
-          <p:cNvSpPr txBox="1"/>
-          <p:nvPr/>
-        </p:nvSpPr>
-        <p:spPr>
-          <a:xfrm>
-            <a:off x="685800" y="594360"/>
-            <a:ext cx="10817352" cy="731520"/>
-          </a:xfrm>
-          <a:prstGeom prst="rect">
-            <a:avLst/>
-          </a:prstGeom>
-          <a:noFill/>
-        </p:spPr>
-        <p:txBody>
-          <a:bodyPr wrap="square" lIns="0">
-            <a:spAutoFit/>
-          </a:bodyPr>
-          <a:lstStyle/>
-          <a:p>
-            <a:pPr>
-              <a:defRPr sz="3200" b="1">
-                <a:solidFill>
-                  <a:srgbClr val="F8FAFC"/>
-                </a:solidFill>
-                <a:latin typeface="Century Gothic"/>
-              </a:defRPr>
-            </a:pPr>
-            <a:r>
-              <a:t>Four Engine Command Core Components</a:t>
-            </a:r>
-          </a:p>
-        </p:txBody>
-      </p:sp>
-      <p:sp>
-        <p:nvSpPr>
-          <p:cNvPr id="4" name="Rounded Rectangle 3"/>
-          <p:cNvSpPr/>
-          <p:nvPr/>
-        </p:nvSpPr>
-        <p:spPr>
-          <a:xfrm>
-            <a:off x="685800" y="1645920"/>
-            <a:ext cx="5120640" cy="1920240"/>
-          </a:xfrm>
-          <a:prstGeom prst="roundRect">
-            <a:avLst/>
-          </a:prstGeom>
-          <a:solidFill>
-            <a:srgbClr val="1E293B"/>
-          </a:solidFill>
-          <a:ln w="19050">
-            <a:solidFill>
-              <a:srgbClr val="38BDF8"/>
-            </a:solidFill>
-          </a:ln>
-        </p:spPr>
-        <p:style>
-          <a:lnRef idx="1">
-            <a:schemeClr val="accent1"/>
-          </a:lnRef>
-          <a:fillRef idx="3">
-            <a:schemeClr val="accent1"/>
-          </a:fillRef>
-          <a:effectRef idx="2">
-            <a:schemeClr val="accent1"/>
-          </a:effectRef>
-          <a:fontRef idx="minor">
-            <a:schemeClr val="lt1"/>
-          </a:fontRef>
-        </p:style>
-        <p:txBody>
-          <a:bodyPr rtlCol="0" anchor="ctr"/>
-          <a:lstStyle/>
-          <a:p>
-            <a:pPr algn="ctr"/>
-          </a:p>
-        </p:txBody>
-      </p:sp>
-      <p:sp>
-        <p:nvSpPr>
-          <p:cNvPr id="5" name="TextBox 4"/>
-          <p:cNvSpPr txBox="1"/>
-          <p:nvPr/>
-        </p:nvSpPr>
-        <p:spPr>
-          <a:xfrm>
-            <a:off x="868680" y="1828800"/>
-            <a:ext cx="4754880" cy="1554480"/>
-          </a:xfrm>
-          <a:prstGeom prst="rect">
-            <a:avLst/>
-          </a:prstGeom>
-          <a:noFill/>
-        </p:spPr>
-        <p:txBody>
-          <a:bodyPr wrap="square">
-            <a:spAutoFit/>
-          </a:bodyPr>
-          <a:lstStyle/>
-          <a:p>
-            <a:pPr>
-              <a:spcAft>
-                <a:spcPts val="800"/>
-              </a:spcAft>
-              <a:defRPr sz="1500" b="1">
-                <a:solidFill>
-                  <a:srgbClr val="38BDF8"/>
-                </a:solidFill>
-                <a:latin typeface="Century Gothic"/>
-              </a:defRPr>
-            </a:pPr>
-            <a:r>
-              <a:t>■  SAFE ROUTE ENGINE</a:t>
-            </a:r>
-          </a:p>
-          <a:p>
-            <a:pPr>
-              <a:spcBef>
-                <a:spcPts val="400"/>
-              </a:spcBef>
-              <a:defRPr sz="1150">
-                <a:solidFill>
-                  <a:srgbClr val="F8FAFC"/>
-                </a:solidFill>
-                <a:latin typeface="Century Gothic"/>
-              </a:defRPr>
-            </a:pPr>
-            <a:r>
-              <a:t>Computes the Fastest, Safest, and Least Incident routes. Fully integrated with live safety index statistics and real-time mapping polylines.</a:t>
-            </a:r>
-          </a:p>
-        </p:txBody>
-      </p:sp>
-      <p:sp>
-        <p:nvSpPr>
-          <p:cNvPr id="6" name="Rounded Rectangle 5"/>
-          <p:cNvSpPr/>
-          <p:nvPr/>
-        </p:nvSpPr>
-        <p:spPr>
-          <a:xfrm>
-            <a:off x="6382512" y="1645920"/>
-            <a:ext cx="5120640" cy="1920240"/>
-          </a:xfrm>
-          <a:prstGeom prst="roundRect">
-            <a:avLst/>
-          </a:prstGeom>
-          <a:solidFill>
-            <a:srgbClr val="1E293B"/>
-          </a:solidFill>
-          <a:ln w="19050">
-            <a:solidFill>
-              <a:srgbClr val="F59E0B"/>
-            </a:solidFill>
-          </a:ln>
-        </p:spPr>
-        <p:style>
-          <a:lnRef idx="1">
-            <a:schemeClr val="accent1"/>
-          </a:lnRef>
-          <a:fillRef idx="3">
-            <a:schemeClr val="accent1"/>
-          </a:fillRef>
-          <a:effectRef idx="2">
-            <a:schemeClr val="accent1"/>
-          </a:effectRef>
-          <a:fontRef idx="minor">
-            <a:schemeClr val="lt1"/>
-          </a:fontRef>
-        </p:style>
-        <p:txBody>
-          <a:bodyPr rtlCol="0" anchor="ctr"/>
-          <a:lstStyle/>
-          <a:p>
-            <a:pPr algn="ctr"/>
-          </a:p>
-        </p:txBody>
-      </p:sp>
-      <p:sp>
-        <p:nvSpPr>
-          <p:cNvPr id="7" name="TextBox 6"/>
-          <p:cNvSpPr txBox="1"/>
-          <p:nvPr/>
-        </p:nvSpPr>
-        <p:spPr>
-          <a:xfrm>
-            <a:off x="6565392" y="1828800"/>
-            <a:ext cx="4754880" cy="1554480"/>
-          </a:xfrm>
-          <a:prstGeom prst="rect">
-            <a:avLst/>
-          </a:prstGeom>
-          <a:noFill/>
-        </p:spPr>
-        <p:txBody>
-          <a:bodyPr wrap="square">
-            <a:spAutoFit/>
-          </a:bodyPr>
-          <a:lstStyle/>
-          <a:p>
-            <a:pPr>
-              <a:spcAft>
-                <a:spcPts val="800"/>
-              </a:spcAft>
-              <a:defRPr sz="1500" b="1">
-                <a:solidFill>
-                  <a:srgbClr val="F59E0B"/>
-                </a:solidFill>
-                <a:latin typeface="Century Gothic"/>
-              </a:defRPr>
-            </a:pPr>
-            <a:r>
-              <a:t>■  DRIVELEGAL INDEX</a:t>
-            </a:r>
-          </a:p>
-          <a:p>
-            <a:pPr>
-              <a:spcBef>
-                <a:spcPts val="400"/>
-              </a:spcBef>
-              <a:defRPr sz="1150">
-                <a:solidFill>
-                  <a:srgbClr val="F8FAFC"/>
-                </a:solidFill>
-                <a:latin typeface="Century Gothic"/>
-              </a:defRPr>
-            </a:pPr>
-            <a:r>
-              <a:t>Contextualized traffic rules index with regional selectors for Karnataka, TN, and Maharashtra. Dynamically recalibrates penalty surcharges.</a:t>
-            </a:r>
-          </a:p>
-        </p:txBody>
-      </p:sp>
-      <p:sp>
-        <p:nvSpPr>
-          <p:cNvPr id="8" name="Rounded Rectangle 7"/>
-          <p:cNvSpPr/>
-          <p:nvPr/>
-        </p:nvSpPr>
-        <p:spPr>
-          <a:xfrm>
-            <a:off x="685800" y="3931920"/>
-            <a:ext cx="5120640" cy="1920240"/>
-          </a:xfrm>
-          <a:prstGeom prst="roundRect">
-            <a:avLst/>
-          </a:prstGeom>
-          <a:solidFill>
-            <a:srgbClr val="1E293B"/>
-          </a:solidFill>
-          <a:ln w="19050">
-            <a:solidFill>
-              <a:srgbClr val="F59E0B"/>
-            </a:solidFill>
-          </a:ln>
-        </p:spPr>
-        <p:style>
-          <a:lnRef idx="1">
-            <a:schemeClr val="accent1"/>
-          </a:lnRef>
-          <a:fillRef idx="3">
-            <a:schemeClr val="accent1"/>
-          </a:fillRef>
-          <a:effectRef idx="2">
-            <a:schemeClr val="accent1"/>
-          </a:effectRef>
-          <a:fontRef idx="minor">
-            <a:schemeClr val="lt1"/>
-          </a:fontRef>
-        </p:style>
-        <p:txBody>
-          <a:bodyPr rtlCol="0" anchor="ctr"/>
-          <a:lstStyle/>
-          <a:p>
-            <a:pPr algn="ctr"/>
-          </a:p>
-        </p:txBody>
-      </p:sp>
-      <p:sp>
-        <p:nvSpPr>
-          <p:cNvPr id="9" name="TextBox 8"/>
-          <p:cNvSpPr txBox="1"/>
-          <p:nvPr/>
-        </p:nvSpPr>
-        <p:spPr>
-          <a:xfrm>
-            <a:off x="868680" y="4114800"/>
-            <a:ext cx="4754880" cy="1554480"/>
-          </a:xfrm>
-          <a:prstGeom prst="rect">
-            <a:avLst/>
-          </a:prstGeom>
-          <a:noFill/>
-        </p:spPr>
-        <p:txBody>
-          <a:bodyPr wrap="square">
-            <a:spAutoFit/>
-          </a:bodyPr>
-          <a:lstStyle/>
-          <a:p>
-            <a:pPr>
-              <a:spcAft>
-                <a:spcPts val="800"/>
-              </a:spcAft>
-              <a:defRPr sz="1500" b="1">
-                <a:solidFill>
-                  <a:srgbClr val="F59E0B"/>
-                </a:solidFill>
-                <a:latin typeface="Century Gothic"/>
-              </a:defRPr>
-            </a:pPr>
-            <a:r>
-              <a:t>■  ROADWATCH TRANSPARENCY</a:t>
-            </a:r>
-          </a:p>
-          <a:p>
-            <a:pPr>
-              <a:spcBef>
-                <a:spcPts val="400"/>
-              </a:spcBef>
-              <a:defRPr sz="1150">
-                <a:solidFill>
-                  <a:srgbClr val="F8FAFC"/>
-                </a:solidFill>
-                <a:latin typeface="Century Gothic"/>
-              </a:defRPr>
-            </a:pPr>
-            <a:r>
-              <a:t>Accountability deck displaying citizen complaints, repair milestones, allocated vs spent budget meters, and historical audit logs.</a:t>
-            </a:r>
-          </a:p>
-        </p:txBody>
-      </p:sp>
-      <p:sp>
-        <p:nvSpPr>
-          <p:cNvPr id="10" name="Rounded Rectangle 9"/>
-          <p:cNvSpPr/>
-          <p:nvPr/>
-        </p:nvSpPr>
-        <p:spPr>
-          <a:xfrm>
-            <a:off x="6382512" y="3931920"/>
-            <a:ext cx="5120640" cy="1920240"/>
-          </a:xfrm>
-          <a:prstGeom prst="roundRect">
-            <a:avLst/>
-          </a:prstGeom>
-          <a:solidFill>
-            <a:srgbClr val="1E293B"/>
-          </a:solidFill>
-          <a:ln w="19050">
-            <a:solidFill>
-              <a:srgbClr val="F43F5E"/>
-            </a:solidFill>
-          </a:ln>
-        </p:spPr>
-        <p:style>
-          <a:lnRef idx="1">
-            <a:schemeClr val="accent1"/>
-          </a:lnRef>
-          <a:fillRef idx="3">
-            <a:schemeClr val="accent1"/>
-          </a:fillRef>
-          <a:effectRef idx="2">
-            <a:schemeClr val="accent1"/>
-          </a:effectRef>
-          <a:fontRef idx="minor">
-            <a:schemeClr val="lt1"/>
-          </a:fontRef>
-        </p:style>
-        <p:txBody>
-          <a:bodyPr rtlCol="0" anchor="ctr"/>
-          <a:lstStyle/>
-          <a:p>
-            <a:pPr algn="ctr"/>
-          </a:p>
-        </p:txBody>
-      </p:sp>
-      <p:sp>
-        <p:nvSpPr>
-          <p:cNvPr id="11" name="TextBox 10"/>
-          <p:cNvSpPr txBox="1"/>
-          <p:nvPr/>
-        </p:nvSpPr>
-        <p:spPr>
-          <a:xfrm>
-            <a:off x="6565392" y="4114800"/>
-            <a:ext cx="4754880" cy="1554480"/>
-          </a:xfrm>
-          <a:prstGeom prst="rect">
-            <a:avLst/>
-          </a:prstGeom>
-          <a:noFill/>
-        </p:spPr>
-        <p:txBody>
-          <a:bodyPr wrap="square">
-            <a:spAutoFit/>
-          </a:bodyPr>
-          <a:lstStyle/>
-          <a:p>
-            <a:pPr>
-              <a:spcAft>
-                <a:spcPts val="800"/>
-              </a:spcAft>
-              <a:defRPr sz="1500" b="1">
-                <a:solidFill>
-                  <a:srgbClr val="F43F5E"/>
-                </a:solidFill>
-                <a:latin typeface="Century Gothic"/>
-              </a:defRPr>
-            </a:pPr>
-            <a:r>
-              <a:t>■  ROADSOS BEACON</a:t>
-            </a:r>
-          </a:p>
-          <a:p>
-            <a:pPr>
-              <a:spcBef>
-                <a:spcPts val="400"/>
-              </a:spcBef>
-              <a:defRPr sz="1150">
-                <a:solidFill>
-                  <a:srgbClr val="F8FAFC"/>
-                </a:solidFill>
-                <a:latin typeface="Century Gothic"/>
-              </a:defRPr>
-            </a:pPr>
-            <a:r>
-              <a:t>60-minute descending countdown timer prioritizing dispatch survival. Integrates exact GPS telemetry coordination and center routing.</a:t>
-            </a:r>
-          </a:p>
-        </p:txBody>
-      </p:sp>
-    </p:spTree>
-  </p:cSld>
-  <p:clrMapOvr>
-    <a:masterClrMapping/>
-  </p:clrMapOvr>
-</p:sld>
-</file>
-
-<file path=ppt/slides/slide5.xml><?xml version="1.0" encoding="utf-8"?>
-<p:sld xmlns:a="http://schemas.openxmlformats.org/drawingml/2006/main" xmlns:p="http://schemas.openxmlformats.org/presentationml/2006/main" xmlns:r="http://schemas.openxmlformats.org/officeDocument/2006/relationships">
-  <p:cSld>
-    <p:bg>
-      <p:bgPr>
-        <a:solidFill>
-          <a:srgbClr val="0F172A"/>
-        </a:solidFill>
-        <a:effectLst/>
-      </p:bgPr>
-    </p:bg>
-    <p:spTree>
-      <p:nvGrpSpPr>
-        <p:cNvPr id="1" name=""/>
-        <p:cNvGrpSpPr/>
-        <p:nvPr/>
-      </p:nvGrpSpPr>
-      <p:grpSpPr/>
-      <p:sp>
-        <p:nvSpPr>
-          <p:cNvPr id="2" name="TextBox 1"/>
-          <p:cNvSpPr txBox="1"/>
-          <p:nvPr/>
-        </p:nvSpPr>
-        <p:spPr>
-          <a:xfrm>
-            <a:off x="685800" y="365760"/>
-            <a:ext cx="9144000" cy="365760"/>
-          </a:xfrm>
-          <a:prstGeom prst="rect">
-            <a:avLst/>
-          </a:prstGeom>
-          <a:noFill/>
-        </p:spPr>
-        <p:txBody>
-          <a:bodyPr wrap="square" lIns="0">
-            <a:spAutoFit/>
-          </a:bodyPr>
-          <a:lstStyle/>
-          <a:p>
-            <a:pPr>
-              <a:defRPr sz="1000" b="1">
-                <a:solidFill>
-                  <a:srgbClr val="38BDF8"/>
-                </a:solidFill>
-                <a:latin typeface="Century Gothic"/>
-              </a:defRPr>
-            </a:pPr>
-            <a:r>
-              <a:t>I18N &amp; TELEMETRY HUD</a:t>
-            </a:r>
-          </a:p>
-        </p:txBody>
-      </p:sp>
-      <p:sp>
-        <p:nvSpPr>
-          <p:cNvPr id="3" name="TextBox 2"/>
-          <p:cNvSpPr txBox="1"/>
-          <p:nvPr/>
-        </p:nvSpPr>
-        <p:spPr>
-          <a:xfrm>
-            <a:off x="685800" y="594360"/>
-            <a:ext cx="10817352" cy="731520"/>
-          </a:xfrm>
-          <a:prstGeom prst="rect">
-            <a:avLst/>
-          </a:prstGeom>
-          <a:noFill/>
-        </p:spPr>
-        <p:txBody>
-          <a:bodyPr wrap="square" lIns="0">
-            <a:spAutoFit/>
-          </a:bodyPr>
-          <a:lstStyle/>
-          <a:p>
-            <a:pPr>
-              <a:defRPr sz="3200" b="1">
-                <a:solidFill>
-                  <a:srgbClr val="F8FAFC"/>
-                </a:solidFill>
-                <a:latin typeface="Century Gothic"/>
-              </a:defRPr>
-            </a:pPr>
-            <a:r>
-              <a:t>Multilingual &amp; System Observability HUD</a:t>
-            </a:r>
-          </a:p>
-        </p:txBody>
-      </p:sp>
-      <p:sp>
-        <p:nvSpPr>
-          <p:cNvPr id="4" name="Rounded Rectangle 3"/>
-          <p:cNvSpPr/>
-          <p:nvPr/>
-        </p:nvSpPr>
-        <p:spPr>
-          <a:xfrm>
-            <a:off x="685800" y="1645920"/>
-            <a:ext cx="4754880" cy="4297680"/>
-          </a:xfrm>
-          <a:prstGeom prst="roundRect">
-            <a:avLst/>
-          </a:prstGeom>
-          <a:solidFill>
-            <a:srgbClr val="1E293B"/>
-          </a:solidFill>
-          <a:ln w="19050">
-            <a:solidFill>
-              <a:srgbClr val="38BDF8"/>
-            </a:solidFill>
-          </a:ln>
-        </p:spPr>
-        <p:style>
-          <a:lnRef idx="1">
-            <a:schemeClr val="accent1"/>
-          </a:lnRef>
-          <a:fillRef idx="3">
-            <a:schemeClr val="accent1"/>
-          </a:fillRef>
-          <a:effectRef idx="2">
-            <a:schemeClr val="accent1"/>
-          </a:effectRef>
-          <a:fontRef idx="minor">
-            <a:schemeClr val="lt1"/>
-          </a:fontRef>
-        </p:style>
-        <p:txBody>
-          <a:bodyPr rtlCol="0" anchor="ctr"/>
-          <a:lstStyle/>
-          <a:p>
-            <a:pPr algn="ctr"/>
-          </a:p>
-        </p:txBody>
-      </p:sp>
-      <p:sp>
-        <p:nvSpPr>
-          <p:cNvPr id="5" name="TextBox 4"/>
-          <p:cNvSpPr txBox="1"/>
-          <p:nvPr/>
-        </p:nvSpPr>
-        <p:spPr>
-          <a:xfrm>
-            <a:off x="914400" y="1920240"/>
-            <a:ext cx="4297680" cy="3749039"/>
-          </a:xfrm>
-          <a:prstGeom prst="rect">
-            <a:avLst/>
-          </a:prstGeom>
-          <a:noFill/>
-        </p:spPr>
-        <p:txBody>
-          <a:bodyPr wrap="square">
-            <a:spAutoFit/>
-          </a:bodyPr>
-          <a:lstStyle/>
-          <a:p>
-            <a:pPr>
-              <a:spcAft>
-                <a:spcPts val="2000"/>
-              </a:spcAft>
-              <a:defRPr sz="1600" b="1">
-                <a:solidFill>
-                  <a:srgbClr val="38BDF8"/>
-                </a:solidFill>
-                <a:latin typeface="Century Gothic"/>
-              </a:defRPr>
-            </a:pPr>
-            <a:r>
-              <a:t>9-LANGUAGE REGIONAL LOCALIZATION</a:t>
-            </a:r>
-          </a:p>
-          <a:p>
-            <a:pPr>
-              <a:spcBef>
-                <a:spcPts val="800"/>
-              </a:spcBef>
-              <a:defRPr sz="1300" b="1">
-                <a:solidFill>
-                  <a:srgbClr val="F59E0B"/>
-                </a:solidFill>
-                <a:latin typeface="Century Gothic"/>
-              </a:defRPr>
-            </a:pPr>
-            <a:r>
-              <a:t>9 Native Indian Languages</a:t>
-            </a:r>
-          </a:p>
-          <a:p>
-            <a:pPr>
-              <a:spcAft>
-                <a:spcPts val="1000"/>
-              </a:spcAft>
-              <a:defRPr sz="1100">
-                <a:solidFill>
-                  <a:srgbClr val="F8FAFC"/>
-                </a:solidFill>
-                <a:latin typeface="Century Gothic"/>
-              </a:defRPr>
-            </a:pPr>
-            <a:r>
-              <a:t>Complete i18n support mapping English, Hindi, Marathi, Tamil, Telugu, Kannada, Gujarati, Punjabi, and Bengali dynamically.</a:t>
-            </a:r>
-          </a:p>
-          <a:p>
-            <a:pPr>
-              <a:spcBef>
-                <a:spcPts val="800"/>
-              </a:spcBef>
-              <a:defRPr sz="1300" b="1">
-                <a:solidFill>
-                  <a:srgbClr val="F59E0B"/>
-                </a:solidFill>
-                <a:latin typeface="Century Gothic"/>
-              </a:defRPr>
-            </a:pPr>
-            <a:r>
-              <a:t>Glassmorphic Toggle Dropper</a:t>
-            </a:r>
-          </a:p>
-          <a:p>
-            <a:pPr>
-              <a:spcAft>
-                <a:spcPts val="1000"/>
-              </a:spcAft>
-              <a:defRPr sz="1100">
-                <a:solidFill>
-                  <a:srgbClr val="F8FAFC"/>
-                </a:solidFill>
-                <a:latin typeface="Century Gothic"/>
-              </a:defRPr>
-            </a:pPr>
-            <a:r>
-              <a:t>Immediate runtime translation of navigation, legal counselor metrics, fine indexes, and municipal watch tickets.</a:t>
-            </a:r>
-          </a:p>
-          <a:p>
-            <a:pPr>
-              <a:spcBef>
-                <a:spcPts val="800"/>
-              </a:spcBef>
-              <a:defRPr sz="1300" b="1">
-                <a:solidFill>
-                  <a:srgbClr val="F59E0B"/>
-                </a:solidFill>
-                <a:latin typeface="Century Gothic"/>
-              </a:defRPr>
-            </a:pPr>
-            <a:r>
-              <a:t>Zero-Latency Translation</a:t>
-            </a:r>
-          </a:p>
-          <a:p>
-            <a:pPr>
-              <a:spcAft>
-                <a:spcPts val="1000"/>
-              </a:spcAft>
-              <a:defRPr sz="1100">
-                <a:solidFill>
-                  <a:srgbClr val="F8FAFC"/>
-                </a:solidFill>
-                <a:latin typeface="Century Gothic"/>
-              </a:defRPr>
-            </a:pPr>
-            <a:r>
-              <a:t>Runs on standard React state and localized JSON dictionary assets with zero third-party API dependencies.</a:t>
-            </a:r>
-          </a:p>
-        </p:txBody>
-      </p:sp>
-      <p:sp>
-        <p:nvSpPr>
-          <p:cNvPr id="6" name="Rounded Rectangle 5"/>
-          <p:cNvSpPr/>
-          <p:nvPr/>
-        </p:nvSpPr>
-        <p:spPr>
-          <a:xfrm>
-            <a:off x="5833872" y="1645920"/>
-            <a:ext cx="5669280" cy="4297680"/>
-          </a:xfrm>
-          <a:prstGeom prst="roundRect">
-            <a:avLst/>
-          </a:prstGeom>
-          <a:solidFill>
-            <a:srgbClr val="1E293B"/>
-          </a:solidFill>
-          <a:ln w="19050">
-            <a:solidFill>
-              <a:srgbClr val="F59E0B"/>
-            </a:solidFill>
-          </a:ln>
-        </p:spPr>
-        <p:style>
-          <a:lnRef idx="1">
-            <a:schemeClr val="accent1"/>
-          </a:lnRef>
-          <a:fillRef idx="3">
-            <a:schemeClr val="accent1"/>
-          </a:fillRef>
-          <a:effectRef idx="2">
-            <a:schemeClr val="accent1"/>
-          </a:effectRef>
-          <a:fontRef idx="minor">
-            <a:schemeClr val="lt1"/>
-          </a:fontRef>
-        </p:style>
-        <p:txBody>
-          <a:bodyPr rtlCol="0" anchor="ctr"/>
-          <a:lstStyle/>
-          <a:p>
-            <a:pPr algn="ctr"/>
-          </a:p>
-        </p:txBody>
-      </p:sp>
-      <p:sp>
-        <p:nvSpPr>
-          <p:cNvPr id="7" name="TextBox 6"/>
-          <p:cNvSpPr txBox="1"/>
-          <p:nvPr/>
-        </p:nvSpPr>
-        <p:spPr>
-          <a:xfrm>
-            <a:off x="6108192" y="1920240"/>
-            <a:ext cx="5120640" cy="3749039"/>
-          </a:xfrm>
-          <a:prstGeom prst="rect">
-            <a:avLst/>
-          </a:prstGeom>
-          <a:noFill/>
-        </p:spPr>
-        <p:txBody>
-          <a:bodyPr wrap="square">
-            <a:spAutoFit/>
-          </a:bodyPr>
-          <a:lstStyle/>
-          <a:p>
-            <a:pPr>
-              <a:spcAft>
-                <a:spcPts val="1600"/>
-              </a:spcAft>
-              <a:defRPr sz="1600" b="1">
-                <a:solidFill>
-                  <a:srgbClr val="F59E0B"/>
-                </a:solidFill>
-                <a:latin typeface="Century Gothic"/>
-              </a:defRPr>
-            </a:pPr>
-            <a:r>
-              <a:t>ANALYTICS HUD &amp; CONFIG DIAGNOSTICS</a:t>
-            </a:r>
-          </a:p>
-          <a:p>
-            <a:pPr>
-              <a:spcBef>
-                <a:spcPts val="600"/>
-              </a:spcBef>
-              <a:defRPr sz="1300" b="1">
-                <a:solidFill>
-                  <a:srgbClr val="38BDF8"/>
-                </a:solidFill>
-                <a:latin typeface="Century Gothic"/>
-              </a:defRPr>
-            </a:pPr>
-            <a:r>
-              <a:t>■  Dynamic Inline SVG Charts</a:t>
-            </a:r>
-          </a:p>
-          <a:p>
-            <a:pPr>
-              <a:spcAft>
-                <a:spcPts val="600"/>
-              </a:spcAft>
-              <a:defRPr sz="1100">
-                <a:solidFill>
-                  <a:srgbClr val="F8FAFC"/>
-                </a:solidFill>
-                <a:latin typeface="Century Gothic"/>
-              </a:defRPr>
-            </a:pPr>
-            <a:r>
-              <a:t>Custom React SVG-rendered live line graphs mapping route congestion trends and vertical bar charts tracking resolution times.</a:t>
-            </a:r>
-          </a:p>
-          <a:p>
-            <a:pPr>
-              <a:spcBef>
-                <a:spcPts val="600"/>
-              </a:spcBef>
-              <a:defRPr sz="1300" b="1">
-                <a:solidFill>
-                  <a:srgbClr val="38BDF8"/>
-                </a:solidFill>
-                <a:latin typeface="Century Gothic"/>
-              </a:defRPr>
-            </a:pPr>
-            <a:r>
-              <a:t>■  Simulated Infrastructure Settings</a:t>
-            </a:r>
-          </a:p>
-          <a:p>
-            <a:pPr>
-              <a:spcAft>
-                <a:spcPts val="600"/>
-              </a:spcAft>
-              <a:defRPr sz="1100">
-                <a:solidFill>
-                  <a:srgbClr val="F8FAFC"/>
-                </a:solidFill>
-                <a:latin typeface="Century Gothic"/>
-              </a:defRPr>
-            </a:pPr>
-            <a:r>
-              <a:t>HUD checking NoSQL database connection status, active environment configurations, and Vercel aliased live links.</a:t>
-            </a:r>
-          </a:p>
-          <a:p>
-            <a:pPr>
-              <a:spcBef>
-                <a:spcPts val="600"/>
-              </a:spcBef>
-              <a:defRPr sz="1300" b="1">
-                <a:solidFill>
-                  <a:srgbClr val="38BDF8"/>
-                </a:solidFill>
-                <a:latin typeface="Century Gothic"/>
-              </a:defRPr>
-            </a:pPr>
-            <a:r>
-              <a:t>■  Live Telemetry Logging Console</a:t>
-            </a:r>
-          </a:p>
-          <a:p>
-            <a:pPr>
-              <a:spcAft>
-                <a:spcPts val="600"/>
-              </a:spcAft>
-              <a:defRPr sz="1100">
-                <a:solidFill>
-                  <a:srgbClr val="F8FAFC"/>
-                </a:solidFill>
-                <a:latin typeface="Century Gothic"/>
-              </a:defRPr>
-            </a:pPr>
-            <a:r>
-              <a:t>Active logs feed simulating continuous audit trails, Firestore client indicators, and Golden Hour loop checks.</a:t>
+              <a:t>• Live Console Telemetry Stream: Chronological NoSQL Firestore connectivity indicator and telemetry status outputs.</a:t>
+            </a:r>
+            <a:br/>
+            <a:br/>
+            <a:r>
+              <a:t>• Custom SVG Safety Charts: Real-time route congestion graph and repairs metrics tracker.</a:t>
+            </a:r>
+            <a:br/>
+            <a:br/>
+            <a:r>
+              <a:t>• 9-Language Localization Dropdown: Multi-lingual localizer supporting regional fine surcharges, legal codes, and AI advice swaps with zero-lag.</a:t>
             </a:r>
           </a:p>
         </p:txBody>
@@ -5215,8 +4346,8 @@
         </p:nvSpPr>
         <p:spPr>
           <a:xfrm>
-            <a:off x="685800" y="365760"/>
-            <a:ext cx="9144000" cy="365760"/>
+            <a:off x="731520" y="457200"/>
+            <a:ext cx="10698480" cy="731520"/>
           </a:xfrm>
           <a:prstGeom prst="rect">
             <a:avLst/>
@@ -5224,71 +4355,35 @@
           <a:noFill/>
         </p:spPr>
         <p:txBody>
-          <a:bodyPr wrap="square" lIns="0">
+          <a:bodyPr wrap="none">
             <a:spAutoFit/>
           </a:bodyPr>
           <a:lstStyle/>
           <a:p>
             <a:pPr>
-              <a:defRPr sz="1000" b="1">
+              <a:defRPr sz="2800" b="1">
                 <a:solidFill>
                   <a:srgbClr val="38BDF8"/>
                 </a:solidFill>
-                <a:latin typeface="Century Gothic"/>
+                <a:latin typeface="Segoe UI"/>
               </a:defRPr>
             </a:pPr>
             <a:r>
-              <a:t>SYSTEM MECHANICS</a:t>
-            </a:r>
-          </a:p>
-        </p:txBody>
-      </p:sp>
-      <p:sp>
-        <p:nvSpPr>
-          <p:cNvPr id="3" name="TextBox 2"/>
-          <p:cNvSpPr txBox="1"/>
+              <a:t>MEASURED SOCIETAL &amp; CIVIC IMPACT</a:t>
+            </a:r>
+          </a:p>
+        </p:txBody>
+      </p:sp>
+      <p:sp>
+        <p:nvSpPr>
+          <p:cNvPr id="3" name="Rounded Rectangle 2"/>
+          <p:cNvSpPr/>
           <p:nvPr/>
         </p:nvSpPr>
         <p:spPr>
           <a:xfrm>
-            <a:off x="685800" y="594360"/>
-            <a:ext cx="10817352" cy="731520"/>
-          </a:xfrm>
-          <a:prstGeom prst="rect">
-            <a:avLst/>
-          </a:prstGeom>
-          <a:noFill/>
-        </p:spPr>
-        <p:txBody>
-          <a:bodyPr wrap="square" lIns="0">
-            <a:spAutoFit/>
-          </a:bodyPr>
-          <a:lstStyle/>
-          <a:p>
-            <a:pPr>
-              <a:defRPr sz="3200" b="1">
-                <a:solidFill>
-                  <a:srgbClr val="F8FAFC"/>
-                </a:solidFill>
-                <a:latin typeface="Century Gothic"/>
-              </a:defRPr>
-            </a:pPr>
-            <a:r>
-              <a:t>Ecosystem Technical Architecture</a:t>
-            </a:r>
-          </a:p>
-        </p:txBody>
-      </p:sp>
-      <p:sp>
-        <p:nvSpPr>
-          <p:cNvPr id="4" name="Rounded Rectangle 3"/>
-          <p:cNvSpPr/>
-          <p:nvPr/>
-        </p:nvSpPr>
-        <p:spPr>
-          <a:xfrm>
-            <a:off x="685800" y="1645920"/>
-            <a:ext cx="4754880" cy="4297680"/>
+            <a:off x="731520" y="1645920"/>
+            <a:ext cx="3291840" cy="4114800"/>
           </a:xfrm>
           <a:prstGeom prst="roundRect">
             <a:avLst/>
@@ -5296,7 +4391,7 @@
           <a:solidFill>
             <a:srgbClr val="1E293B"/>
           </a:solidFill>
-          <a:ln w="19050">
+          <a:ln>
             <a:solidFill>
               <a:srgbClr val="38BDF8"/>
             </a:solidFill>
@@ -5317,158 +4412,49 @@
           </a:fontRef>
         </p:style>
         <p:txBody>
-          <a:bodyPr rtlCol="0" anchor="ctr"/>
-          <a:lstStyle/>
-          <a:p>
-            <a:pPr algn="ctr"/>
-          </a:p>
-        </p:txBody>
-      </p:sp>
-      <p:sp>
-        <p:nvSpPr>
-          <p:cNvPr id="5" name="TextBox 4"/>
-          <p:cNvSpPr txBox="1"/>
+          <a:bodyPr rtlCol="0" anchor="ctr" wrap="square" tIns="274320"/>
+          <a:lstStyle/>
+          <a:p>
+            <a:pPr algn="ctr">
+              <a:spcAft>
+                <a:spcPts val="1400"/>
+              </a:spcAft>
+              <a:defRPr sz="1800" b="1">
+                <a:solidFill>
+                  <a:srgbClr val="FFFFFF"/>
+                </a:solidFill>
+                <a:latin typeface="Segoe UI"/>
+              </a:defRPr>
+            </a:pPr>
+            <a:r>
+              <a:t>🚲 Citizens</a:t>
+            </a:r>
+          </a:p>
+          <a:p>
+            <a:pPr>
+              <a:defRPr sz="1300">
+                <a:solidFill>
+                  <a:srgbClr val="94A3B8"/>
+                </a:solidFill>
+                <a:latin typeface="Segoe UI"/>
+              </a:defRPr>
+            </a:pPr>
+            <a:r>
+              <a:t>Safe routing guidelines keep travelers out of congestion/danger zones. Regional DriveLegal counselor builds critical legal self-awareness.</a:t>
+            </a:r>
+          </a:p>
+        </p:txBody>
+      </p:sp>
+      <p:sp>
+        <p:nvSpPr>
+          <p:cNvPr id="4" name="Rounded Rectangle 3"/>
+          <p:cNvSpPr/>
           <p:nvPr/>
         </p:nvSpPr>
         <p:spPr>
           <a:xfrm>
-            <a:off x="914400" y="1920240"/>
-            <a:ext cx="4297680" cy="3749039"/>
-          </a:xfrm>
-          <a:prstGeom prst="rect">
-            <a:avLst/>
-          </a:prstGeom>
-          <a:noFill/>
-        </p:spPr>
-        <p:txBody>
-          <a:bodyPr wrap="square">
-            <a:spAutoFit/>
-          </a:bodyPr>
-          <a:lstStyle/>
-          <a:p>
-            <a:pPr>
-              <a:spcAft>
-                <a:spcPts val="2000"/>
-              </a:spcAft>
-              <a:defRPr sz="1600" b="1">
-                <a:solidFill>
-                  <a:srgbClr val="38BDF8"/>
-                </a:solidFill>
-                <a:latin typeface="Century Gothic"/>
-              </a:defRPr>
-            </a:pPr>
-            <a:r>
-              <a:t>INTELLIGENT SYSTEM PIPELINE</a:t>
-            </a:r>
-          </a:p>
-          <a:p>
-            <a:pPr>
-              <a:spcBef>
-                <a:spcPts val="800"/>
-              </a:spcBef>
-              <a:defRPr sz="1300" b="1">
-                <a:solidFill>
-                  <a:srgbClr val="F59E0B"/>
-                </a:solidFill>
-                <a:latin typeface="Century Gothic"/>
-              </a:defRPr>
-            </a:pPr>
-            <a:r>
-              <a:t>1. Data Telemetry Intake</a:t>
-            </a:r>
-          </a:p>
-          <a:p>
-            <a:pPr>
-              <a:spcAft>
-                <a:spcPts val="1000"/>
-              </a:spcAft>
-              <a:defRPr sz="1100">
-                <a:solidFill>
-                  <a:srgbClr val="F8FAFC"/>
-                </a:solidFill>
-                <a:latin typeface="Century Gothic"/>
-              </a:defRPr>
-            </a:pPr>
-            <a:r>
-              <a:t>Simulates continuous GPS coordinate updates, weather conditions, and spatial traffic flow variables.</a:t>
-            </a:r>
-          </a:p>
-          <a:p>
-            <a:pPr>
-              <a:spcBef>
-                <a:spcPts val="800"/>
-              </a:spcBef>
-              <a:defRPr sz="1300" b="1">
-                <a:solidFill>
-                  <a:srgbClr val="F59E0B"/>
-                </a:solidFill>
-                <a:latin typeface="Century Gothic"/>
-              </a:defRPr>
-            </a:pPr>
-            <a:r>
-              <a:t>2. Rule &amp; Safety Engine</a:t>
-            </a:r>
-          </a:p>
-          <a:p>
-            <a:pPr>
-              <a:spcAft>
-                <a:spcPts val="1000"/>
-              </a:spcAft>
-              <a:defRPr sz="1100">
-                <a:solidFill>
-                  <a:srgbClr val="F8FAFC"/>
-                </a:solidFill>
-                <a:latin typeface="Century Gothic"/>
-              </a:defRPr>
-            </a:pPr>
-            <a:r>
-              <a:t>Evaluates road risk factors, checks state-level surcharges, and updates structural transparency data.</a:t>
-            </a:r>
-          </a:p>
-          <a:p>
-            <a:pPr>
-              <a:spcBef>
-                <a:spcPts val="800"/>
-              </a:spcBef>
-              <a:defRPr sz="1300" b="1">
-                <a:solidFill>
-                  <a:srgbClr val="F59E0B"/>
-                </a:solidFill>
-                <a:latin typeface="Century Gothic"/>
-              </a:defRPr>
-            </a:pPr>
-            <a:r>
-              <a:t>3. GIS Dispatch Layer</a:t>
-            </a:r>
-          </a:p>
-          <a:p>
-            <a:pPr>
-              <a:spcAft>
-                <a:spcPts val="1000"/>
-              </a:spcAft>
-              <a:defRPr sz="1100">
-                <a:solidFill>
-                  <a:srgbClr val="F8FAFC"/>
-                </a:solidFill>
-                <a:latin typeface="Century Gothic"/>
-              </a:defRPr>
-            </a:pPr>
-            <a:r>
-              <a:t>Resolves Leaflet routing layers and triggers coordinate-locked emergency beacons instantly.</a:t>
-            </a:r>
-          </a:p>
-        </p:txBody>
-      </p:sp>
-      <p:sp>
-        <p:nvSpPr>
-          <p:cNvPr id="6" name="Rounded Rectangle 5"/>
-          <p:cNvSpPr/>
-          <p:nvPr/>
-        </p:nvSpPr>
-        <p:spPr>
-          <a:xfrm>
-            <a:off x="5833872" y="1645920"/>
-            <a:ext cx="5669280" cy="4297680"/>
+            <a:off x="4389120" y="1645920"/>
+            <a:ext cx="3291840" cy="4114800"/>
           </a:xfrm>
           <a:prstGeom prst="roundRect">
             <a:avLst/>
@@ -5476,7 +4462,7 @@
           <a:solidFill>
             <a:srgbClr val="1E293B"/>
           </a:solidFill>
-          <a:ln w="19050">
+          <a:ln>
             <a:solidFill>
               <a:srgbClr val="F59E0B"/>
             </a:solidFill>
@@ -5497,176 +4483,106 @@
           </a:fontRef>
         </p:style>
         <p:txBody>
-          <a:bodyPr rtlCol="0" anchor="ctr"/>
-          <a:lstStyle/>
-          <a:p>
-            <a:pPr algn="ctr"/>
-          </a:p>
-        </p:txBody>
-      </p:sp>
-      <p:sp>
-        <p:nvSpPr>
-          <p:cNvPr id="7" name="TextBox 6"/>
-          <p:cNvSpPr txBox="1"/>
+          <a:bodyPr rtlCol="0" anchor="ctr" wrap="square" tIns="274320"/>
+          <a:lstStyle/>
+          <a:p>
+            <a:pPr algn="ctr">
+              <a:spcAft>
+                <a:spcPts val="1400"/>
+              </a:spcAft>
+              <a:defRPr sz="1800" b="1">
+                <a:solidFill>
+                  <a:srgbClr val="FFFFFF"/>
+                </a:solidFill>
+                <a:latin typeface="Segoe UI"/>
+              </a:defRPr>
+            </a:pPr>
+            <a:r>
+              <a:t>👮 Municipalities</a:t>
+            </a:r>
+          </a:p>
+          <a:p>
+            <a:pPr>
+              <a:defRPr sz="1300">
+                <a:solidFill>
+                  <a:srgbClr val="94A3B8"/>
+                </a:solidFill>
+                <a:latin typeface="Segoe UI"/>
+              </a:defRPr>
+            </a:pPr>
+            <a:r>
+              <a:t>RoadWatch community dashboards create transparency in public infrastructure spending, pothole repair trails, and automated violation reporting.</a:t>
+            </a:r>
+          </a:p>
+        </p:txBody>
+      </p:sp>
+      <p:sp>
+        <p:nvSpPr>
+          <p:cNvPr id="5" name="Rounded Rectangle 4"/>
+          <p:cNvSpPr/>
           <p:nvPr/>
         </p:nvSpPr>
         <p:spPr>
           <a:xfrm>
-            <a:off x="6108192" y="1920240"/>
-            <a:ext cx="5120640" cy="3749039"/>
+            <a:off x="8046720" y="1645920"/>
+            <a:ext cx="3291840" cy="4114800"/>
           </a:xfrm>
-          <a:prstGeom prst="rect">
+          <a:prstGeom prst="roundRect">
             <a:avLst/>
           </a:prstGeom>
-          <a:noFill/>
+          <a:solidFill>
+            <a:srgbClr val="1E293B"/>
+          </a:solidFill>
+          <a:ln>
+            <a:solidFill>
+              <a:srgbClr val="F43F5E"/>
+            </a:solidFill>
+          </a:ln>
         </p:spPr>
-        <p:txBody>
-          <a:bodyPr wrap="square">
-            <a:spAutoFit/>
-          </a:bodyPr>
-          <a:lstStyle/>
+        <p:style>
+          <a:lnRef idx="1">
+            <a:schemeClr val="accent1"/>
+          </a:lnRef>
+          <a:fillRef idx="3">
+            <a:schemeClr val="accent1"/>
+          </a:fillRef>
+          <a:effectRef idx="2">
+            <a:schemeClr val="accent1"/>
+          </a:effectRef>
+          <a:fontRef idx="minor">
+            <a:schemeClr val="lt1"/>
+          </a:fontRef>
+        </p:style>
+        <p:txBody>
+          <a:bodyPr rtlCol="0" anchor="ctr" wrap="square" tIns="274320"/>
+          <a:lstStyle/>
+          <a:p>
+            <a:pPr algn="ctr">
+              <a:spcAft>
+                <a:spcPts val="1400"/>
+              </a:spcAft>
+              <a:defRPr sz="1800" b="1">
+                <a:solidFill>
+                  <a:srgbClr val="FFFFFF"/>
+                </a:solidFill>
+                <a:latin typeface="Segoe UI"/>
+              </a:defRPr>
+            </a:pPr>
+            <a:r>
+              <a:t>🚑 Responders</a:t>
+            </a:r>
+          </a:p>
           <a:p>
             <a:pPr>
-              <a:spcAft>
-                <a:spcPts val="1600"/>
-              </a:spcAft>
-              <a:defRPr sz="1600" b="1">
-                <a:solidFill>
-                  <a:srgbClr val="F59E0B"/>
-                </a:solidFill>
-                <a:latin typeface="Century Gothic"/>
+              <a:defRPr sz="1300">
+                <a:solidFill>
+                  <a:srgbClr val="94A3B8"/>
+                </a:solidFill>
+                <a:latin typeface="Segoe UI"/>
               </a:defRPr>
             </a:pPr>
             <a:r>
-              <a:t>TECHNOLOGY STACK CORE</a:t>
-            </a:r>
-          </a:p>
-          <a:p>
-            <a:pPr>
-              <a:spcBef>
-                <a:spcPts val="600"/>
-              </a:spcBef>
-              <a:defRPr sz="1300" b="1">
-                <a:solidFill>
-                  <a:srgbClr val="38BDF8"/>
-                </a:solidFill>
-                <a:latin typeface="Century Gothic"/>
-              </a:defRPr>
-            </a:pPr>
-            <a:r>
-              <a:t>■  Interactive Frontend</a:t>
-            </a:r>
-          </a:p>
-          <a:p>
-            <a:pPr>
-              <a:spcAft>
-                <a:spcPts val="600"/>
-              </a:spcAft>
-              <a:defRPr sz="1100">
-                <a:solidFill>
-                  <a:srgbClr val="F8FAFC"/>
-                </a:solidFill>
-                <a:latin typeface="Century Gothic"/>
-              </a:defRPr>
-            </a:pPr>
-            <a:r>
-              <a:t>React 18, Leaflet.js, Framer Motion, Tailwind CSS, Lucide Icons</a:t>
-            </a:r>
-          </a:p>
-          <a:p>
-            <a:pPr>
-              <a:spcBef>
-                <a:spcPts val="600"/>
-              </a:spcBef>
-              <a:defRPr sz="1300" b="1">
-                <a:solidFill>
-                  <a:srgbClr val="38BDF8"/>
-                </a:solidFill>
-                <a:latin typeface="Century Gothic"/>
-              </a:defRPr>
-            </a:pPr>
-            <a:r>
-              <a:t>■  Monorepo API Backend</a:t>
-            </a:r>
-          </a:p>
-          <a:p>
-            <a:pPr>
-              <a:spcAft>
-                <a:spcPts val="600"/>
-              </a:spcAft>
-              <a:defRPr sz="1100">
-                <a:solidFill>
-                  <a:srgbClr val="F8FAFC"/>
-                </a:solidFill>
-                <a:latin typeface="Century Gothic"/>
-              </a:defRPr>
-            </a:pPr>
-            <a:r>
-              <a:t>Node.js, Express, Telemetry Simulators, Geolocation trackers</a:t>
-            </a:r>
-          </a:p>
-          <a:p>
-            <a:pPr>
-              <a:spcBef>
-                <a:spcPts val="600"/>
-              </a:spcBef>
-              <a:defRPr sz="1300" b="1">
-                <a:solidFill>
-                  <a:srgbClr val="38BDF8"/>
-                </a:solidFill>
-                <a:latin typeface="Century Gothic"/>
-              </a:defRPr>
-            </a:pPr>
-            <a:r>
-              <a:t>■  Generative AI Agent</a:t>
-            </a:r>
-          </a:p>
-          <a:p>
-            <a:pPr>
-              <a:spcAft>
-                <a:spcPts val="600"/>
-              </a:spcAft>
-              <a:defRPr sz="1100">
-                <a:solidFill>
-                  <a:srgbClr val="F8FAFC"/>
-                </a:solidFill>
-                <a:latin typeface="Century Gothic"/>
-              </a:defRPr>
-            </a:pPr>
-            <a:r>
-              <a:t>Google Generative AI (Gemini Core) with static safety fallback catalog</a:t>
-            </a:r>
-          </a:p>
-          <a:p>
-            <a:pPr>
-              <a:spcBef>
-                <a:spcPts val="600"/>
-              </a:spcBef>
-              <a:defRPr sz="1300" b="1">
-                <a:solidFill>
-                  <a:srgbClr val="38BDF8"/>
-                </a:solidFill>
-                <a:latin typeface="Century Gothic"/>
-              </a:defRPr>
-            </a:pPr>
-            <a:r>
-              <a:t>■  GIS Mapping Tiles</a:t>
-            </a:r>
-          </a:p>
-          <a:p>
-            <a:pPr>
-              <a:spcAft>
-                <a:spcPts val="600"/>
-              </a:spcAft>
-              <a:defRPr sz="1100">
-                <a:solidFill>
-                  <a:srgbClr val="F8FAFC"/>
-                </a:solidFill>
-                <a:latin typeface="Century Gothic"/>
-              </a:defRPr>
-            </a:pPr>
-            <a:r>
-              <a:t>OpenStreetMap GIS Tile Systems with animated traffic overlays</a:t>
+              <a:t>RoadSOS beacon coordinates lock directly on responder navigation units, slicing dispatch delays and securing the critical Golden Hour rescue frame.</a:t>
             </a:r>
           </a:p>
         </p:txBody>
@@ -5705,8 +4621,8 @@
         </p:nvSpPr>
         <p:spPr>
           <a:xfrm>
-            <a:off x="685800" y="365760"/>
-            <a:ext cx="9144000" cy="365760"/>
+            <a:off x="822960" y="1097280"/>
+            <a:ext cx="10515600" cy="4572000"/>
           </a:xfrm>
           <a:prstGeom prst="rect">
             <a:avLst/>
@@ -5714,704 +4630,60 @@
           <a:noFill/>
         </p:spPr>
         <p:txBody>
-          <a:bodyPr wrap="square" lIns="0">
-            <a:spAutoFit/>
-          </a:bodyPr>
-          <a:lstStyle/>
-          <a:p>
-            <a:pPr>
-              <a:defRPr sz="1000" b="1">
-                <a:solidFill>
-                  <a:srgbClr val="38BDF8"/>
-                </a:solidFill>
-                <a:latin typeface="Century Gothic"/>
-              </a:defRPr>
-            </a:pPr>
-            <a:r>
-              <a:t>ECOSYSTEM OUTCOMES</a:t>
-            </a:r>
-          </a:p>
-        </p:txBody>
-      </p:sp>
-      <p:sp>
-        <p:nvSpPr>
-          <p:cNvPr id="3" name="TextBox 2"/>
-          <p:cNvSpPr txBox="1"/>
-          <p:nvPr/>
-        </p:nvSpPr>
-        <p:spPr>
-          <a:xfrm>
-            <a:off x="685800" y="594360"/>
-            <a:ext cx="10817352" cy="731520"/>
-          </a:xfrm>
-          <a:prstGeom prst="rect">
-            <a:avLst/>
-          </a:prstGeom>
-          <a:noFill/>
-        </p:spPr>
-        <p:txBody>
-          <a:bodyPr wrap="square" lIns="0">
-            <a:spAutoFit/>
-          </a:bodyPr>
-          <a:lstStyle/>
-          <a:p>
-            <a:pPr>
-              <a:defRPr sz="3200" b="1">
-                <a:solidFill>
-                  <a:srgbClr val="F8FAFC"/>
-                </a:solidFill>
-                <a:latin typeface="Century Gothic"/>
-              </a:defRPr>
-            </a:pPr>
-            <a:r>
-              <a:t>Operational &amp; Societal Impact Matrix</a:t>
-            </a:r>
-          </a:p>
-        </p:txBody>
-      </p:sp>
-      <p:sp>
-        <p:nvSpPr>
-          <p:cNvPr id="4" name="Rounded Rectangle 3"/>
-          <p:cNvSpPr/>
-          <p:nvPr/>
-        </p:nvSpPr>
-        <p:spPr>
-          <a:xfrm>
-            <a:off x="685800" y="1645920"/>
-            <a:ext cx="3364992" cy="4297680"/>
-          </a:xfrm>
-          <a:prstGeom prst="roundRect">
-            <a:avLst/>
-          </a:prstGeom>
-          <a:solidFill>
-            <a:srgbClr val="1E293B"/>
-          </a:solidFill>
-          <a:ln w="19050">
-            <a:solidFill>
-              <a:srgbClr val="38BDF8"/>
-            </a:solidFill>
-          </a:ln>
-        </p:spPr>
-        <p:style>
-          <a:lnRef idx="1">
-            <a:schemeClr val="accent1"/>
-          </a:lnRef>
-          <a:fillRef idx="3">
-            <a:schemeClr val="accent1"/>
-          </a:fillRef>
-          <a:effectRef idx="2">
-            <a:schemeClr val="accent1"/>
-          </a:effectRef>
-          <a:fontRef idx="minor">
-            <a:schemeClr val="lt1"/>
-          </a:fontRef>
-        </p:style>
-        <p:txBody>
-          <a:bodyPr rtlCol="0" anchor="ctr"/>
-          <a:lstStyle/>
-          <a:p>
-            <a:pPr algn="ctr"/>
-          </a:p>
-        </p:txBody>
-      </p:sp>
-      <p:sp>
-        <p:nvSpPr>
-          <p:cNvPr id="5" name="TextBox 4"/>
-          <p:cNvSpPr txBox="1"/>
-          <p:nvPr/>
-        </p:nvSpPr>
-        <p:spPr>
-          <a:xfrm>
-            <a:off x="914400" y="1920240"/>
-            <a:ext cx="2907792" cy="3749039"/>
-          </a:xfrm>
-          <a:prstGeom prst="rect">
-            <a:avLst/>
-          </a:prstGeom>
-          <a:noFill/>
-        </p:spPr>
-        <p:txBody>
           <a:bodyPr wrap="square">
             <a:spAutoFit/>
           </a:bodyPr>
           <a:lstStyle/>
           <a:p>
-            <a:pPr>
+            <a:pPr algn="ctr">
               <a:spcAft>
-                <a:spcPts val="1800"/>
+                <a:spcPts val="1400"/>
               </a:spcAft>
-              <a:defRPr sz="1800" b="1">
+              <a:defRPr sz="6400" b="1">
                 <a:solidFill>
                   <a:srgbClr val="38BDF8"/>
                 </a:solidFill>
-                <a:latin typeface="Century Gothic"/>
+                <a:latin typeface="Segoe UI"/>
               </a:defRPr>
             </a:pPr>
             <a:r>
-              <a:t>CITIZENS</a:t>
-            </a:r>
-          </a:p>
-          <a:p>
-            <a:pPr>
-              <a:spcBef>
-                <a:spcPts val="800"/>
-              </a:spcBef>
-              <a:defRPr sz="1300">
-                <a:solidFill>
-                  <a:srgbClr val="F8FAFC"/>
-                </a:solidFill>
-                <a:latin typeface="Century Gothic"/>
+              <a:t>THANK YOU!</a:t>
+            </a:r>
+          </a:p>
+          <a:p>
+            <a:pPr algn="ctr">
+              <a:spcAft>
+                <a:spcPts val="4000"/>
+              </a:spcAft>
+              <a:defRPr sz="2000" b="1">
+                <a:solidFill>
+                  <a:srgbClr val="FFFFFF"/>
+                </a:solidFill>
+                <a:latin typeface="Segoe UI"/>
               </a:defRPr>
             </a:pPr>
             <a:r>
-              <a:t>Enables safe route planning, instant dangerous pothole file reports, active AI safety coaching, and localized drive-legal penalties awareness.</a:t>
-            </a:r>
-          </a:p>
-        </p:txBody>
-      </p:sp>
-      <p:sp>
-        <p:nvSpPr>
-          <p:cNvPr id="6" name="Rounded Rectangle 5"/>
-          <p:cNvSpPr/>
-          <p:nvPr/>
-        </p:nvSpPr>
-        <p:spPr>
-          <a:xfrm>
-            <a:off x="4416552" y="1645920"/>
-            <a:ext cx="3364992" cy="4297680"/>
-          </a:xfrm>
-          <a:prstGeom prst="roundRect">
-            <a:avLst/>
-          </a:prstGeom>
-          <a:solidFill>
-            <a:srgbClr val="1E293B"/>
-          </a:solidFill>
-          <a:ln w="19050">
-            <a:solidFill>
-              <a:srgbClr val="F59E0B"/>
-            </a:solidFill>
-          </a:ln>
-        </p:spPr>
-        <p:style>
-          <a:lnRef idx="1">
-            <a:schemeClr val="accent1"/>
-          </a:lnRef>
-          <a:fillRef idx="3">
-            <a:schemeClr val="accent1"/>
-          </a:fillRef>
-          <a:effectRef idx="2">
-            <a:schemeClr val="accent1"/>
-          </a:effectRef>
-          <a:fontRef idx="minor">
-            <a:schemeClr val="lt1"/>
-          </a:fontRef>
-        </p:style>
-        <p:txBody>
-          <a:bodyPr rtlCol="0" anchor="ctr"/>
-          <a:lstStyle/>
-          <a:p>
-            <a:pPr algn="ctr"/>
-          </a:p>
-        </p:txBody>
-      </p:sp>
-      <p:sp>
-        <p:nvSpPr>
-          <p:cNvPr id="7" name="TextBox 6"/>
-          <p:cNvSpPr txBox="1"/>
-          <p:nvPr/>
-        </p:nvSpPr>
-        <p:spPr>
-          <a:xfrm>
-            <a:off x="4645152" y="1920240"/>
-            <a:ext cx="2907792" cy="3749039"/>
-          </a:xfrm>
-          <a:prstGeom prst="rect">
-            <a:avLst/>
-          </a:prstGeom>
-          <a:noFill/>
-        </p:spPr>
-        <p:txBody>
-          <a:bodyPr wrap="square">
-            <a:spAutoFit/>
-          </a:bodyPr>
-          <a:lstStyle/>
-          <a:p>
-            <a:pPr>
+              <a:t>Join us in transforming Indian transit corridors, one life at a time.</a:t>
+            </a:r>
+          </a:p>
+          <a:p>
+            <a:pPr algn="ctr">
               <a:spcAft>
-                <a:spcPts val="1800"/>
+                <a:spcPts val="2000"/>
               </a:spcAft>
-              <a:defRPr sz="1800" b="1">
+              <a:defRPr sz="1600" b="1">
                 <a:solidFill>
                   <a:srgbClr val="F59E0B"/>
                 </a:solidFill>
-                <a:latin typeface="Century Gothic"/>
+                <a:latin typeface="Consolas"/>
               </a:defRPr>
             </a:pPr>
             <a:r>
-              <a:t>AUTHORITIES</a:t>
-            </a:r>
-          </a:p>
-          <a:p>
-            <a:pPr>
-              <a:spcBef>
-                <a:spcPts val="800"/>
-              </a:spcBef>
-              <a:defRPr sz="1300">
-                <a:solidFill>
-                  <a:srgbClr val="F8FAFC"/>
-                </a:solidFill>
-                <a:latin typeface="Century Gothic"/>
-              </a:defRPr>
-            </a:pPr>
-            <a:r>
-              <a:t>Guarantees public auditability of repair tasks, displays allocated fund utilization transparently, and accelerates dispatcher repair coordination.</a:t>
-            </a:r>
-          </a:p>
-        </p:txBody>
-      </p:sp>
-      <p:sp>
-        <p:nvSpPr>
-          <p:cNvPr id="8" name="Rounded Rectangle 7"/>
-          <p:cNvSpPr/>
-          <p:nvPr/>
-        </p:nvSpPr>
-        <p:spPr>
-          <a:xfrm>
-            <a:off x="8147304" y="1645920"/>
-            <a:ext cx="3364992" cy="4297680"/>
-          </a:xfrm>
-          <a:prstGeom prst="roundRect">
-            <a:avLst/>
-          </a:prstGeom>
-          <a:solidFill>
-            <a:srgbClr val="1E293B"/>
-          </a:solidFill>
-          <a:ln w="19050">
-            <a:solidFill>
-              <a:srgbClr val="F43F5E"/>
-            </a:solidFill>
-          </a:ln>
-        </p:spPr>
-        <p:style>
-          <a:lnRef idx="1">
-            <a:schemeClr val="accent1"/>
-          </a:lnRef>
-          <a:fillRef idx="3">
-            <a:schemeClr val="accent1"/>
-          </a:fillRef>
-          <a:effectRef idx="2">
-            <a:schemeClr val="accent1"/>
-          </a:effectRef>
-          <a:fontRef idx="minor">
-            <a:schemeClr val="lt1"/>
-          </a:fontRef>
-        </p:style>
-        <p:txBody>
-          <a:bodyPr rtlCol="0" anchor="ctr"/>
-          <a:lstStyle/>
-          <a:p>
-            <a:pPr algn="ctr"/>
-          </a:p>
-        </p:txBody>
-      </p:sp>
-      <p:sp>
-        <p:nvSpPr>
-          <p:cNvPr id="9" name="TextBox 8"/>
-          <p:cNvSpPr txBox="1"/>
-          <p:nvPr/>
-        </p:nvSpPr>
-        <p:spPr>
-          <a:xfrm>
-            <a:off x="8375904" y="1920240"/>
-            <a:ext cx="2907792" cy="3749039"/>
-          </a:xfrm>
-          <a:prstGeom prst="rect">
-            <a:avLst/>
-          </a:prstGeom>
-          <a:noFill/>
-        </p:spPr>
-        <p:txBody>
-          <a:bodyPr wrap="square">
-            <a:spAutoFit/>
-          </a:bodyPr>
-          <a:lstStyle/>
-          <a:p>
-            <a:pPr>
-              <a:spcAft>
-                <a:spcPts val="1800"/>
-              </a:spcAft>
-              <a:defRPr sz="1800" b="1">
-                <a:solidFill>
-                  <a:srgbClr val="F43F5E"/>
-                </a:solidFill>
-                <a:latin typeface="Century Gothic"/>
-              </a:defRPr>
-            </a:pPr>
-            <a:r>
-              <a:t>EMERGENCY SERVICES</a:t>
-            </a:r>
-          </a:p>
-          <a:p>
-            <a:pPr>
-              <a:spcBef>
-                <a:spcPts val="800"/>
-              </a:spcBef>
-              <a:defRPr sz="1300">
-                <a:solidFill>
-                  <a:srgbClr val="F8FAFC"/>
-                </a:solidFill>
-                <a:latin typeface="Century Gothic"/>
-              </a:defRPr>
-            </a:pPr>
-            <a:r>
-              <a:t>Coordinates critical 60-minute golden hour rescue beacons, provides 100% accurate geolocation tracking, and pre-allocates rescue channels.</a:t>
-            </a:r>
-          </a:p>
-        </p:txBody>
-      </p:sp>
-    </p:spTree>
-  </p:cSld>
-  <p:clrMapOvr>
-    <a:masterClrMapping/>
-  </p:clrMapOvr>
-</p:sld>
-</file>
-
-<file path=ppt/slides/slide8.xml><?xml version="1.0" encoding="utf-8"?>
-<p:sld xmlns:a="http://schemas.openxmlformats.org/drawingml/2006/main" xmlns:p="http://schemas.openxmlformats.org/presentationml/2006/main" xmlns:r="http://schemas.openxmlformats.org/officeDocument/2006/relationships">
-  <p:cSld>
-    <p:bg>
-      <p:bgPr>
-        <a:solidFill>
-          <a:srgbClr val="0F172A"/>
-        </a:solidFill>
-        <a:effectLst/>
-      </p:bgPr>
-    </p:bg>
-    <p:spTree>
-      <p:nvGrpSpPr>
-        <p:cNvPr id="1" name=""/>
-        <p:cNvGrpSpPr/>
-        <p:nvPr/>
-      </p:nvGrpSpPr>
-      <p:grpSpPr/>
-      <p:sp>
-        <p:nvSpPr>
-          <p:cNvPr id="2" name="TextBox 1"/>
-          <p:cNvSpPr txBox="1"/>
-          <p:nvPr/>
-        </p:nvSpPr>
-        <p:spPr>
-          <a:xfrm>
-            <a:off x="914400" y="1645920"/>
-            <a:ext cx="10360152" cy="1097280"/>
-          </a:xfrm>
-          <a:prstGeom prst="rect">
-            <a:avLst/>
-          </a:prstGeom>
-          <a:noFill/>
-        </p:spPr>
-        <p:txBody>
-          <a:bodyPr wrap="square">
-            <a:spAutoFit/>
-          </a:bodyPr>
-          <a:lstStyle/>
-          <a:p>
-            <a:pPr algn="ctr">
-              <a:defRPr sz="6400" b="1">
-                <a:solidFill>
-                  <a:srgbClr val="38BDF8"/>
-                </a:solidFill>
-                <a:latin typeface="Century Gothic"/>
-              </a:defRPr>
-            </a:pPr>
-            <a:r>
-              <a:t>THANK YOU!</a:t>
-            </a:r>
-          </a:p>
-        </p:txBody>
-      </p:sp>
-      <p:sp>
-        <p:nvSpPr>
-          <p:cNvPr id="3" name="TextBox 2"/>
-          <p:cNvSpPr txBox="1"/>
-          <p:nvPr/>
-        </p:nvSpPr>
-        <p:spPr>
-          <a:xfrm>
-            <a:off x="914400" y="2743200"/>
-            <a:ext cx="10360152" cy="731520"/>
-          </a:xfrm>
-          <a:prstGeom prst="rect">
-            <a:avLst/>
-          </a:prstGeom>
-          <a:noFill/>
-        </p:spPr>
-        <p:txBody>
-          <a:bodyPr wrap="square">
-            <a:spAutoFit/>
-          </a:bodyPr>
-          <a:lstStyle/>
-          <a:p>
-            <a:pPr algn="ctr">
-              <a:defRPr sz="2000" b="0">
-                <a:solidFill>
-                  <a:srgbClr val="F8FAFC"/>
-                </a:solidFill>
-                <a:latin typeface="Century Gothic"/>
-              </a:defRPr>
-            </a:pPr>
-            <a:r>
-              <a:t>Transforming Indian Roads, Protecting Precious Lives.</a:t>
-            </a:r>
-          </a:p>
-        </p:txBody>
-      </p:sp>
-      <p:sp>
-        <p:nvSpPr>
-          <p:cNvPr id="4" name="TextBox 3"/>
-          <p:cNvSpPr txBox="1"/>
-          <p:nvPr/>
-        </p:nvSpPr>
-        <p:spPr>
-          <a:xfrm>
-            <a:off x="914400" y="3474720"/>
-            <a:ext cx="10360152" cy="731520"/>
-          </a:xfrm>
-          <a:prstGeom prst="rect">
-            <a:avLst/>
-          </a:prstGeom>
-          <a:noFill/>
-        </p:spPr>
-        <p:txBody>
-          <a:bodyPr wrap="square">
-            <a:spAutoFit/>
-          </a:bodyPr>
-          <a:lstStyle/>
-          <a:p>
-            <a:pPr algn="ctr">
-              <a:defRPr sz="1400" b="1">
-                <a:solidFill>
-                  <a:srgbClr val="F59E0B"/>
-                </a:solidFill>
-                <a:latin typeface="Century Gothic"/>
-              </a:defRPr>
-            </a:pPr>
-            <a:r>
-              <a:t>Presented by Team NXT-waVE (Ajay Rathod &amp; Animesh Bhanarkar)</a:t>
-            </a:r>
-          </a:p>
-        </p:txBody>
-      </p:sp>
-      <p:sp>
-        <p:nvSpPr>
-          <p:cNvPr id="5" name="Rectangle 4"/>
-          <p:cNvSpPr/>
-          <p:nvPr/>
-        </p:nvSpPr>
-        <p:spPr>
-          <a:xfrm>
-            <a:off x="4261104" y="4114800"/>
-            <a:ext cx="3657600" cy="27432"/>
-          </a:xfrm>
-          <a:prstGeom prst="rect">
-            <a:avLst/>
-          </a:prstGeom>
-          <a:solidFill>
-            <a:srgbClr val="38BDF8"/>
-          </a:solidFill>
-          <a:ln>
-            <a:noFill/>
-          </a:ln>
-        </p:spPr>
-        <p:style>
-          <a:lnRef idx="1">
-            <a:schemeClr val="accent1"/>
-          </a:lnRef>
-          <a:fillRef idx="3">
-            <a:schemeClr val="accent1"/>
-          </a:fillRef>
-          <a:effectRef idx="2">
-            <a:schemeClr val="accent1"/>
-          </a:effectRef>
-          <a:fontRef idx="minor">
-            <a:schemeClr val="lt1"/>
-          </a:fontRef>
-        </p:style>
-        <p:txBody>
-          <a:bodyPr rtlCol="0" anchor="ctr"/>
-          <a:lstStyle/>
-          <a:p>
-            <a:pPr algn="ctr"/>
-          </a:p>
-        </p:txBody>
-      </p:sp>
-      <p:sp>
-        <p:nvSpPr>
-          <p:cNvPr id="6" name="Rounded Rectangle 5"/>
-          <p:cNvSpPr/>
-          <p:nvPr/>
-        </p:nvSpPr>
-        <p:spPr>
-          <a:xfrm>
-            <a:off x="2011680" y="4480560"/>
-            <a:ext cx="3749039" cy="914400"/>
-          </a:xfrm>
-          <a:prstGeom prst="roundRect">
-            <a:avLst/>
-          </a:prstGeom>
-          <a:solidFill>
-            <a:srgbClr val="1E293B"/>
-          </a:solidFill>
-          <a:ln w="19050">
-            <a:solidFill>
-              <a:srgbClr val="38BDF8"/>
-            </a:solidFill>
-          </a:ln>
-        </p:spPr>
-        <p:style>
-          <a:lnRef idx="1">
-            <a:schemeClr val="accent1"/>
-          </a:lnRef>
-          <a:fillRef idx="3">
-            <a:schemeClr val="accent1"/>
-          </a:fillRef>
-          <a:effectRef idx="2">
-            <a:schemeClr val="accent1"/>
-          </a:effectRef>
-          <a:fontRef idx="minor">
-            <a:schemeClr val="lt1"/>
-          </a:fontRef>
-        </p:style>
-        <p:txBody>
-          <a:bodyPr rtlCol="0" anchor="ctr"/>
-          <a:lstStyle/>
-          <a:p>
-            <a:pPr algn="ctr"/>
-          </a:p>
-        </p:txBody>
-      </p:sp>
-      <p:sp>
-        <p:nvSpPr>
-          <p:cNvPr id="7" name="TextBox 6"/>
-          <p:cNvSpPr txBox="1"/>
-          <p:nvPr/>
-        </p:nvSpPr>
-        <p:spPr>
-          <a:xfrm>
-            <a:off x="2011680" y="4572000"/>
-            <a:ext cx="3749039" cy="731520"/>
-          </a:xfrm>
-          <a:prstGeom prst="rect">
-            <a:avLst/>
-          </a:prstGeom>
-          <a:noFill/>
-        </p:spPr>
-        <p:txBody>
-          <a:bodyPr wrap="square">
-            <a:spAutoFit/>
-          </a:bodyPr>
-          <a:lstStyle/>
-          <a:p>
-            <a:pPr algn="ctr">
-              <a:defRPr sz="1100">
-                <a:solidFill>
-                  <a:srgbClr val="F8FAFC"/>
-                </a:solidFill>
-                <a:latin typeface="Century Gothic"/>
-              </a:defRPr>
-            </a:pPr>
-            <a:r>
-              <a:t>DEMO LINK</a:t>
+              <a:t>🌐 Interactive Live Demo: https://raastasense.vercel.app</a:t>
             </a:r>
             <a:br/>
             <a:r>
-              <a:t>https://raastasense.vercel.app</a:t>
-            </a:r>
-          </a:p>
-        </p:txBody>
-      </p:sp>
-      <p:sp>
-        <p:nvSpPr>
-          <p:cNvPr id="8" name="Rounded Rectangle 7"/>
-          <p:cNvSpPr/>
-          <p:nvPr/>
-        </p:nvSpPr>
-        <p:spPr>
-          <a:xfrm>
-            <a:off x="6400800" y="4480560"/>
-            <a:ext cx="3749039" cy="914400"/>
-          </a:xfrm>
-          <a:prstGeom prst="roundRect">
-            <a:avLst/>
-          </a:prstGeom>
-          <a:solidFill>
-            <a:srgbClr val="1E293B"/>
-          </a:solidFill>
-          <a:ln w="19050">
-            <a:solidFill>
-              <a:srgbClr val="F59E0B"/>
-            </a:solidFill>
-          </a:ln>
-        </p:spPr>
-        <p:style>
-          <a:lnRef idx="1">
-            <a:schemeClr val="accent1"/>
-          </a:lnRef>
-          <a:fillRef idx="3">
-            <a:schemeClr val="accent1"/>
-          </a:fillRef>
-          <a:effectRef idx="2">
-            <a:schemeClr val="accent1"/>
-          </a:effectRef>
-          <a:fontRef idx="minor">
-            <a:schemeClr val="lt1"/>
-          </a:fontRef>
-        </p:style>
-        <p:txBody>
-          <a:bodyPr rtlCol="0" anchor="ctr"/>
-          <a:lstStyle/>
-          <a:p>
-            <a:pPr algn="ctr"/>
-          </a:p>
-        </p:txBody>
-      </p:sp>
-      <p:sp>
-        <p:nvSpPr>
-          <p:cNvPr id="9" name="TextBox 8"/>
-          <p:cNvSpPr txBox="1"/>
-          <p:nvPr/>
-        </p:nvSpPr>
-        <p:spPr>
-          <a:xfrm>
-            <a:off x="6400800" y="4572000"/>
-            <a:ext cx="3749039" cy="731520"/>
-          </a:xfrm>
-          <a:prstGeom prst="rect">
-            <a:avLst/>
-          </a:prstGeom>
-          <a:noFill/>
-        </p:spPr>
-        <p:txBody>
-          <a:bodyPr wrap="square">
-            <a:spAutoFit/>
-          </a:bodyPr>
-          <a:lstStyle/>
-          <a:p>
-            <a:pPr algn="ctr">
-              <a:defRPr sz="1100">
-                <a:solidFill>
-                  <a:srgbClr val="F8FAFC"/>
-                </a:solidFill>
-                <a:latin typeface="Century Gothic"/>
-              </a:defRPr>
-            </a:pPr>
-            <a:r>
-              <a:t>GITHUB LINK</a:t>
-            </a:r>
-            <a:br/>
-            <a:r>
-              <a:t>https://github.com/Ajayrathod04/RaastaSense</a:t>
+              <a:t>💻 Open-Source Codebase: https://github.com/Ajayrathod04/RaastaSense</a:t>
             </a:r>
           </a:p>
         </p:txBody>

</xml_diff>

<commit_message>
hackathon-upgrades: fix Map coordinates, correct speedometer types, integrate 10-city Analytics dashboard, add AI Guardian assistant page, and update submission assets
</commit_message>
<xml_diff>
--- a/RaastaSense_Hackathon_Presentation.pptx
+++ b/RaastaSense_Hackathon_Presentation.pptx
@@ -8,8 +8,19 @@
     <p:sldId id="256" r:id="rId7"/>
     <p:sldId id="257" r:id="rId8"/>
     <p:sldId id="258" r:id="rId9"/>
+    <p:sldId id="269" r:id="rId20"/>
+    <p:sldId id="270" r:id="rId21"/>
+    <p:sldId id="266" r:id="rId17"/>
+    <p:sldId id="271" r:id="rId22"/>
+    <p:sldId id="263" r:id="rId14"/>
+    <p:sldId id="272" r:id="rId23"/>
+    <p:sldId id="273" r:id="rId24"/>
+    <p:sldId id="267" r:id="rId18"/>
     <p:sldId id="259" r:id="rId10"/>
+    <p:sldId id="268" r:id="rId19"/>
+    <p:sldId id="264" r:id="rId15"/>
     <p:sldId id="260" r:id="rId11"/>
+    <p:sldId id="265" r:id="rId16"/>
     <p:sldId id="261" r:id="rId12"/>
     <p:sldId id="262" r:id="rId13"/>
   </p:sldIdLst>
@@ -3234,6 +3245,1462 @@
 </p:sld>
 </file>
 
+<file path=ppt/slides/slide10.xml><?xml version="1.0" encoding="utf-8"?>
+<p:sld xmlns:a="http://schemas.openxmlformats.org/drawingml/2006/main" xmlns:p="http://schemas.openxmlformats.org/presentationml/2006/main" xmlns:r="http://schemas.openxmlformats.org/officeDocument/2006/relationships">
+  <p:cSld>
+    <p:spTree>
+      <p:nvGrpSpPr>
+        <p:cNvPr id="1" name=""/>
+        <p:cNvGrpSpPr/>
+        <p:nvPr/>
+      </p:nvGrpSpPr>
+      <p:grpSpPr/>
+      <p:sp>
+        <p:nvSpPr>
+          <p:cNvPr id="2" name="Title 1"/>
+          <p:cNvSpPr>
+            <a:spLocks noGrp="1"/>
+          </p:cNvSpPr>
+          <p:nvPr>
+            <p:ph type="title"/>
+          </p:nvPr>
+        </p:nvSpPr>
+        <p:spPr/>
+        <p:txBody>
+          <a:bodyPr/>
+          <a:lstStyle/>
+          <a:p>
+            <a:pPr>
+              <a:defRPr sz="2800" b="1">
+                <a:solidFill>
+                  <a:srgbClr val="FFFFFF"/>
+                </a:solidFill>
+              </a:defRPr>
+            </a:pPr>
+            <a:r>
+              <a:t>VISUAL HUD: DIGITAL TWIN MAPPING ENGINE</a:t>
+            </a:r>
+          </a:p>
+        </p:txBody>
+      </p:sp>
+      <p:sp>
+        <p:nvSpPr>
+          <p:cNvPr id="3" name="TextBox 2"/>
+          <p:cNvSpPr txBox="1"/>
+          <p:nvPr/>
+        </p:nvSpPr>
+        <p:spPr>
+          <a:xfrm>
+            <a:off x="731520" y="1371600"/>
+            <a:ext cx="10698480" cy="1097280"/>
+          </a:xfrm>
+          <a:prstGeom prst="rect">
+            <a:avLst/>
+          </a:prstGeom>
+          <a:noFill/>
+        </p:spPr>
+        <p:txBody>
+          <a:bodyPr wrap="square">
+            <a:spAutoFit/>
+          </a:bodyPr>
+          <a:lstStyle/>
+          <a:p>
+            <a:pPr>
+              <a:defRPr sz="1400">
+                <a:solidFill>
+                  <a:srgbClr val="94A3B8"/>
+                </a:solidFill>
+              </a:defRPr>
+            </a:pPr>
+            <a:r>
+              <a:t>Cyberslate GIS Interface demonstrating safest, fastest, eco-friendly, and emergency vehicle routing paths, dynamic coordinates telemetry, and active incident report layers.</a:t>
+            </a:r>
+          </a:p>
+        </p:txBody>
+      </p:sp>
+      <p:pic>
+        <p:nvPicPr>
+          <p:cNvPr id="4" name="Picture 3" descr="raastasense_route_engine.png"/>
+          <p:cNvPicPr>
+            <a:picLocks noChangeAspect="1"/>
+          </p:cNvPicPr>
+          <p:nvPr/>
+        </p:nvPicPr>
+        <p:blipFill>
+          <a:blip r:embed="rId2"/>
+          <a:stretch>
+            <a:fillRect/>
+          </a:stretch>
+        </p:blipFill>
+        <p:spPr>
+          <a:xfrm>
+            <a:off x="2798064" y="2468880"/>
+            <a:ext cx="6583680" cy="3840480"/>
+          </a:xfrm>
+          <a:prstGeom prst="rect">
+            <a:avLst/>
+          </a:prstGeom>
+        </p:spPr>
+      </p:pic>
+    </p:spTree>
+  </p:cSld>
+  <p:clrMapOvr>
+    <a:masterClrMapping/>
+  </p:clrMapOvr>
+</p:sld>
+</file>
+
+<file path=ppt/slides/slide11.xml><?xml version="1.0" encoding="utf-8"?>
+<p:sld xmlns:a="http://schemas.openxmlformats.org/drawingml/2006/main" xmlns:p="http://schemas.openxmlformats.org/presentationml/2006/main" xmlns:r="http://schemas.openxmlformats.org/officeDocument/2006/relationships">
+  <p:cSld>
+    <p:bg>
+      <p:bgPr>
+        <a:solidFill>
+          <a:srgbClr val="0F172A"/>
+        </a:solidFill>
+        <a:effectLst/>
+      </p:bgPr>
+    </p:bg>
+    <p:spTree>
+      <p:nvGrpSpPr>
+        <p:cNvPr id="1" name=""/>
+        <p:cNvGrpSpPr/>
+        <p:nvPr/>
+      </p:nvGrpSpPr>
+      <p:grpSpPr/>
+      <p:sp>
+        <p:nvSpPr>
+          <p:cNvPr id="2" name="TextBox 1"/>
+          <p:cNvSpPr txBox="1"/>
+          <p:nvPr/>
+        </p:nvSpPr>
+        <p:spPr>
+          <a:xfrm>
+            <a:off x="731520" y="457200"/>
+            <a:ext cx="10698480" cy="731520"/>
+          </a:xfrm>
+          <a:prstGeom prst="rect">
+            <a:avLst/>
+          </a:prstGeom>
+          <a:noFill/>
+        </p:spPr>
+        <p:txBody>
+          <a:bodyPr wrap="none">
+            <a:spAutoFit/>
+          </a:bodyPr>
+          <a:lstStyle/>
+          <a:p>
+            <a:pPr>
+              <a:defRPr sz="2800" b="1">
+                <a:solidFill>
+                  <a:srgbClr val="F59E0B"/>
+                </a:solidFill>
+                <a:latin typeface="Segoe UI"/>
+              </a:defRPr>
+            </a:pPr>
+            <a:r>
+              <a:t>INTELLIGENT CORE ENGINE MODULES</a:t>
+            </a:r>
+          </a:p>
+        </p:txBody>
+      </p:sp>
+      <p:sp>
+        <p:nvSpPr>
+          <p:cNvPr id="3" name="Rounded Rectangle 2"/>
+          <p:cNvSpPr/>
+          <p:nvPr/>
+        </p:nvSpPr>
+        <p:spPr>
+          <a:xfrm>
+            <a:off x="731520" y="1463040"/>
+            <a:ext cx="5120640" cy="2011680"/>
+          </a:xfrm>
+          <a:prstGeom prst="roundRect">
+            <a:avLst/>
+          </a:prstGeom>
+          <a:solidFill>
+            <a:srgbClr val="1E293B"/>
+          </a:solidFill>
+          <a:ln>
+            <a:solidFill>
+              <a:srgbClr val="38BDF8"/>
+            </a:solidFill>
+          </a:ln>
+        </p:spPr>
+        <p:style>
+          <a:lnRef idx="1">
+            <a:schemeClr val="accent1"/>
+          </a:lnRef>
+          <a:fillRef idx="3">
+            <a:schemeClr val="accent1"/>
+          </a:fillRef>
+          <a:effectRef idx="2">
+            <a:schemeClr val="accent1"/>
+          </a:effectRef>
+          <a:fontRef idx="minor">
+            <a:schemeClr val="lt1"/>
+          </a:fontRef>
+        </p:style>
+        <p:txBody>
+          <a:bodyPr rtlCol="0" anchor="ctr" wrap="square" tIns="137160"/>
+          <a:lstStyle/>
+          <a:p>
+            <a:pPr algn="ctr">
+              <a:spcAft>
+                <a:spcPts val="800"/>
+              </a:spcAft>
+              <a:defRPr sz="1600" b="1">
+                <a:solidFill>
+                  <a:srgbClr val="FFFFFF"/>
+                </a:solidFill>
+                <a:latin typeface="Segoe UI"/>
+              </a:defRPr>
+            </a:pPr>
+            <a:r>
+              <a:t>🚦 Safe Route Engine (Phase 8 Highlight)</a:t>
+            </a:r>
+          </a:p>
+          <a:p>
+            <a:pPr>
+              <a:defRPr sz="1200">
+                <a:solidFill>
+                  <a:srgbClr val="94A3B8"/>
+                </a:solidFill>
+                <a:latin typeface="Segoe UI"/>
+              </a:defRPr>
+            </a:pPr>
+            <a:r>
+              <a:t>Calculates Fastest, Safest, and Least Incident corridors. Displays Safety Indexes, weather/traffic conditions, and dynamic recommended overlays.</a:t>
+            </a:r>
+          </a:p>
+        </p:txBody>
+      </p:sp>
+      <p:sp>
+        <p:nvSpPr>
+          <p:cNvPr id="4" name="Rounded Rectangle 3"/>
+          <p:cNvSpPr/>
+          <p:nvPr/>
+        </p:nvSpPr>
+        <p:spPr>
+          <a:xfrm>
+            <a:off x="6217920" y="1463040"/>
+            <a:ext cx="5120640" cy="2011680"/>
+          </a:xfrm>
+          <a:prstGeom prst="roundRect">
+            <a:avLst/>
+          </a:prstGeom>
+          <a:solidFill>
+            <a:srgbClr val="1E293B"/>
+          </a:solidFill>
+          <a:ln>
+            <a:solidFill>
+              <a:srgbClr val="38BDF8"/>
+            </a:solidFill>
+          </a:ln>
+        </p:spPr>
+        <p:style>
+          <a:lnRef idx="1">
+            <a:schemeClr val="accent1"/>
+          </a:lnRef>
+          <a:fillRef idx="3">
+            <a:schemeClr val="accent1"/>
+          </a:fillRef>
+          <a:effectRef idx="2">
+            <a:schemeClr val="accent1"/>
+          </a:effectRef>
+          <a:fontRef idx="minor">
+            <a:schemeClr val="lt1"/>
+          </a:fontRef>
+        </p:style>
+        <p:txBody>
+          <a:bodyPr rtlCol="0" anchor="ctr" wrap="square" tIns="137160"/>
+          <a:lstStyle/>
+          <a:p>
+            <a:pPr>
+              <a:defRPr sz="1200">
+                <a:solidFill>
+                  <a:srgbClr val="E2E8F0"/>
+                </a:solidFill>
+              </a:defRPr>
+            </a:pPr>
+            <a:r>
+              <a:t>⚖️ AI Guardian Safety Counseling</a:t>
+            </a:r>
+          </a:p>
+          <a:p>
+            <a:pPr>
+              <a:defRPr sz="1200">
+                <a:solidFill>
+                  <a:srgbClr val="E2E8F0"/>
+                </a:solidFill>
+              </a:defRPr>
+            </a:pPr>
+            <a:r>
+              <a:t>Monitors driver parameters (fatigue, speed, seatbelt) in real-time. Delivers multilingual voice and text alerts to enforce legal compliance and safe transit.</a:t>
+            </a:r>
+          </a:p>
+        </p:txBody>
+      </p:sp>
+      <p:sp>
+        <p:nvSpPr>
+          <p:cNvPr id="5" name="Rounded Rectangle 4"/>
+          <p:cNvSpPr/>
+          <p:nvPr/>
+        </p:nvSpPr>
+        <p:spPr>
+          <a:xfrm>
+            <a:off x="731520" y="3840480"/>
+            <a:ext cx="5120640" cy="2011680"/>
+          </a:xfrm>
+          <a:prstGeom prst="roundRect">
+            <a:avLst/>
+          </a:prstGeom>
+          <a:solidFill>
+            <a:srgbClr val="1E293B"/>
+          </a:solidFill>
+          <a:ln>
+            <a:solidFill>
+              <a:srgbClr val="38BDF8"/>
+            </a:solidFill>
+          </a:ln>
+        </p:spPr>
+        <p:style>
+          <a:lnRef idx="1">
+            <a:schemeClr val="accent1"/>
+          </a:lnRef>
+          <a:fillRef idx="3">
+            <a:schemeClr val="accent1"/>
+          </a:fillRef>
+          <a:effectRef idx="2">
+            <a:schemeClr val="accent1"/>
+          </a:effectRef>
+          <a:fontRef idx="minor">
+            <a:schemeClr val="lt1"/>
+          </a:fontRef>
+        </p:style>
+        <p:txBody>
+          <a:bodyPr rtlCol="0" anchor="ctr" wrap="square" tIns="137160"/>
+          <a:lstStyle/>
+          <a:p>
+            <a:pPr algn="ctr">
+              <a:spcAft>
+                <a:spcPts val="800"/>
+              </a:spcAft>
+              <a:defRPr sz="1600" b="1">
+                <a:solidFill>
+                  <a:srgbClr val="FFFFFF"/>
+                </a:solidFill>
+                <a:latin typeface="Segoe UI"/>
+              </a:defRPr>
+            </a:pPr>
+            <a:r>
+              <a:t>📸 RoadWatch AI Incident Diagnostics</a:t>
+            </a:r>
+          </a:p>
+          <a:p>
+            <a:pPr>
+              <a:defRPr sz="1200">
+                <a:solidFill>
+                  <a:srgbClr val="94A3B8"/>
+                </a:solidFill>
+                <a:latin typeface="Segoe UI"/>
+              </a:defRPr>
+            </a:pPr>
+            <a:r>
+              <a:t>Citizen hazard submission portals. Features automatic AI-powered image diagnosis with calculated confidence matrices, severity metrics, and direct action protocols.</a:t>
+            </a:r>
+          </a:p>
+        </p:txBody>
+      </p:sp>
+      <p:sp>
+        <p:nvSpPr>
+          <p:cNvPr id="6" name="Rounded Rectangle 5"/>
+          <p:cNvSpPr/>
+          <p:nvPr/>
+        </p:nvSpPr>
+        <p:spPr>
+          <a:xfrm>
+            <a:off x="6217920" y="3840480"/>
+            <a:ext cx="5120640" cy="2011680"/>
+          </a:xfrm>
+          <a:prstGeom prst="roundRect">
+            <a:avLst/>
+          </a:prstGeom>
+          <a:solidFill>
+            <a:srgbClr val="1E293B"/>
+          </a:solidFill>
+          <a:ln>
+            <a:solidFill>
+              <a:srgbClr val="38BDF8"/>
+            </a:solidFill>
+          </a:ln>
+        </p:spPr>
+        <p:style>
+          <a:lnRef idx="1">
+            <a:schemeClr val="accent1"/>
+          </a:lnRef>
+          <a:fillRef idx="3">
+            <a:schemeClr val="accent1"/>
+          </a:fillRef>
+          <a:effectRef idx="2">
+            <a:schemeClr val="accent1"/>
+          </a:effectRef>
+          <a:fontRef idx="minor">
+            <a:schemeClr val="lt1"/>
+          </a:fontRef>
+        </p:style>
+        <p:txBody>
+          <a:bodyPr rtlCol="0" anchor="ctr" wrap="square" tIns="137160"/>
+          <a:lstStyle/>
+          <a:p>
+            <a:pPr algn="ctr">
+              <a:spcAft>
+                <a:spcPts val="800"/>
+              </a:spcAft>
+              <a:defRPr sz="1600" b="1">
+                <a:solidFill>
+                  <a:srgbClr val="FFFFFF"/>
+                </a:solidFill>
+                <a:latin typeface="Segoe UI"/>
+              </a:defRPr>
+            </a:pPr>
+            <a:r>
+              <a:t>🆘 RoadSOS Emergency Controller</a:t>
+            </a:r>
+          </a:p>
+          <a:p>
+            <a:pPr>
+              <a:defRPr sz="1200">
+                <a:solidFill>
+                  <a:srgbClr val="94A3B8"/>
+                </a:solidFill>
+                <a:latin typeface="Segoe UI"/>
+              </a:defRPr>
+            </a:pPr>
+            <a:r>
+              <a:t>GPS telemetry tracker locks precise coordinates. Displays immediate emergency dials, trauma center proximities, and custom full-screen alarm dispatch overlay panels.</a:t>
+            </a:r>
+          </a:p>
+        </p:txBody>
+      </p:sp>
+    </p:spTree>
+  </p:cSld>
+  <p:clrMapOvr>
+    <a:masterClrMapping/>
+  </p:clrMapOvr>
+</p:sld>
+</file>
+
+<file path=ppt/slides/slide12.xml><?xml version="1.0" encoding="utf-8"?>
+<p:sld xmlns:a="http://schemas.openxmlformats.org/drawingml/2006/main" xmlns:p="http://schemas.openxmlformats.org/presentationml/2006/main" xmlns:r="http://schemas.openxmlformats.org/officeDocument/2006/relationships">
+  <p:cSld>
+    <p:spTree>
+      <p:nvGrpSpPr>
+        <p:cNvPr id="1" name=""/>
+        <p:cNvGrpSpPr/>
+        <p:nvPr/>
+      </p:nvGrpSpPr>
+      <p:grpSpPr/>
+      <p:sp>
+        <p:nvSpPr>
+          <p:cNvPr id="2" name="Title 1"/>
+          <p:cNvSpPr>
+            <a:spLocks noGrp="1"/>
+          </p:cNvSpPr>
+          <p:nvPr>
+            <p:ph type="title"/>
+          </p:nvPr>
+        </p:nvSpPr>
+        <p:spPr/>
+        <p:txBody>
+          <a:bodyPr/>
+          <a:lstStyle/>
+          <a:p>
+            <a:pPr>
+              <a:defRPr sz="2800" b="1">
+                <a:solidFill>
+                  <a:srgbClr val="FFFFFF"/>
+                </a:solidFill>
+              </a:defRPr>
+            </a:pPr>
+            <a:r>
+              <a:t>VISUAL HUD: OBSERVABILITY &amp; 10-CITY ANALYTICS</a:t>
+            </a:r>
+          </a:p>
+        </p:txBody>
+      </p:sp>
+      <p:sp>
+        <p:nvSpPr>
+          <p:cNvPr id="3" name="TextBox 2"/>
+          <p:cNvSpPr txBox="1"/>
+          <p:nvPr/>
+        </p:nvSpPr>
+        <p:spPr>
+          <a:xfrm>
+            <a:off x="731520" y="1371600"/>
+            <a:ext cx="10698480" cy="1097280"/>
+          </a:xfrm>
+          <a:prstGeom prst="rect">
+            <a:avLst/>
+          </a:prstGeom>
+          <a:noFill/>
+        </p:spPr>
+        <p:txBody>
+          <a:bodyPr wrap="square">
+            <a:spAutoFit/>
+          </a:bodyPr>
+          <a:lstStyle/>
+          <a:p>
+            <a:pPr>
+              <a:defRPr sz="1400">
+                <a:solidFill>
+                  <a:srgbClr val="94A3B8"/>
+                </a:solidFill>
+              </a:defRPr>
+            </a:pPr>
+            <a:r>
+              <a:t>Advanced telemetry dashboard with chronological NoSQL live stream, and dynamic comparative metrics for Nagpur, Mumbai, Pune, Delhi, Hyderabad, Bangalore, Chennai, Ahmedabad, Kolkata, and Jaipur.</a:t>
+            </a:r>
+          </a:p>
+        </p:txBody>
+      </p:sp>
+      <p:pic>
+        <p:nvPicPr>
+          <p:cNvPr id="4" name="Picture 3" descr="raastasense_observability_settings.png"/>
+          <p:cNvPicPr>
+            <a:picLocks noChangeAspect="1"/>
+          </p:cNvPicPr>
+          <p:nvPr/>
+        </p:nvPicPr>
+        <p:blipFill>
+          <a:blip r:embed="rId2"/>
+          <a:stretch>
+            <a:fillRect/>
+          </a:stretch>
+        </p:blipFill>
+        <p:spPr>
+          <a:xfrm>
+            <a:off x="2798064" y="2468880"/>
+            <a:ext cx="6583680" cy="3840480"/>
+          </a:xfrm>
+          <a:prstGeom prst="rect">
+            <a:avLst/>
+          </a:prstGeom>
+        </p:spPr>
+      </p:pic>
+    </p:spTree>
+  </p:cSld>
+  <p:clrMapOvr>
+    <a:masterClrMapping/>
+  </p:clrMapOvr>
+</p:sld>
+</file>
+
+<file path=ppt/slides/slide13.xml><?xml version="1.0" encoding="utf-8"?>
+<p:sld xmlns:a="http://schemas.openxmlformats.org/drawingml/2006/main" xmlns:p="http://schemas.openxmlformats.org/presentationml/2006/main" xmlns:r="http://schemas.openxmlformats.org/officeDocument/2006/relationships">
+  <p:cSld>
+    <p:spTree>
+      <p:nvGrpSpPr>
+        <p:cNvPr id="1" name=""/>
+        <p:cNvGrpSpPr/>
+        <p:nvPr/>
+      </p:nvGrpSpPr>
+      <p:grpSpPr/>
+      <p:sp>
+        <p:nvSpPr>
+          <p:cNvPr id="2" name="Title 1"/>
+          <p:cNvSpPr>
+            <a:spLocks noGrp="1"/>
+          </p:cNvSpPr>
+          <p:nvPr>
+            <p:ph type="title"/>
+          </p:nvPr>
+        </p:nvSpPr>
+        <p:spPr/>
+        <p:txBody>
+          <a:bodyPr/>
+          <a:lstStyle/>
+          <a:p>
+            <a:pPr>
+              <a:defRPr sz="2800" b="1">
+                <a:solidFill>
+                  <a:srgbClr val="FFFFFF"/>
+                </a:solidFill>
+              </a:defRPr>
+            </a:pPr>
+            <a:r>
+              <a:t>VISUAL HUD: DIGITAL TWIN MAPPING ENGINE</a:t>
+            </a:r>
+          </a:p>
+        </p:txBody>
+      </p:sp>
+      <p:sp>
+        <p:nvSpPr>
+          <p:cNvPr id="3" name="TextBox 2"/>
+          <p:cNvSpPr txBox="1"/>
+          <p:nvPr/>
+        </p:nvSpPr>
+        <p:spPr>
+          <a:xfrm>
+            <a:off x="731520" y="1371600"/>
+            <a:ext cx="10698480" cy="1097280"/>
+          </a:xfrm>
+          <a:prstGeom prst="rect">
+            <a:avLst/>
+          </a:prstGeom>
+          <a:noFill/>
+        </p:spPr>
+        <p:txBody>
+          <a:bodyPr wrap="square">
+            <a:spAutoFit/>
+          </a:bodyPr>
+          <a:lstStyle/>
+          <a:p>
+            <a:pPr>
+              <a:defRPr sz="1400">
+                <a:solidFill>
+                  <a:srgbClr val="94A3B8"/>
+                </a:solidFill>
+              </a:defRPr>
+            </a:pPr>
+            <a:r>
+              <a:t>Cyberslate GIS Interface demonstrating safest, fastest, eco-friendly, and emergency vehicle routing paths, dynamic coordinates telemetry, and active incident report layers.</a:t>
+            </a:r>
+          </a:p>
+        </p:txBody>
+      </p:sp>
+      <p:pic>
+        <p:nvPicPr>
+          <p:cNvPr id="4" name="Picture 3" descr="raastasense_route_engine.png"/>
+          <p:cNvPicPr>
+            <a:picLocks noChangeAspect="1"/>
+          </p:cNvPicPr>
+          <p:nvPr/>
+        </p:nvPicPr>
+        <p:blipFill>
+          <a:blip r:embed="rId2"/>
+          <a:stretch>
+            <a:fillRect/>
+          </a:stretch>
+        </p:blipFill>
+        <p:spPr>
+          <a:xfrm>
+            <a:off x="2798064" y="2468880"/>
+            <a:ext cx="6583680" cy="3840480"/>
+          </a:xfrm>
+          <a:prstGeom prst="rect">
+            <a:avLst/>
+          </a:prstGeom>
+        </p:spPr>
+      </p:pic>
+    </p:spTree>
+  </p:cSld>
+  <p:clrMapOvr>
+    <a:masterClrMapping/>
+  </p:clrMapOvr>
+</p:sld>
+</file>
+
+<file path=ppt/slides/slide14.xml><?xml version="1.0" encoding="utf-8"?>
+<p:sld xmlns:a="http://schemas.openxmlformats.org/drawingml/2006/main" xmlns:p="http://schemas.openxmlformats.org/presentationml/2006/main" xmlns:r="http://schemas.openxmlformats.org/officeDocument/2006/relationships">
+  <p:cSld>
+    <p:bg>
+      <p:bgPr>
+        <a:solidFill>
+          <a:srgbClr val="0F172A"/>
+        </a:solidFill>
+        <a:effectLst/>
+      </p:bgPr>
+    </p:bg>
+    <p:spTree>
+      <p:nvGrpSpPr>
+        <p:cNvPr id="1" name=""/>
+        <p:cNvGrpSpPr/>
+        <p:nvPr/>
+      </p:nvGrpSpPr>
+      <p:grpSpPr/>
+      <p:sp>
+        <p:nvSpPr>
+          <p:cNvPr id="2" name="TextBox 1"/>
+          <p:cNvSpPr txBox="1"/>
+          <p:nvPr/>
+        </p:nvSpPr>
+        <p:spPr>
+          <a:xfrm>
+            <a:off x="731520" y="457200"/>
+            <a:ext cx="10698480" cy="731520"/>
+          </a:xfrm>
+          <a:prstGeom prst="rect">
+            <a:avLst/>
+          </a:prstGeom>
+          <a:noFill/>
+        </p:spPr>
+        <p:txBody>
+          <a:bodyPr wrap="none">
+            <a:spAutoFit/>
+          </a:bodyPr>
+          <a:lstStyle/>
+          <a:p>
+            <a:pPr>
+              <a:defRPr sz="2800" b="1">
+                <a:solidFill>
+                  <a:srgbClr val="FFFFFF"/>
+                </a:solidFill>
+                <a:latin typeface="Segoe UI"/>
+              </a:defRPr>
+            </a:pPr>
+            <a:r>
+              <a:t>SYSTEM ARCHITECTURE &amp; OBSERVABILITY HUD</a:t>
+            </a:r>
+          </a:p>
+        </p:txBody>
+      </p:sp>
+      <p:sp>
+        <p:nvSpPr>
+          <p:cNvPr id="3" name="Rounded Rectangle 2"/>
+          <p:cNvSpPr/>
+          <p:nvPr/>
+        </p:nvSpPr>
+        <p:spPr>
+          <a:xfrm>
+            <a:off x="731520" y="1463040"/>
+            <a:ext cx="5120640" cy="4389120"/>
+          </a:xfrm>
+          <a:prstGeom prst="roundRect">
+            <a:avLst/>
+          </a:prstGeom>
+          <a:solidFill>
+            <a:srgbClr val="1E293B"/>
+          </a:solidFill>
+          <a:ln w="19050">
+            <a:solidFill>
+              <a:srgbClr val="38BDF8"/>
+            </a:solidFill>
+          </a:ln>
+        </p:spPr>
+        <p:style>
+          <a:lnRef idx="1">
+            <a:schemeClr val="accent1"/>
+          </a:lnRef>
+          <a:fillRef idx="3">
+            <a:schemeClr val="accent1"/>
+          </a:fillRef>
+          <a:effectRef idx="2">
+            <a:schemeClr val="accent1"/>
+          </a:effectRef>
+          <a:fontRef idx="minor">
+            <a:schemeClr val="lt1"/>
+          </a:fontRef>
+        </p:style>
+        <p:txBody>
+          <a:bodyPr rtlCol="0" anchor="ctr" wrap="square" tIns="274320"/>
+          <a:lstStyle/>
+          <a:p>
+            <a:pPr algn="ctr">
+              <a:spcAft>
+                <a:spcPts val="1800"/>
+              </a:spcAft>
+              <a:defRPr sz="2000" b="1">
+                <a:solidFill>
+                  <a:srgbClr val="FFFFFF"/>
+                </a:solidFill>
+                <a:latin typeface="Segoe UI"/>
+              </a:defRPr>
+            </a:pPr>
+            <a:r>
+              <a:t>⚙️ Full-Stack Pipeline Architecture</a:t>
+            </a:r>
+          </a:p>
+          <a:p>
+            <a:pPr>
+              <a:defRPr sz="1300">
+                <a:solidFill>
+                  <a:srgbClr val="94A3B8"/>
+                </a:solidFill>
+                <a:latin typeface="Segoe UI"/>
+              </a:defRPr>
+            </a:pPr>
+            <a:r>
+              <a:t>• Client Tier: React 18, Vite, Tailwind CSS, Framer Motion, and custom vector SVGs.</a:t>
+            </a:r>
+            <a:br/>
+            <a:br/>
+            <a:r>
+              <a:t>• Map/GIS Layer: OpenStreetMap integrations, polyline vector algorithms, dynamic marker overlays.</a:t>
+            </a:r>
+            <a:br/>
+            <a:br/>
+            <a:r>
+              <a:t>• Backend &amp; Database: Node.js, Express, mock-telemetry sensor algorithms.</a:t>
+            </a:r>
+            <a:br/>
+            <a:br/>
+            <a:r>
+              <a:t>• AI Core: Google Vision API pothole pixel scanner &amp; safety chatbot fallbacks.</a:t>
+            </a:r>
+          </a:p>
+        </p:txBody>
+      </p:sp>
+      <p:sp>
+        <p:nvSpPr>
+          <p:cNvPr id="4" name="Rounded Rectangle 3"/>
+          <p:cNvSpPr/>
+          <p:nvPr/>
+        </p:nvSpPr>
+        <p:spPr>
+          <a:xfrm>
+            <a:off x="6217920" y="1463040"/>
+            <a:ext cx="5120640" cy="4389120"/>
+          </a:xfrm>
+          <a:prstGeom prst="roundRect">
+            <a:avLst/>
+          </a:prstGeom>
+          <a:solidFill>
+            <a:srgbClr val="1E293B"/>
+          </a:solidFill>
+          <a:ln w="19050">
+            <a:solidFill>
+              <a:srgbClr val="F59E0B"/>
+            </a:solidFill>
+          </a:ln>
+        </p:spPr>
+        <p:style>
+          <a:lnRef idx="1">
+            <a:schemeClr val="accent1"/>
+          </a:lnRef>
+          <a:fillRef idx="3">
+            <a:schemeClr val="accent1"/>
+          </a:fillRef>
+          <a:effectRef idx="2">
+            <a:schemeClr val="accent1"/>
+          </a:effectRef>
+          <a:fontRef idx="minor">
+            <a:schemeClr val="lt1"/>
+          </a:fontRef>
+        </p:style>
+        <p:txBody>
+          <a:bodyPr rtlCol="0" anchor="ctr" wrap="square" tIns="274320"/>
+          <a:lstStyle/>
+          <a:p>
+            <a:pPr>
+              <a:defRPr sz="1200">
+                <a:solidFill>
+                  <a:srgbClr val="E2E8F0"/>
+                </a:solidFill>
+              </a:defRPr>
+            </a:pPr>
+            <a:r>
+              <a:t>📊 10-City Analytics &amp; Observability HUD</a:t>
+            </a:r>
+          </a:p>
+          <a:p>
+            <a:pPr>
+              <a:defRPr sz="1200">
+                <a:solidFill>
+                  <a:srgbClr val="E2E8F0"/>
+                </a:solidFill>
+              </a:defRPr>
+            </a:pPr>
+            <a:r>
+              <a:t>Dynamic comparison console tracking safety scores, accident rates, road quality, and response times for 10 major metropolitan districts.</a:t>
+            </a:r>
+          </a:p>
+        </p:txBody>
+      </p:sp>
+    </p:spTree>
+  </p:cSld>
+  <p:clrMapOvr>
+    <a:masterClrMapping/>
+  </p:clrMapOvr>
+</p:sld>
+</file>
+
+<file path=ppt/slides/slide15.xml><?xml version="1.0" encoding="utf-8"?>
+<p:sld xmlns:a="http://schemas.openxmlformats.org/drawingml/2006/main" xmlns:p="http://schemas.openxmlformats.org/presentationml/2006/main" xmlns:r="http://schemas.openxmlformats.org/officeDocument/2006/relationships">
+  <p:cSld>
+    <p:spTree>
+      <p:nvGrpSpPr>
+        <p:cNvPr id="1" name=""/>
+        <p:cNvGrpSpPr/>
+        <p:nvPr/>
+      </p:nvGrpSpPr>
+      <p:grpSpPr/>
+      <p:sp>
+        <p:nvSpPr>
+          <p:cNvPr id="2" name="Title 1"/>
+          <p:cNvSpPr>
+            <a:spLocks noGrp="1"/>
+          </p:cNvSpPr>
+          <p:nvPr>
+            <p:ph type="title"/>
+          </p:nvPr>
+        </p:nvSpPr>
+        <p:spPr/>
+        <p:txBody>
+          <a:bodyPr/>
+          <a:lstStyle/>
+          <a:p>
+            <a:pPr>
+              <a:defRPr sz="2800" b="1">
+                <a:solidFill>
+                  <a:srgbClr val="FFFFFF"/>
+                </a:solidFill>
+              </a:defRPr>
+            </a:pPr>
+            <a:r>
+              <a:t>VISUAL HUD: OBSERVABILITY &amp; 10-CITY ANALYTICS</a:t>
+            </a:r>
+          </a:p>
+        </p:txBody>
+      </p:sp>
+      <p:sp>
+        <p:nvSpPr>
+          <p:cNvPr id="3" name="TextBox 2"/>
+          <p:cNvSpPr txBox="1"/>
+          <p:nvPr/>
+        </p:nvSpPr>
+        <p:spPr>
+          <a:xfrm>
+            <a:off x="731520" y="1371600"/>
+            <a:ext cx="10698480" cy="1097280"/>
+          </a:xfrm>
+          <a:prstGeom prst="rect">
+            <a:avLst/>
+          </a:prstGeom>
+          <a:noFill/>
+        </p:spPr>
+        <p:txBody>
+          <a:bodyPr wrap="square">
+            <a:spAutoFit/>
+          </a:bodyPr>
+          <a:lstStyle/>
+          <a:p>
+            <a:pPr>
+              <a:defRPr sz="1400">
+                <a:solidFill>
+                  <a:srgbClr val="94A3B8"/>
+                </a:solidFill>
+              </a:defRPr>
+            </a:pPr>
+            <a:r>
+              <a:t>Advanced telemetry dashboard with chronological NoSQL live stream, and dynamic comparative metrics for Nagpur, Mumbai, Pune, Delhi, Hyderabad, Bangalore, Chennai, Ahmedabad, Kolkata, and Jaipur.</a:t>
+            </a:r>
+          </a:p>
+        </p:txBody>
+      </p:sp>
+      <p:pic>
+        <p:nvPicPr>
+          <p:cNvPr id="4" name="Picture 3" descr="raastasense_observability_settings.png"/>
+          <p:cNvPicPr>
+            <a:picLocks noChangeAspect="1"/>
+          </p:cNvPicPr>
+          <p:nvPr/>
+        </p:nvPicPr>
+        <p:blipFill>
+          <a:blip r:embed="rId2"/>
+          <a:stretch>
+            <a:fillRect/>
+          </a:stretch>
+        </p:blipFill>
+        <p:spPr>
+          <a:xfrm>
+            <a:off x="2798064" y="2468880"/>
+            <a:ext cx="6583680" cy="3840480"/>
+          </a:xfrm>
+          <a:prstGeom prst="rect">
+            <a:avLst/>
+          </a:prstGeom>
+        </p:spPr>
+      </p:pic>
+    </p:spTree>
+  </p:cSld>
+  <p:clrMapOvr>
+    <a:masterClrMapping/>
+  </p:clrMapOvr>
+</p:sld>
+</file>
+
+<file path=ppt/slides/slide16.xml><?xml version="1.0" encoding="utf-8"?>
+<p:sld xmlns:a="http://schemas.openxmlformats.org/drawingml/2006/main" xmlns:p="http://schemas.openxmlformats.org/presentationml/2006/main" xmlns:r="http://schemas.openxmlformats.org/officeDocument/2006/relationships">
+  <p:cSld>
+    <p:bg>
+      <p:bgPr>
+        <a:solidFill>
+          <a:srgbClr val="0F172A"/>
+        </a:solidFill>
+        <a:effectLst/>
+      </p:bgPr>
+    </p:bg>
+    <p:spTree>
+      <p:nvGrpSpPr>
+        <p:cNvPr id="1" name=""/>
+        <p:cNvGrpSpPr/>
+        <p:nvPr/>
+      </p:nvGrpSpPr>
+      <p:grpSpPr/>
+      <p:sp>
+        <p:nvSpPr>
+          <p:cNvPr id="2" name="TextBox 1"/>
+          <p:cNvSpPr txBox="1"/>
+          <p:nvPr/>
+        </p:nvSpPr>
+        <p:spPr>
+          <a:xfrm>
+            <a:off x="731520" y="457200"/>
+            <a:ext cx="10698480" cy="731520"/>
+          </a:xfrm>
+          <a:prstGeom prst="rect">
+            <a:avLst/>
+          </a:prstGeom>
+          <a:noFill/>
+        </p:spPr>
+        <p:txBody>
+          <a:bodyPr wrap="none">
+            <a:spAutoFit/>
+          </a:bodyPr>
+          <a:lstStyle/>
+          <a:p>
+            <a:pPr>
+              <a:defRPr sz="2800" b="1">
+                <a:solidFill>
+                  <a:srgbClr val="38BDF8"/>
+                </a:solidFill>
+                <a:latin typeface="Segoe UI"/>
+              </a:defRPr>
+            </a:pPr>
+            <a:r>
+              <a:t>MEASURED SOCIETAL &amp; CIVIC IMPACT</a:t>
+            </a:r>
+          </a:p>
+        </p:txBody>
+      </p:sp>
+      <p:sp>
+        <p:nvSpPr>
+          <p:cNvPr id="3" name="Rounded Rectangle 2"/>
+          <p:cNvSpPr/>
+          <p:nvPr/>
+        </p:nvSpPr>
+        <p:spPr>
+          <a:xfrm>
+            <a:off x="731520" y="1645920"/>
+            <a:ext cx="3291840" cy="4114800"/>
+          </a:xfrm>
+          <a:prstGeom prst="roundRect">
+            <a:avLst/>
+          </a:prstGeom>
+          <a:solidFill>
+            <a:srgbClr val="1E293B"/>
+          </a:solidFill>
+          <a:ln>
+            <a:solidFill>
+              <a:srgbClr val="38BDF8"/>
+            </a:solidFill>
+          </a:ln>
+        </p:spPr>
+        <p:style>
+          <a:lnRef idx="1">
+            <a:schemeClr val="accent1"/>
+          </a:lnRef>
+          <a:fillRef idx="3">
+            <a:schemeClr val="accent1"/>
+          </a:fillRef>
+          <a:effectRef idx="2">
+            <a:schemeClr val="accent1"/>
+          </a:effectRef>
+          <a:fontRef idx="minor">
+            <a:schemeClr val="lt1"/>
+          </a:fontRef>
+        </p:style>
+        <p:txBody>
+          <a:bodyPr rtlCol="0" anchor="ctr" wrap="square" tIns="274320"/>
+          <a:lstStyle/>
+          <a:p>
+            <a:pPr algn="ctr">
+              <a:spcAft>
+                <a:spcPts val="1400"/>
+              </a:spcAft>
+              <a:defRPr sz="1800" b="1">
+                <a:solidFill>
+                  <a:srgbClr val="FFFFFF"/>
+                </a:solidFill>
+                <a:latin typeface="Segoe UI"/>
+              </a:defRPr>
+            </a:pPr>
+            <a:r>
+              <a:t>🚲 Citizens</a:t>
+            </a:r>
+          </a:p>
+          <a:p>
+            <a:pPr>
+              <a:defRPr sz="1300">
+                <a:solidFill>
+                  <a:srgbClr val="94A3B8"/>
+                </a:solidFill>
+                <a:latin typeface="Segoe UI"/>
+              </a:defRPr>
+            </a:pPr>
+            <a:r>
+              <a:t>Safe routing guidelines keep travelers out of congestion/danger zones. Regional DriveLegal counselor builds critical legal self-awareness.</a:t>
+            </a:r>
+          </a:p>
+        </p:txBody>
+      </p:sp>
+      <p:sp>
+        <p:nvSpPr>
+          <p:cNvPr id="4" name="Rounded Rectangle 3"/>
+          <p:cNvSpPr/>
+          <p:nvPr/>
+        </p:nvSpPr>
+        <p:spPr>
+          <a:xfrm>
+            <a:off x="4389120" y="1645920"/>
+            <a:ext cx="3291840" cy="4114800"/>
+          </a:xfrm>
+          <a:prstGeom prst="roundRect">
+            <a:avLst/>
+          </a:prstGeom>
+          <a:solidFill>
+            <a:srgbClr val="1E293B"/>
+          </a:solidFill>
+          <a:ln>
+            <a:solidFill>
+              <a:srgbClr val="F59E0B"/>
+            </a:solidFill>
+          </a:ln>
+        </p:spPr>
+        <p:style>
+          <a:lnRef idx="1">
+            <a:schemeClr val="accent1"/>
+          </a:lnRef>
+          <a:fillRef idx="3">
+            <a:schemeClr val="accent1"/>
+          </a:fillRef>
+          <a:effectRef idx="2">
+            <a:schemeClr val="accent1"/>
+          </a:effectRef>
+          <a:fontRef idx="minor">
+            <a:schemeClr val="lt1"/>
+          </a:fontRef>
+        </p:style>
+        <p:txBody>
+          <a:bodyPr rtlCol="0" anchor="ctr" wrap="square" tIns="274320"/>
+          <a:lstStyle/>
+          <a:p>
+            <a:pPr algn="ctr">
+              <a:spcAft>
+                <a:spcPts val="1400"/>
+              </a:spcAft>
+              <a:defRPr sz="1800" b="1">
+                <a:solidFill>
+                  <a:srgbClr val="FFFFFF"/>
+                </a:solidFill>
+                <a:latin typeface="Segoe UI"/>
+              </a:defRPr>
+            </a:pPr>
+            <a:r>
+              <a:t>👮 Municipalities</a:t>
+            </a:r>
+          </a:p>
+          <a:p>
+            <a:pPr>
+              <a:defRPr sz="1300">
+                <a:solidFill>
+                  <a:srgbClr val="94A3B8"/>
+                </a:solidFill>
+                <a:latin typeface="Segoe UI"/>
+              </a:defRPr>
+            </a:pPr>
+            <a:r>
+              <a:t>RoadWatch community dashboards create transparency in public infrastructure spending, pothole repair trails, and automated violation reporting.</a:t>
+            </a:r>
+          </a:p>
+        </p:txBody>
+      </p:sp>
+      <p:sp>
+        <p:nvSpPr>
+          <p:cNvPr id="5" name="Rounded Rectangle 4"/>
+          <p:cNvSpPr/>
+          <p:nvPr/>
+        </p:nvSpPr>
+        <p:spPr>
+          <a:xfrm>
+            <a:off x="8046720" y="1645920"/>
+            <a:ext cx="3291840" cy="4114800"/>
+          </a:xfrm>
+          <a:prstGeom prst="roundRect">
+            <a:avLst/>
+          </a:prstGeom>
+          <a:solidFill>
+            <a:srgbClr val="1E293B"/>
+          </a:solidFill>
+          <a:ln>
+            <a:solidFill>
+              <a:srgbClr val="F43F5E"/>
+            </a:solidFill>
+          </a:ln>
+        </p:spPr>
+        <p:style>
+          <a:lnRef idx="1">
+            <a:schemeClr val="accent1"/>
+          </a:lnRef>
+          <a:fillRef idx="3">
+            <a:schemeClr val="accent1"/>
+          </a:fillRef>
+          <a:effectRef idx="2">
+            <a:schemeClr val="accent1"/>
+          </a:effectRef>
+          <a:fontRef idx="minor">
+            <a:schemeClr val="lt1"/>
+          </a:fontRef>
+        </p:style>
+        <p:txBody>
+          <a:bodyPr rtlCol="0" anchor="ctr" wrap="square" tIns="274320"/>
+          <a:lstStyle/>
+          <a:p>
+            <a:pPr algn="ctr">
+              <a:spcAft>
+                <a:spcPts val="1400"/>
+              </a:spcAft>
+              <a:defRPr sz="1800" b="1">
+                <a:solidFill>
+                  <a:srgbClr val="FFFFFF"/>
+                </a:solidFill>
+                <a:latin typeface="Segoe UI"/>
+              </a:defRPr>
+            </a:pPr>
+            <a:r>
+              <a:t>🚑 Responders</a:t>
+            </a:r>
+          </a:p>
+          <a:p>
+            <a:pPr>
+              <a:defRPr sz="1300">
+                <a:solidFill>
+                  <a:srgbClr val="94A3B8"/>
+                </a:solidFill>
+                <a:latin typeface="Segoe UI"/>
+              </a:defRPr>
+            </a:pPr>
+            <a:r>
+              <a:t>RoadSOS beacon coordinates lock directly on responder navigation units, slicing dispatch delays and securing the critical Golden Hour rescue frame.</a:t>
+            </a:r>
+          </a:p>
+        </p:txBody>
+      </p:sp>
+    </p:spTree>
+  </p:cSld>
+  <p:clrMapOvr>
+    <a:masterClrMapping/>
+  </p:clrMapOvr>
+</p:sld>
+</file>
+
+<file path=ppt/slides/slide17.xml><?xml version="1.0" encoding="utf-8"?>
+<p:sld xmlns:a="http://schemas.openxmlformats.org/drawingml/2006/main" xmlns:p="http://schemas.openxmlformats.org/presentationml/2006/main" xmlns:r="http://schemas.openxmlformats.org/officeDocument/2006/relationships">
+  <p:cSld>
+    <p:bg>
+      <p:bgPr>
+        <a:solidFill>
+          <a:srgbClr val="0F172A"/>
+        </a:solidFill>
+        <a:effectLst/>
+      </p:bgPr>
+    </p:bg>
+    <p:spTree>
+      <p:nvGrpSpPr>
+        <p:cNvPr id="1" name=""/>
+        <p:cNvGrpSpPr/>
+        <p:nvPr/>
+      </p:nvGrpSpPr>
+      <p:grpSpPr/>
+      <p:sp>
+        <p:nvSpPr>
+          <p:cNvPr id="2" name="TextBox 1"/>
+          <p:cNvSpPr txBox="1"/>
+          <p:nvPr/>
+        </p:nvSpPr>
+        <p:spPr>
+          <a:xfrm>
+            <a:off x="822960" y="1097280"/>
+            <a:ext cx="10515600" cy="4572000"/>
+          </a:xfrm>
+          <a:prstGeom prst="rect">
+            <a:avLst/>
+          </a:prstGeom>
+          <a:noFill/>
+        </p:spPr>
+        <p:txBody>
+          <a:bodyPr wrap="square">
+            <a:spAutoFit/>
+          </a:bodyPr>
+          <a:lstStyle/>
+          <a:p>
+            <a:pPr algn="ctr">
+              <a:spcAft>
+                <a:spcPts val="1400"/>
+              </a:spcAft>
+              <a:defRPr sz="6400" b="1">
+                <a:solidFill>
+                  <a:srgbClr val="38BDF8"/>
+                </a:solidFill>
+                <a:latin typeface="Segoe UI"/>
+              </a:defRPr>
+            </a:pPr>
+            <a:r>
+              <a:t>THANK YOU!</a:t>
+            </a:r>
+          </a:p>
+          <a:p>
+            <a:pPr algn="ctr">
+              <a:spcAft>
+                <a:spcPts val="4000"/>
+              </a:spcAft>
+              <a:defRPr sz="2000" b="1">
+                <a:solidFill>
+                  <a:srgbClr val="FFFFFF"/>
+                </a:solidFill>
+                <a:latin typeface="Segoe UI"/>
+              </a:defRPr>
+            </a:pPr>
+            <a:r>
+              <a:t>Join us in transforming Indian transit corridors, one life at a time.</a:t>
+            </a:r>
+          </a:p>
+          <a:p>
+            <a:pPr algn="ctr">
+              <a:spcAft>
+                <a:spcPts val="2000"/>
+              </a:spcAft>
+              <a:defRPr sz="1600" b="1">
+                <a:solidFill>
+                  <a:srgbClr val="F59E0B"/>
+                </a:solidFill>
+                <a:latin typeface="Consolas"/>
+              </a:defRPr>
+            </a:pPr>
+            <a:r>
+              <a:t>🌐 Interactive Live Demo: https://raastasense.vercel.app</a:t>
+            </a:r>
+            <a:br/>
+            <a:r>
+              <a:t>💻 Open-Source Codebase: https://github.com/Ajayrathod04/RaastaSense</a:t>
+            </a:r>
+          </a:p>
+        </p:txBody>
+      </p:sp>
+    </p:spTree>
+  </p:cSld>
+  <p:clrMapOvr>
+    <a:masterClrMapping/>
+  </p:clrMapOvr>
+</p:sld>
+</file>
+
+<file path=ppt/slides/slide18.xml><?xml version="1.0" encoding="utf-8"?>
+<p:sld xmlns:a="http://schemas.openxmlformats.org/drawingml/2006/main" xmlns:p="http://schemas.openxmlformats.org/presentationml/2006/main" xmlns:r="http://schemas.openxmlformats.org/officeDocument/2006/relationships">
+  <p:cSld>
+    <p:spTree>
+      <p:nvGrpSpPr>
+        <p:cNvPr id="1" name=""/>
+        <p:cNvGrpSpPr/>
+        <p:nvPr/>
+      </p:nvGrpSpPr>
+      <p:grpSpPr/>
+      <p:sp>
+        <p:nvSpPr>
+          <p:cNvPr id="2" name="Title 1"/>
+          <p:cNvSpPr>
+            <a:spLocks noGrp="1"/>
+          </p:cNvSpPr>
+          <p:nvPr>
+            <p:ph type="title"/>
+          </p:nvPr>
+        </p:nvSpPr>
+        <p:spPr/>
+        <p:txBody>
+          <a:bodyPr/>
+          <a:lstStyle/>
+          <a:p>
+            <a:pPr>
+              <a:defRPr sz="2800" b="1">
+                <a:solidFill>
+                  <a:srgbClr val="FFFFFF"/>
+                </a:solidFill>
+              </a:defRPr>
+            </a:pPr>
+            <a:r>
+              <a:t>TECHNICAL FLOW &amp; PIPELINE ARCHITECTURE</a:t>
+            </a:r>
+          </a:p>
+        </p:txBody>
+      </p:sp>
+      <p:sp>
+        <p:nvSpPr>
+          <p:cNvPr id="3" name="TextBox 2"/>
+          <p:cNvSpPr txBox="1"/>
+          <p:nvPr/>
+        </p:nvSpPr>
+        <p:spPr>
+          <a:xfrm>
+            <a:off x="731520" y="1371600"/>
+            <a:ext cx="10698480" cy="1097280"/>
+          </a:xfrm>
+          <a:prstGeom prst="rect">
+            <a:avLst/>
+          </a:prstGeom>
+          <a:noFill/>
+        </p:spPr>
+        <p:txBody>
+          <a:bodyPr wrap="square">
+            <a:spAutoFit/>
+          </a:bodyPr>
+          <a:lstStyle/>
+          <a:p>
+            <a:pPr>
+              <a:defRPr sz="1400">
+                <a:solidFill>
+                  <a:srgbClr val="94A3B8"/>
+                </a:solidFill>
+              </a:defRPr>
+            </a:pPr>
+            <a:r>
+              <a:t>High-fidelity technology stack showing full-stack Node.js Express connectivity, Leaflet GIS client telemetry interfaces, Google Vision classification, and Firebase sync streams.</a:t>
+            </a:r>
+          </a:p>
+        </p:txBody>
+      </p:sp>
+      <p:pic>
+        <p:nvPicPr>
+          <p:cNvPr id="4" name="Picture 3" descr="raastasense_system_architecture.png"/>
+          <p:cNvPicPr>
+            <a:picLocks noChangeAspect="1"/>
+          </p:cNvPicPr>
+          <p:nvPr/>
+        </p:nvPicPr>
+        <p:blipFill>
+          <a:blip r:embed="rId2"/>
+          <a:stretch>
+            <a:fillRect/>
+          </a:stretch>
+        </p:blipFill>
+        <p:spPr>
+          <a:xfrm>
+            <a:off x="2798064" y="2468880"/>
+            <a:ext cx="6583680" cy="3840480"/>
+          </a:xfrm>
+          <a:prstGeom prst="rect">
+            <a:avLst/>
+          </a:prstGeom>
+        </p:spPr>
+      </p:pic>
+    </p:spTree>
+  </p:cSld>
+  <p:clrMapOvr>
+    <a:masterClrMapping/>
+  </p:clrMapOvr>
+</p:sld>
+</file>
+
 <file path=ppt/slides/slide2.xml><?xml version="1.0" encoding="utf-8"?>
 <p:sld xmlns:a="http://schemas.openxmlformats.org/drawingml/2006/main" xmlns:p="http://schemas.openxmlformats.org/presentationml/2006/main" xmlns:r="http://schemas.openxmlformats.org/officeDocument/2006/relationships">
   <p:cSld>
@@ -3636,32 +5103,27 @@
           <a:bodyPr rtlCol="0" anchor="ctr" wrap="square" tIns="274320"/>
           <a:lstStyle/>
           <a:p>
-            <a:pPr algn="ctr">
-              <a:spcAft>
-                <a:spcPts val="1400"/>
-              </a:spcAft>
-              <a:defRPr sz="1800" b="1">
-                <a:solidFill>
-                  <a:srgbClr val="FFFFFF"/>
-                </a:solidFill>
-                <a:latin typeface="Segoe UI"/>
+            <a:pPr>
+              <a:defRPr sz="1200">
+                <a:solidFill>
+                  <a:srgbClr val="E2E8F0"/>
+                </a:solidFill>
               </a:defRPr>
             </a:pPr>
             <a:r>
-              <a:t>🛡️ AI Legal Advisor</a:t>
+              <a:t>🛡️ AI Guardian &amp; Legal Localizer</a:t>
             </a:r>
           </a:p>
           <a:p>
             <a:pPr>
-              <a:defRPr sz="1300">
-                <a:solidFill>
-                  <a:srgbClr val="94A3B8"/>
-                </a:solidFill>
-                <a:latin typeface="Segoe UI"/>
+              <a:defRPr sz="1200">
+                <a:solidFill>
+                  <a:srgbClr val="E2E8F0"/>
+                </a:solidFill>
               </a:defRPr>
             </a:pPr>
             <a:r>
-              <a:t>9-language custom localizer featuring automatic fine surcharges, legal index, and character dialogue advisory boards.</a:t>
+              <a:t>Custom 10-language localizer with state-specific fine surcharges, legal codes, and interactive driver voice/text counseling console.</a:t>
             </a:r>
           </a:p>
         </p:txBody>
@@ -3748,14 +5210,6 @@
 <file path=ppt/slides/slide4.xml><?xml version="1.0" encoding="utf-8"?>
 <p:sld xmlns:a="http://schemas.openxmlformats.org/drawingml/2006/main" xmlns:p="http://schemas.openxmlformats.org/presentationml/2006/main" xmlns:r="http://schemas.openxmlformats.org/officeDocument/2006/relationships">
   <p:cSld>
-    <p:bg>
-      <p:bgPr>
-        <a:solidFill>
-          <a:srgbClr val="0F172A"/>
-        </a:solidFill>
-        <a:effectLst/>
-      </p:bgPr>
-    </p:bg>
     <p:spTree>
       <p:nvGrpSpPr>
         <p:cNvPr id="1" name=""/>
@@ -3765,14 +5219,42 @@
       <p:grpSpPr/>
       <p:sp>
         <p:nvSpPr>
-          <p:cNvPr id="2" name="TextBox 1"/>
+          <p:cNvPr id="2" name="Title 1"/>
+          <p:cNvSpPr>
+            <a:spLocks noGrp="1"/>
+          </p:cNvSpPr>
+          <p:nvPr>
+            <p:ph type="title"/>
+          </p:nvPr>
+        </p:nvSpPr>
+        <p:spPr/>
+        <p:txBody>
+          <a:bodyPr/>
+          <a:lstStyle/>
+          <a:p>
+            <a:pPr>
+              <a:defRPr sz="2800" b="1">
+                <a:solidFill>
+                  <a:srgbClr val="FFFFFF"/>
+                </a:solidFill>
+              </a:defRPr>
+            </a:pPr>
+            <a:r>
+              <a:t>VISUAL HUD: AI SAFETY COCKPIT &amp; LIVE GUARDIAN</a:t>
+            </a:r>
+          </a:p>
+        </p:txBody>
+      </p:sp>
+      <p:sp>
+        <p:nvSpPr>
+          <p:cNvPr id="3" name="TextBox 2"/>
           <p:cNvSpPr txBox="1"/>
           <p:nvPr/>
         </p:nvSpPr>
         <p:spPr>
           <a:xfrm>
-            <a:off x="731520" y="457200"/>
-            <a:ext cx="10698480" cy="731520"/>
+            <a:off x="731520" y="1371600"/>
+            <a:ext cx="10698480" cy="1097280"/>
           </a:xfrm>
           <a:prstGeom prst="rect">
             <a:avLst/>
@@ -3780,309 +5262,48 @@
           <a:noFill/>
         </p:spPr>
         <p:txBody>
-          <a:bodyPr wrap="none">
+          <a:bodyPr wrap="square">
             <a:spAutoFit/>
           </a:bodyPr>
           <a:lstStyle/>
           <a:p>
             <a:pPr>
-              <a:defRPr sz="2800" b="1">
-                <a:solidFill>
-                  <a:srgbClr val="F59E0B"/>
-                </a:solidFill>
-                <a:latin typeface="Segoe UI"/>
+              <a:defRPr sz="1400">
+                <a:solidFill>
+                  <a:srgbClr val="94A3B8"/>
+                </a:solidFill>
               </a:defRPr>
             </a:pPr>
             <a:r>
-              <a:t>INTELLIGENT CORE ENGINE MODULES</a:t>
-            </a:r>
-          </a:p>
-        </p:txBody>
-      </p:sp>
-      <p:sp>
-        <p:nvSpPr>
-          <p:cNvPr id="3" name="Rounded Rectangle 2"/>
-          <p:cNvSpPr/>
+              <a:t>Real-time driver cockpit containing telemetry simulators, speedometer, and the pulsing AI Guardian mascot console with integrated 10-language localizer speech options.</a:t>
+            </a:r>
+          </a:p>
+        </p:txBody>
+      </p:sp>
+      <p:pic>
+        <p:nvPicPr>
+          <p:cNvPr id="4" name="Picture 3" descr="image.png"/>
+          <p:cNvPicPr>
+            <a:picLocks noChangeAspect="1"/>
+          </p:cNvPicPr>
           <p:nvPr/>
-        </p:nvSpPr>
-        <p:spPr>
-          <a:xfrm>
-            <a:off x="731520" y="1463040"/>
-            <a:ext cx="5120640" cy="2011680"/>
-          </a:xfrm>
-          <a:prstGeom prst="roundRect">
+        </p:nvPicPr>
+        <p:blipFill>
+          <a:blip r:embed="rId2"/>
+          <a:stretch>
+            <a:fillRect/>
+          </a:stretch>
+        </p:blipFill>
+        <p:spPr>
+          <a:xfrm>
+            <a:off x="2798064" y="2468880"/>
+            <a:ext cx="6583680" cy="3840480"/>
+          </a:xfrm>
+          <a:prstGeom prst="rect">
             <a:avLst/>
           </a:prstGeom>
-          <a:solidFill>
-            <a:srgbClr val="1E293B"/>
-          </a:solidFill>
-          <a:ln>
-            <a:solidFill>
-              <a:srgbClr val="38BDF8"/>
-            </a:solidFill>
-          </a:ln>
-        </p:spPr>
-        <p:style>
-          <a:lnRef idx="1">
-            <a:schemeClr val="accent1"/>
-          </a:lnRef>
-          <a:fillRef idx="3">
-            <a:schemeClr val="accent1"/>
-          </a:fillRef>
-          <a:effectRef idx="2">
-            <a:schemeClr val="accent1"/>
-          </a:effectRef>
-          <a:fontRef idx="minor">
-            <a:schemeClr val="lt1"/>
-          </a:fontRef>
-        </p:style>
-        <p:txBody>
-          <a:bodyPr rtlCol="0" anchor="ctr" wrap="square" tIns="137160"/>
-          <a:lstStyle/>
-          <a:p>
-            <a:pPr algn="ctr">
-              <a:spcAft>
-                <a:spcPts val="800"/>
-              </a:spcAft>
-              <a:defRPr sz="1600" b="1">
-                <a:solidFill>
-                  <a:srgbClr val="FFFFFF"/>
-                </a:solidFill>
-                <a:latin typeface="Segoe UI"/>
-              </a:defRPr>
-            </a:pPr>
-            <a:r>
-              <a:t>🚦 Safe Route Engine (Phase 8 Highlight)</a:t>
-            </a:r>
-          </a:p>
-          <a:p>
-            <a:pPr>
-              <a:defRPr sz="1200">
-                <a:solidFill>
-                  <a:srgbClr val="94A3B8"/>
-                </a:solidFill>
-                <a:latin typeface="Segoe UI"/>
-              </a:defRPr>
-            </a:pPr>
-            <a:r>
-              <a:t>Calculates Fastest, Safest, and Least Incident corridors. Displays Safety Indexes, weather/traffic conditions, and dynamic recommended overlays.</a:t>
-            </a:r>
-          </a:p>
-        </p:txBody>
-      </p:sp>
-      <p:sp>
-        <p:nvSpPr>
-          <p:cNvPr id="4" name="Rounded Rectangle 3"/>
-          <p:cNvSpPr/>
-          <p:nvPr/>
-        </p:nvSpPr>
-        <p:spPr>
-          <a:xfrm>
-            <a:off x="6217920" y="1463040"/>
-            <a:ext cx="5120640" cy="2011680"/>
-          </a:xfrm>
-          <a:prstGeom prst="roundRect">
-            <a:avLst/>
-          </a:prstGeom>
-          <a:solidFill>
-            <a:srgbClr val="1E293B"/>
-          </a:solidFill>
-          <a:ln>
-            <a:solidFill>
-              <a:srgbClr val="38BDF8"/>
-            </a:solidFill>
-          </a:ln>
-        </p:spPr>
-        <p:style>
-          <a:lnRef idx="1">
-            <a:schemeClr val="accent1"/>
-          </a:lnRef>
-          <a:fillRef idx="3">
-            <a:schemeClr val="accent1"/>
-          </a:fillRef>
-          <a:effectRef idx="2">
-            <a:schemeClr val="accent1"/>
-          </a:effectRef>
-          <a:fontRef idx="minor">
-            <a:schemeClr val="lt1"/>
-          </a:fontRef>
-        </p:style>
-        <p:txBody>
-          <a:bodyPr rtlCol="0" anchor="ctr" wrap="square" tIns="137160"/>
-          <a:lstStyle/>
-          <a:p>
-            <a:pPr algn="ctr">
-              <a:spcAft>
-                <a:spcPts val="800"/>
-              </a:spcAft>
-              <a:defRPr sz="1600" b="1">
-                <a:solidFill>
-                  <a:srgbClr val="FFFFFF"/>
-                </a:solidFill>
-                <a:latin typeface="Segoe UI"/>
-              </a:defRPr>
-            </a:pPr>
-            <a:r>
-              <a:t>⚖️ DriveLegal Regional Surcharges</a:t>
-            </a:r>
-          </a:p>
-          <a:p>
-            <a:pPr>
-              <a:defRPr sz="1200">
-                <a:solidFill>
-                  <a:srgbClr val="94A3B8"/>
-                </a:solidFill>
-                <a:latin typeface="Segoe UI"/>
-              </a:defRPr>
-            </a:pPr>
-            <a:r>
-              <a:t>Filters 6 main road safety codes. Instantly computes fine adjustments based on Indian State surcharges (TN, MH, KA) and delivers voice-synthesized guidelines.</a:t>
-            </a:r>
-          </a:p>
-        </p:txBody>
-      </p:sp>
-      <p:sp>
-        <p:nvSpPr>
-          <p:cNvPr id="5" name="Rounded Rectangle 4"/>
-          <p:cNvSpPr/>
-          <p:nvPr/>
-        </p:nvSpPr>
-        <p:spPr>
-          <a:xfrm>
-            <a:off x="731520" y="3840480"/>
-            <a:ext cx="5120640" cy="2011680"/>
-          </a:xfrm>
-          <a:prstGeom prst="roundRect">
-            <a:avLst/>
-          </a:prstGeom>
-          <a:solidFill>
-            <a:srgbClr val="1E293B"/>
-          </a:solidFill>
-          <a:ln>
-            <a:solidFill>
-              <a:srgbClr val="38BDF8"/>
-            </a:solidFill>
-          </a:ln>
-        </p:spPr>
-        <p:style>
-          <a:lnRef idx="1">
-            <a:schemeClr val="accent1"/>
-          </a:lnRef>
-          <a:fillRef idx="3">
-            <a:schemeClr val="accent1"/>
-          </a:fillRef>
-          <a:effectRef idx="2">
-            <a:schemeClr val="accent1"/>
-          </a:effectRef>
-          <a:fontRef idx="minor">
-            <a:schemeClr val="lt1"/>
-          </a:fontRef>
-        </p:style>
-        <p:txBody>
-          <a:bodyPr rtlCol="0" anchor="ctr" wrap="square" tIns="137160"/>
-          <a:lstStyle/>
-          <a:p>
-            <a:pPr algn="ctr">
-              <a:spcAft>
-                <a:spcPts val="800"/>
-              </a:spcAft>
-              <a:defRPr sz="1600" b="1">
-                <a:solidFill>
-                  <a:srgbClr val="FFFFFF"/>
-                </a:solidFill>
-                <a:latin typeface="Segoe UI"/>
-              </a:defRPr>
-            </a:pPr>
-            <a:r>
-              <a:t>📸 RoadWatch AI Incident Diagnostics</a:t>
-            </a:r>
-          </a:p>
-          <a:p>
-            <a:pPr>
-              <a:defRPr sz="1200">
-                <a:solidFill>
-                  <a:srgbClr val="94A3B8"/>
-                </a:solidFill>
-                <a:latin typeface="Segoe UI"/>
-              </a:defRPr>
-            </a:pPr>
-            <a:r>
-              <a:t>Citizen hazard submission portals. Features automatic AI-powered image diagnosis with calculated confidence matrices, severity metrics, and direct action protocols.</a:t>
-            </a:r>
-          </a:p>
-        </p:txBody>
-      </p:sp>
-      <p:sp>
-        <p:nvSpPr>
-          <p:cNvPr id="6" name="Rounded Rectangle 5"/>
-          <p:cNvSpPr/>
-          <p:nvPr/>
-        </p:nvSpPr>
-        <p:spPr>
-          <a:xfrm>
-            <a:off x="6217920" y="3840480"/>
-            <a:ext cx="5120640" cy="2011680"/>
-          </a:xfrm>
-          <a:prstGeom prst="roundRect">
-            <a:avLst/>
-          </a:prstGeom>
-          <a:solidFill>
-            <a:srgbClr val="1E293B"/>
-          </a:solidFill>
-          <a:ln>
-            <a:solidFill>
-              <a:srgbClr val="38BDF8"/>
-            </a:solidFill>
-          </a:ln>
-        </p:spPr>
-        <p:style>
-          <a:lnRef idx="1">
-            <a:schemeClr val="accent1"/>
-          </a:lnRef>
-          <a:fillRef idx="3">
-            <a:schemeClr val="accent1"/>
-          </a:fillRef>
-          <a:effectRef idx="2">
-            <a:schemeClr val="accent1"/>
-          </a:effectRef>
-          <a:fontRef idx="minor">
-            <a:schemeClr val="lt1"/>
-          </a:fontRef>
-        </p:style>
-        <p:txBody>
-          <a:bodyPr rtlCol="0" anchor="ctr" wrap="square" tIns="137160"/>
-          <a:lstStyle/>
-          <a:p>
-            <a:pPr algn="ctr">
-              <a:spcAft>
-                <a:spcPts val="800"/>
-              </a:spcAft>
-              <a:defRPr sz="1600" b="1">
-                <a:solidFill>
-                  <a:srgbClr val="FFFFFF"/>
-                </a:solidFill>
-                <a:latin typeface="Segoe UI"/>
-              </a:defRPr>
-            </a:pPr>
-            <a:r>
-              <a:t>🆘 RoadSOS Emergency Controller</a:t>
-            </a:r>
-          </a:p>
-          <a:p>
-            <a:pPr>
-              <a:defRPr sz="1200">
-                <a:solidFill>
-                  <a:srgbClr val="94A3B8"/>
-                </a:solidFill>
-                <a:latin typeface="Segoe UI"/>
-              </a:defRPr>
-            </a:pPr>
-            <a:r>
-              <a:t>GPS telemetry tracker locks precise coordinates. Displays immediate emergency dials, trauma center proximities, and custom full-screen alarm dispatch overlay panels.</a:t>
-            </a:r>
-          </a:p>
-        </p:txBody>
-      </p:sp>
+        </p:spPr>
+      </p:pic>
     </p:spTree>
   </p:cSld>
   <p:clrMapOvr>
@@ -4094,14 +5315,6 @@
 <file path=ppt/slides/slide5.xml><?xml version="1.0" encoding="utf-8"?>
 <p:sld xmlns:a="http://schemas.openxmlformats.org/drawingml/2006/main" xmlns:p="http://schemas.openxmlformats.org/presentationml/2006/main" xmlns:r="http://schemas.openxmlformats.org/officeDocument/2006/relationships">
   <p:cSld>
-    <p:bg>
-      <p:bgPr>
-        <a:solidFill>
-          <a:srgbClr val="0F172A"/>
-        </a:solidFill>
-        <a:effectLst/>
-      </p:bgPr>
-    </p:bg>
     <p:spTree>
       <p:nvGrpSpPr>
         <p:cNvPr id="1" name=""/>
@@ -4111,14 +5324,42 @@
       <p:grpSpPr/>
       <p:sp>
         <p:nvSpPr>
-          <p:cNvPr id="2" name="TextBox 1"/>
+          <p:cNvPr id="2" name="Title 1"/>
+          <p:cNvSpPr>
+            <a:spLocks noGrp="1"/>
+          </p:cNvSpPr>
+          <p:nvPr>
+            <p:ph type="title"/>
+          </p:nvPr>
+        </p:nvSpPr>
+        <p:spPr/>
+        <p:txBody>
+          <a:bodyPr/>
+          <a:lstStyle/>
+          <a:p>
+            <a:pPr>
+              <a:defRPr sz="2800" b="1">
+                <a:solidFill>
+                  <a:srgbClr val="FFFFFF"/>
+                </a:solidFill>
+              </a:defRPr>
+            </a:pPr>
+            <a:r>
+              <a:t>VISUAL HUD: AI GUARDIAN DIALOGUE SYSTEM</a:t>
+            </a:r>
+          </a:p>
+        </p:txBody>
+      </p:sp>
+      <p:sp>
+        <p:nvSpPr>
+          <p:cNvPr id="3" name="TextBox 2"/>
           <p:cNvSpPr txBox="1"/>
           <p:nvPr/>
         </p:nvSpPr>
         <p:spPr>
           <a:xfrm>
-            <a:off x="731520" y="457200"/>
-            <a:ext cx="10698480" cy="731520"/>
+            <a:off x="731520" y="1371600"/>
+            <a:ext cx="10698480" cy="1097280"/>
           </a:xfrm>
           <a:prstGeom prst="rect">
             <a:avLst/>
@@ -4126,192 +5367,48 @@
           <a:noFill/>
         </p:spPr>
         <p:txBody>
-          <a:bodyPr wrap="none">
+          <a:bodyPr wrap="square">
             <a:spAutoFit/>
           </a:bodyPr>
           <a:lstStyle/>
           <a:p>
             <a:pPr>
-              <a:defRPr sz="2800" b="1">
-                <a:solidFill>
-                  <a:srgbClr val="FFFFFF"/>
-                </a:solidFill>
-                <a:latin typeface="Segoe UI"/>
+              <a:defRPr sz="1400">
+                <a:solidFill>
+                  <a:srgbClr val="94A3B8"/>
+                </a:solidFill>
               </a:defRPr>
             </a:pPr>
             <a:r>
-              <a:t>SYSTEM ARCHITECTURE &amp; OBSERVABILITY HUD</a:t>
-            </a:r>
-          </a:p>
-        </p:txBody>
-      </p:sp>
-      <p:sp>
-        <p:nvSpPr>
-          <p:cNvPr id="3" name="Rounded Rectangle 2"/>
-          <p:cNvSpPr/>
+              <a:t>Conversational co-pilot interface showing simulated safety counselor recommendations, legal penalty index search, and speech synthesis feedback stream.</a:t>
+            </a:r>
+          </a:p>
+        </p:txBody>
+      </p:sp>
+      <p:pic>
+        <p:nvPicPr>
+          <p:cNvPr id="4" name="Picture 3" descr="raastasense_ai_guardian.png"/>
+          <p:cNvPicPr>
+            <a:picLocks noChangeAspect="1"/>
+          </p:cNvPicPr>
           <p:nvPr/>
-        </p:nvSpPr>
-        <p:spPr>
-          <a:xfrm>
-            <a:off x="731520" y="1463040"/>
-            <a:ext cx="5120640" cy="4389120"/>
-          </a:xfrm>
-          <a:prstGeom prst="roundRect">
+        </p:nvPicPr>
+        <p:blipFill>
+          <a:blip r:embed="rId2"/>
+          <a:stretch>
+            <a:fillRect/>
+          </a:stretch>
+        </p:blipFill>
+        <p:spPr>
+          <a:xfrm>
+            <a:off x="2798064" y="2468880"/>
+            <a:ext cx="6583680" cy="3840480"/>
+          </a:xfrm>
+          <a:prstGeom prst="rect">
             <a:avLst/>
           </a:prstGeom>
-          <a:solidFill>
-            <a:srgbClr val="1E293B"/>
-          </a:solidFill>
-          <a:ln w="19050">
-            <a:solidFill>
-              <a:srgbClr val="38BDF8"/>
-            </a:solidFill>
-          </a:ln>
-        </p:spPr>
-        <p:style>
-          <a:lnRef idx="1">
-            <a:schemeClr val="accent1"/>
-          </a:lnRef>
-          <a:fillRef idx="3">
-            <a:schemeClr val="accent1"/>
-          </a:fillRef>
-          <a:effectRef idx="2">
-            <a:schemeClr val="accent1"/>
-          </a:effectRef>
-          <a:fontRef idx="minor">
-            <a:schemeClr val="lt1"/>
-          </a:fontRef>
-        </p:style>
-        <p:txBody>
-          <a:bodyPr rtlCol="0" anchor="ctr" wrap="square" tIns="274320"/>
-          <a:lstStyle/>
-          <a:p>
-            <a:pPr algn="ctr">
-              <a:spcAft>
-                <a:spcPts val="1800"/>
-              </a:spcAft>
-              <a:defRPr sz="2000" b="1">
-                <a:solidFill>
-                  <a:srgbClr val="FFFFFF"/>
-                </a:solidFill>
-                <a:latin typeface="Segoe UI"/>
-              </a:defRPr>
-            </a:pPr>
-            <a:r>
-              <a:t>⚙️ Full-Stack Pipeline Architecture</a:t>
-            </a:r>
-          </a:p>
-          <a:p>
-            <a:pPr>
-              <a:defRPr sz="1300">
-                <a:solidFill>
-                  <a:srgbClr val="94A3B8"/>
-                </a:solidFill>
-                <a:latin typeface="Segoe UI"/>
-              </a:defRPr>
-            </a:pPr>
-            <a:r>
-              <a:t>• Client Tier: React 18, Vite, Tailwind CSS, Framer Motion, and custom vector SVGs.</a:t>
-            </a:r>
-            <a:br/>
-            <a:br/>
-            <a:r>
-              <a:t>• Map/GIS Layer: OpenStreetMap integrations, polyline vector algorithms, dynamic marker overlays.</a:t>
-            </a:r>
-            <a:br/>
-            <a:br/>
-            <a:r>
-              <a:t>• Backend &amp; Database: Node.js, Express, mock-telemetry sensor algorithms.</a:t>
-            </a:r>
-            <a:br/>
-            <a:br/>
-            <a:r>
-              <a:t>• AI Core: Google Vision API pothole pixel scanner &amp; safety chatbot fallbacks.</a:t>
-            </a:r>
-          </a:p>
-        </p:txBody>
-      </p:sp>
-      <p:sp>
-        <p:nvSpPr>
-          <p:cNvPr id="4" name="Rounded Rectangle 3"/>
-          <p:cNvSpPr/>
-          <p:nvPr/>
-        </p:nvSpPr>
-        <p:spPr>
-          <a:xfrm>
-            <a:off x="6217920" y="1463040"/>
-            <a:ext cx="5120640" cy="4389120"/>
-          </a:xfrm>
-          <a:prstGeom prst="roundRect">
-            <a:avLst/>
-          </a:prstGeom>
-          <a:solidFill>
-            <a:srgbClr val="1E293B"/>
-          </a:solidFill>
-          <a:ln w="19050">
-            <a:solidFill>
-              <a:srgbClr val="F59E0B"/>
-            </a:solidFill>
-          </a:ln>
-        </p:spPr>
-        <p:style>
-          <a:lnRef idx="1">
-            <a:schemeClr val="accent1"/>
-          </a:lnRef>
-          <a:fillRef idx="3">
-            <a:schemeClr val="accent1"/>
-          </a:fillRef>
-          <a:effectRef idx="2">
-            <a:schemeClr val="accent1"/>
-          </a:effectRef>
-          <a:fontRef idx="minor">
-            <a:schemeClr val="lt1"/>
-          </a:fontRef>
-        </p:style>
-        <p:txBody>
-          <a:bodyPr rtlCol="0" anchor="ctr" wrap="square" tIns="274320"/>
-          <a:lstStyle/>
-          <a:p>
-            <a:pPr algn="ctr">
-              <a:spcAft>
-                <a:spcPts val="1800"/>
-              </a:spcAft>
-              <a:defRPr sz="2000" b="1">
-                <a:solidFill>
-                  <a:srgbClr val="FFFFFF"/>
-                </a:solidFill>
-                <a:latin typeface="Segoe UI"/>
-              </a:defRPr>
-            </a:pPr>
-            <a:r>
-              <a:t>📊 Live Observability &amp; Telemetry Console</a:t>
-            </a:r>
-          </a:p>
-          <a:p>
-            <a:pPr>
-              <a:defRPr sz="1300">
-                <a:solidFill>
-                  <a:srgbClr val="94A3B8"/>
-                </a:solidFill>
-                <a:latin typeface="Segoe UI"/>
-              </a:defRPr>
-            </a:pPr>
-            <a:r>
-              <a:t>• Live Console Telemetry Stream: Chronological NoSQL Firestore connectivity indicator and telemetry status outputs.</a:t>
-            </a:r>
-            <a:br/>
-            <a:br/>
-            <a:r>
-              <a:t>• Custom SVG Safety Charts: Real-time route congestion graph and repairs metrics tracker.</a:t>
-            </a:r>
-            <a:br/>
-            <a:br/>
-            <a:r>
-              <a:t>• 9-Language Localization Dropdown: Multi-lingual localizer supporting regional fine surcharges, legal codes, and AI advice swaps with zero-lag.</a:t>
-            </a:r>
-          </a:p>
-        </p:txBody>
-      </p:sp>
+        </p:spPr>
+      </p:pic>
     </p:spTree>
   </p:cSld>
   <p:clrMapOvr>
@@ -4323,14 +5420,6 @@
 <file path=ppt/slides/slide6.xml><?xml version="1.0" encoding="utf-8"?>
 <p:sld xmlns:a="http://schemas.openxmlformats.org/drawingml/2006/main" xmlns:p="http://schemas.openxmlformats.org/presentationml/2006/main" xmlns:r="http://schemas.openxmlformats.org/officeDocument/2006/relationships">
   <p:cSld>
-    <p:bg>
-      <p:bgPr>
-        <a:solidFill>
-          <a:srgbClr val="0F172A"/>
-        </a:solidFill>
-        <a:effectLst/>
-      </p:bgPr>
-    </p:bg>
     <p:spTree>
       <p:nvGrpSpPr>
         <p:cNvPr id="1" name=""/>
@@ -4340,14 +5429,42 @@
       <p:grpSpPr/>
       <p:sp>
         <p:nvSpPr>
-          <p:cNvPr id="2" name="TextBox 1"/>
+          <p:cNvPr id="2" name="Title 1"/>
+          <p:cNvSpPr>
+            <a:spLocks noGrp="1"/>
+          </p:cNvSpPr>
+          <p:nvPr>
+            <p:ph type="title"/>
+          </p:nvPr>
+        </p:nvSpPr>
+        <p:spPr/>
+        <p:txBody>
+          <a:bodyPr/>
+          <a:lstStyle/>
+          <a:p>
+            <a:pPr>
+              <a:defRPr sz="2800" b="1">
+                <a:solidFill>
+                  <a:srgbClr val="FFFFFF"/>
+                </a:solidFill>
+              </a:defRPr>
+            </a:pPr>
+            <a:r>
+              <a:t>VISUAL HUD: AI SAFETY COCKPIT &amp; LIVE GUARDIAN</a:t>
+            </a:r>
+          </a:p>
+        </p:txBody>
+      </p:sp>
+      <p:sp>
+        <p:nvSpPr>
+          <p:cNvPr id="3" name="TextBox 2"/>
           <p:cNvSpPr txBox="1"/>
           <p:nvPr/>
         </p:nvSpPr>
         <p:spPr>
           <a:xfrm>
-            <a:off x="731520" y="457200"/>
-            <a:ext cx="10698480" cy="731520"/>
+            <a:off x="731520" y="1371600"/>
+            <a:ext cx="10698480" cy="1097280"/>
           </a:xfrm>
           <a:prstGeom prst="rect">
             <a:avLst/>
@@ -4355,238 +5472,48 @@
           <a:noFill/>
         </p:spPr>
         <p:txBody>
-          <a:bodyPr wrap="none">
+          <a:bodyPr wrap="square">
             <a:spAutoFit/>
           </a:bodyPr>
           <a:lstStyle/>
           <a:p>
             <a:pPr>
-              <a:defRPr sz="2800" b="1">
-                <a:solidFill>
-                  <a:srgbClr val="38BDF8"/>
-                </a:solidFill>
-                <a:latin typeface="Segoe UI"/>
+              <a:defRPr sz="1400">
+                <a:solidFill>
+                  <a:srgbClr val="94A3B8"/>
+                </a:solidFill>
               </a:defRPr>
             </a:pPr>
             <a:r>
-              <a:t>MEASURED SOCIETAL &amp; CIVIC IMPACT</a:t>
-            </a:r>
-          </a:p>
-        </p:txBody>
-      </p:sp>
-      <p:sp>
-        <p:nvSpPr>
-          <p:cNvPr id="3" name="Rounded Rectangle 2"/>
-          <p:cNvSpPr/>
+              <a:t>Real-time driver cockpit containing telemetry simulators, speedometer, and the pulsing AI Guardian mascot console with integrated 10-language localizer speech options.</a:t>
+            </a:r>
+          </a:p>
+        </p:txBody>
+      </p:sp>
+      <p:pic>
+        <p:nvPicPr>
+          <p:cNvPr id="4" name="Picture 3" descr="raastasense_hero_ui.png"/>
+          <p:cNvPicPr>
+            <a:picLocks noChangeAspect="1"/>
+          </p:cNvPicPr>
           <p:nvPr/>
-        </p:nvSpPr>
-        <p:spPr>
-          <a:xfrm>
-            <a:off x="731520" y="1645920"/>
-            <a:ext cx="3291840" cy="4114800"/>
-          </a:xfrm>
-          <a:prstGeom prst="roundRect">
+        </p:nvPicPr>
+        <p:blipFill>
+          <a:blip r:embed="rId2"/>
+          <a:stretch>
+            <a:fillRect/>
+          </a:stretch>
+        </p:blipFill>
+        <p:spPr>
+          <a:xfrm>
+            <a:off x="2798064" y="2468880"/>
+            <a:ext cx="6583680" cy="3840480"/>
+          </a:xfrm>
+          <a:prstGeom prst="rect">
             <a:avLst/>
           </a:prstGeom>
-          <a:solidFill>
-            <a:srgbClr val="1E293B"/>
-          </a:solidFill>
-          <a:ln>
-            <a:solidFill>
-              <a:srgbClr val="38BDF8"/>
-            </a:solidFill>
-          </a:ln>
-        </p:spPr>
-        <p:style>
-          <a:lnRef idx="1">
-            <a:schemeClr val="accent1"/>
-          </a:lnRef>
-          <a:fillRef idx="3">
-            <a:schemeClr val="accent1"/>
-          </a:fillRef>
-          <a:effectRef idx="2">
-            <a:schemeClr val="accent1"/>
-          </a:effectRef>
-          <a:fontRef idx="minor">
-            <a:schemeClr val="lt1"/>
-          </a:fontRef>
-        </p:style>
-        <p:txBody>
-          <a:bodyPr rtlCol="0" anchor="ctr" wrap="square" tIns="274320"/>
-          <a:lstStyle/>
-          <a:p>
-            <a:pPr algn="ctr">
-              <a:spcAft>
-                <a:spcPts val="1400"/>
-              </a:spcAft>
-              <a:defRPr sz="1800" b="1">
-                <a:solidFill>
-                  <a:srgbClr val="FFFFFF"/>
-                </a:solidFill>
-                <a:latin typeface="Segoe UI"/>
-              </a:defRPr>
-            </a:pPr>
-            <a:r>
-              <a:t>🚲 Citizens</a:t>
-            </a:r>
-          </a:p>
-          <a:p>
-            <a:pPr>
-              <a:defRPr sz="1300">
-                <a:solidFill>
-                  <a:srgbClr val="94A3B8"/>
-                </a:solidFill>
-                <a:latin typeface="Segoe UI"/>
-              </a:defRPr>
-            </a:pPr>
-            <a:r>
-              <a:t>Safe routing guidelines keep travelers out of congestion/danger zones. Regional DriveLegal counselor builds critical legal self-awareness.</a:t>
-            </a:r>
-          </a:p>
-        </p:txBody>
-      </p:sp>
-      <p:sp>
-        <p:nvSpPr>
-          <p:cNvPr id="4" name="Rounded Rectangle 3"/>
-          <p:cNvSpPr/>
-          <p:nvPr/>
-        </p:nvSpPr>
-        <p:spPr>
-          <a:xfrm>
-            <a:off x="4389120" y="1645920"/>
-            <a:ext cx="3291840" cy="4114800"/>
-          </a:xfrm>
-          <a:prstGeom prst="roundRect">
-            <a:avLst/>
-          </a:prstGeom>
-          <a:solidFill>
-            <a:srgbClr val="1E293B"/>
-          </a:solidFill>
-          <a:ln>
-            <a:solidFill>
-              <a:srgbClr val="F59E0B"/>
-            </a:solidFill>
-          </a:ln>
-        </p:spPr>
-        <p:style>
-          <a:lnRef idx="1">
-            <a:schemeClr val="accent1"/>
-          </a:lnRef>
-          <a:fillRef idx="3">
-            <a:schemeClr val="accent1"/>
-          </a:fillRef>
-          <a:effectRef idx="2">
-            <a:schemeClr val="accent1"/>
-          </a:effectRef>
-          <a:fontRef idx="minor">
-            <a:schemeClr val="lt1"/>
-          </a:fontRef>
-        </p:style>
-        <p:txBody>
-          <a:bodyPr rtlCol="0" anchor="ctr" wrap="square" tIns="274320"/>
-          <a:lstStyle/>
-          <a:p>
-            <a:pPr algn="ctr">
-              <a:spcAft>
-                <a:spcPts val="1400"/>
-              </a:spcAft>
-              <a:defRPr sz="1800" b="1">
-                <a:solidFill>
-                  <a:srgbClr val="FFFFFF"/>
-                </a:solidFill>
-                <a:latin typeface="Segoe UI"/>
-              </a:defRPr>
-            </a:pPr>
-            <a:r>
-              <a:t>👮 Municipalities</a:t>
-            </a:r>
-          </a:p>
-          <a:p>
-            <a:pPr>
-              <a:defRPr sz="1300">
-                <a:solidFill>
-                  <a:srgbClr val="94A3B8"/>
-                </a:solidFill>
-                <a:latin typeface="Segoe UI"/>
-              </a:defRPr>
-            </a:pPr>
-            <a:r>
-              <a:t>RoadWatch community dashboards create transparency in public infrastructure spending, pothole repair trails, and automated violation reporting.</a:t>
-            </a:r>
-          </a:p>
-        </p:txBody>
-      </p:sp>
-      <p:sp>
-        <p:nvSpPr>
-          <p:cNvPr id="5" name="Rounded Rectangle 4"/>
-          <p:cNvSpPr/>
-          <p:nvPr/>
-        </p:nvSpPr>
-        <p:spPr>
-          <a:xfrm>
-            <a:off x="8046720" y="1645920"/>
-            <a:ext cx="3291840" cy="4114800"/>
-          </a:xfrm>
-          <a:prstGeom prst="roundRect">
-            <a:avLst/>
-          </a:prstGeom>
-          <a:solidFill>
-            <a:srgbClr val="1E293B"/>
-          </a:solidFill>
-          <a:ln>
-            <a:solidFill>
-              <a:srgbClr val="F43F5E"/>
-            </a:solidFill>
-          </a:ln>
-        </p:spPr>
-        <p:style>
-          <a:lnRef idx="1">
-            <a:schemeClr val="accent1"/>
-          </a:lnRef>
-          <a:fillRef idx="3">
-            <a:schemeClr val="accent1"/>
-          </a:fillRef>
-          <a:effectRef idx="2">
-            <a:schemeClr val="accent1"/>
-          </a:effectRef>
-          <a:fontRef idx="minor">
-            <a:schemeClr val="lt1"/>
-          </a:fontRef>
-        </p:style>
-        <p:txBody>
-          <a:bodyPr rtlCol="0" anchor="ctr" wrap="square" tIns="274320"/>
-          <a:lstStyle/>
-          <a:p>
-            <a:pPr algn="ctr">
-              <a:spcAft>
-                <a:spcPts val="1400"/>
-              </a:spcAft>
-              <a:defRPr sz="1800" b="1">
-                <a:solidFill>
-                  <a:srgbClr val="FFFFFF"/>
-                </a:solidFill>
-                <a:latin typeface="Segoe UI"/>
-              </a:defRPr>
-            </a:pPr>
-            <a:r>
-              <a:t>🚑 Responders</a:t>
-            </a:r>
-          </a:p>
-          <a:p>
-            <a:pPr>
-              <a:defRPr sz="1300">
-                <a:solidFill>
-                  <a:srgbClr val="94A3B8"/>
-                </a:solidFill>
-                <a:latin typeface="Segoe UI"/>
-              </a:defRPr>
-            </a:pPr>
-            <a:r>
-              <a:t>RoadSOS beacon coordinates lock directly on responder navigation units, slicing dispatch delays and securing the critical Golden Hour rescue frame.</a:t>
-            </a:r>
-          </a:p>
-        </p:txBody>
-      </p:sp>
+        </p:spPr>
+      </p:pic>
     </p:spTree>
   </p:cSld>
   <p:clrMapOvr>
@@ -4598,14 +5525,6 @@
 <file path=ppt/slides/slide7.xml><?xml version="1.0" encoding="utf-8"?>
 <p:sld xmlns:a="http://schemas.openxmlformats.org/drawingml/2006/main" xmlns:p="http://schemas.openxmlformats.org/presentationml/2006/main" xmlns:r="http://schemas.openxmlformats.org/officeDocument/2006/relationships">
   <p:cSld>
-    <p:bg>
-      <p:bgPr>
-        <a:solidFill>
-          <a:srgbClr val="0F172A"/>
-        </a:solidFill>
-        <a:effectLst/>
-      </p:bgPr>
-    </p:bg>
     <p:spTree>
       <p:nvGrpSpPr>
         <p:cNvPr id="1" name=""/>
@@ -4615,14 +5534,42 @@
       <p:grpSpPr/>
       <p:sp>
         <p:nvSpPr>
-          <p:cNvPr id="2" name="TextBox 1"/>
+          <p:cNvPr id="2" name="Title 1"/>
+          <p:cNvSpPr>
+            <a:spLocks noGrp="1"/>
+          </p:cNvSpPr>
+          <p:nvPr>
+            <p:ph type="title"/>
+          </p:nvPr>
+        </p:nvSpPr>
+        <p:spPr/>
+        <p:txBody>
+          <a:bodyPr/>
+          <a:lstStyle/>
+          <a:p>
+            <a:pPr>
+              <a:defRPr sz="2800" b="1">
+                <a:solidFill>
+                  <a:srgbClr val="FFFFFF"/>
+                </a:solidFill>
+              </a:defRPr>
+            </a:pPr>
+            <a:r>
+              <a:t>VISUAL HUD: DIGITAL TWIN MAPPING ENGINE</a:t>
+            </a:r>
+          </a:p>
+        </p:txBody>
+      </p:sp>
+      <p:sp>
+        <p:nvSpPr>
+          <p:cNvPr id="3" name="TextBox 2"/>
           <p:cNvSpPr txBox="1"/>
           <p:nvPr/>
         </p:nvSpPr>
         <p:spPr>
           <a:xfrm>
-            <a:off x="822960" y="1097280"/>
-            <a:ext cx="10515600" cy="4572000"/>
+            <a:off x="731520" y="1371600"/>
+            <a:ext cx="10698480" cy="1097280"/>
           </a:xfrm>
           <a:prstGeom prst="rect">
             <a:avLst/>
@@ -4635,59 +5582,253 @@
           </a:bodyPr>
           <a:lstStyle/>
           <a:p>
-            <a:pPr algn="ctr">
-              <a:spcAft>
-                <a:spcPts val="1400"/>
-              </a:spcAft>
-              <a:defRPr sz="6400" b="1">
-                <a:solidFill>
-                  <a:srgbClr val="38BDF8"/>
-                </a:solidFill>
-                <a:latin typeface="Segoe UI"/>
+            <a:pPr>
+              <a:defRPr sz="1400">
+                <a:solidFill>
+                  <a:srgbClr val="94A3B8"/>
+                </a:solidFill>
               </a:defRPr>
             </a:pPr>
             <a:r>
-              <a:t>THANK YOU!</a:t>
-            </a:r>
-          </a:p>
-          <a:p>
-            <a:pPr algn="ctr">
-              <a:spcAft>
-                <a:spcPts val="4000"/>
-              </a:spcAft>
-              <a:defRPr sz="2000" b="1">
+              <a:t>Cyberslate GIS Interface demonstrating safest, fastest, eco-friendly, and emergency vehicle routing paths, dynamic coordinates telemetry, and active incident report layers.</a:t>
+            </a:r>
+          </a:p>
+        </p:txBody>
+      </p:sp>
+      <p:pic>
+        <p:nvPicPr>
+          <p:cNvPr id="4" name="Picture 3" descr="image.png"/>
+          <p:cNvPicPr>
+            <a:picLocks noChangeAspect="1"/>
+          </p:cNvPicPr>
+          <p:nvPr/>
+        </p:nvPicPr>
+        <p:blipFill>
+          <a:blip r:embed="rId2"/>
+          <a:stretch>
+            <a:fillRect/>
+          </a:stretch>
+        </p:blipFill>
+        <p:spPr>
+          <a:xfrm>
+            <a:off x="2798064" y="2468880"/>
+            <a:ext cx="6583680" cy="3840480"/>
+          </a:xfrm>
+          <a:prstGeom prst="rect">
+            <a:avLst/>
+          </a:prstGeom>
+        </p:spPr>
+      </p:pic>
+    </p:spTree>
+  </p:cSld>
+  <p:clrMapOvr>
+    <a:masterClrMapping/>
+  </p:clrMapOvr>
+</p:sld>
+</file>
+
+<file path=ppt/slides/slide8.xml><?xml version="1.0" encoding="utf-8"?>
+<p:sld xmlns:a="http://schemas.openxmlformats.org/drawingml/2006/main" xmlns:p="http://schemas.openxmlformats.org/presentationml/2006/main" xmlns:r="http://schemas.openxmlformats.org/officeDocument/2006/relationships">
+  <p:cSld>
+    <p:spTree>
+      <p:nvGrpSpPr>
+        <p:cNvPr id="1" name=""/>
+        <p:cNvGrpSpPr/>
+        <p:nvPr/>
+      </p:nvGrpSpPr>
+      <p:grpSpPr/>
+      <p:sp>
+        <p:nvSpPr>
+          <p:cNvPr id="2" name="Title 1"/>
+          <p:cNvSpPr>
+            <a:spLocks noGrp="1"/>
+          </p:cNvSpPr>
+          <p:nvPr>
+            <p:ph type="title"/>
+          </p:nvPr>
+        </p:nvSpPr>
+        <p:spPr/>
+        <p:txBody>
+          <a:bodyPr/>
+          <a:lstStyle/>
+          <a:p>
+            <a:pPr>
+              <a:defRPr sz="2800" b="1">
                 <a:solidFill>
                   <a:srgbClr val="FFFFFF"/>
                 </a:solidFill>
-                <a:latin typeface="Segoe UI"/>
               </a:defRPr>
             </a:pPr>
             <a:r>
-              <a:t>Join us in transforming Indian transit corridors, one life at a time.</a:t>
-            </a:r>
-          </a:p>
-          <a:p>
-            <a:pPr algn="ctr">
-              <a:spcAft>
-                <a:spcPts val="2000"/>
-              </a:spcAft>
-              <a:defRPr sz="1600" b="1">
-                <a:solidFill>
-                  <a:srgbClr val="F59E0B"/>
-                </a:solidFill>
-                <a:latin typeface="Consolas"/>
+              <a:t>VISUAL HUD: AI SAFETY COCKPIT &amp; LIVE GUARDIAN</a:t>
+            </a:r>
+          </a:p>
+        </p:txBody>
+      </p:sp>
+      <p:sp>
+        <p:nvSpPr>
+          <p:cNvPr id="3" name="TextBox 2"/>
+          <p:cNvSpPr txBox="1"/>
+          <p:nvPr/>
+        </p:nvSpPr>
+        <p:spPr>
+          <a:xfrm>
+            <a:off x="731520" y="1371600"/>
+            <a:ext cx="10698480" cy="1097280"/>
+          </a:xfrm>
+          <a:prstGeom prst="rect">
+            <a:avLst/>
+          </a:prstGeom>
+          <a:noFill/>
+        </p:spPr>
+        <p:txBody>
+          <a:bodyPr wrap="square">
+            <a:spAutoFit/>
+          </a:bodyPr>
+          <a:lstStyle/>
+          <a:p>
+            <a:pPr>
+              <a:defRPr sz="1400">
+                <a:solidFill>
+                  <a:srgbClr val="94A3B8"/>
+                </a:solidFill>
               </a:defRPr>
             </a:pPr>
             <a:r>
-              <a:t>🌐 Interactive Live Demo: https://raastasense.vercel.app</a:t>
-            </a:r>
-            <a:br/>
-            <a:r>
-              <a:t>💻 Open-Source Codebase: https://github.com/Ajayrathod04/RaastaSense</a:t>
-            </a:r>
-          </a:p>
-        </p:txBody>
-      </p:sp>
+              <a:t>Real-time driver cockpit containing telemetry simulators, speedometer, and the pulsing AI Guardian mascot console with integrated 10-language localizer speech options.</a:t>
+            </a:r>
+          </a:p>
+        </p:txBody>
+      </p:sp>
+      <p:pic>
+        <p:nvPicPr>
+          <p:cNvPr id="4" name="Picture 3" descr="raastasense_hero_ui.png"/>
+          <p:cNvPicPr>
+            <a:picLocks noChangeAspect="1"/>
+          </p:cNvPicPr>
+          <p:nvPr/>
+        </p:nvPicPr>
+        <p:blipFill>
+          <a:blip r:embed="rId2"/>
+          <a:stretch>
+            <a:fillRect/>
+          </a:stretch>
+        </p:blipFill>
+        <p:spPr>
+          <a:xfrm>
+            <a:off x="2798064" y="2468880"/>
+            <a:ext cx="6583680" cy="3840480"/>
+          </a:xfrm>
+          <a:prstGeom prst="rect">
+            <a:avLst/>
+          </a:prstGeom>
+        </p:spPr>
+      </p:pic>
+    </p:spTree>
+  </p:cSld>
+  <p:clrMapOvr>
+    <a:masterClrMapping/>
+  </p:clrMapOvr>
+</p:sld>
+</file>
+
+<file path=ppt/slides/slide9.xml><?xml version="1.0" encoding="utf-8"?>
+<p:sld xmlns:a="http://schemas.openxmlformats.org/drawingml/2006/main" xmlns:p="http://schemas.openxmlformats.org/presentationml/2006/main" xmlns:r="http://schemas.openxmlformats.org/officeDocument/2006/relationships">
+  <p:cSld>
+    <p:spTree>
+      <p:nvGrpSpPr>
+        <p:cNvPr id="1" name=""/>
+        <p:cNvGrpSpPr/>
+        <p:nvPr/>
+      </p:nvGrpSpPr>
+      <p:grpSpPr/>
+      <p:sp>
+        <p:nvSpPr>
+          <p:cNvPr id="2" name="Title 1"/>
+          <p:cNvSpPr>
+            <a:spLocks noGrp="1"/>
+          </p:cNvSpPr>
+          <p:nvPr>
+            <p:ph type="title"/>
+          </p:nvPr>
+        </p:nvSpPr>
+        <p:spPr/>
+        <p:txBody>
+          <a:bodyPr/>
+          <a:lstStyle/>
+          <a:p>
+            <a:pPr>
+              <a:defRPr sz="2800" b="1">
+                <a:solidFill>
+                  <a:srgbClr val="FFFFFF"/>
+                </a:solidFill>
+              </a:defRPr>
+            </a:pPr>
+            <a:r>
+              <a:t>VISUAL HUD: OBSERVABILITY &amp; 10-CITY ANALYTICS</a:t>
+            </a:r>
+          </a:p>
+        </p:txBody>
+      </p:sp>
+      <p:sp>
+        <p:nvSpPr>
+          <p:cNvPr id="3" name="TextBox 2"/>
+          <p:cNvSpPr txBox="1"/>
+          <p:nvPr/>
+        </p:nvSpPr>
+        <p:spPr>
+          <a:xfrm>
+            <a:off x="731520" y="1371600"/>
+            <a:ext cx="10698480" cy="1097280"/>
+          </a:xfrm>
+          <a:prstGeom prst="rect">
+            <a:avLst/>
+          </a:prstGeom>
+          <a:noFill/>
+        </p:spPr>
+        <p:txBody>
+          <a:bodyPr wrap="square">
+            <a:spAutoFit/>
+          </a:bodyPr>
+          <a:lstStyle/>
+          <a:p>
+            <a:pPr>
+              <a:defRPr sz="1400">
+                <a:solidFill>
+                  <a:srgbClr val="94A3B8"/>
+                </a:solidFill>
+              </a:defRPr>
+            </a:pPr>
+            <a:r>
+              <a:t>Advanced telemetry dashboard with chronological NoSQL live stream, and dynamic comparative metrics for Nagpur, Mumbai, Pune, Delhi, Hyderabad, Bangalore, Chennai, Ahmedabad, Kolkata, and Jaipur.</a:t>
+            </a:r>
+          </a:p>
+        </p:txBody>
+      </p:sp>
+      <p:pic>
+        <p:nvPicPr>
+          <p:cNvPr id="4" name="Picture 3" descr="image.png"/>
+          <p:cNvPicPr>
+            <a:picLocks noChangeAspect="1"/>
+          </p:cNvPicPr>
+          <p:nvPr/>
+        </p:nvPicPr>
+        <p:blipFill>
+          <a:blip r:embed="rId2"/>
+          <a:stretch>
+            <a:fillRect/>
+          </a:stretch>
+        </p:blipFill>
+        <p:spPr>
+          <a:xfrm>
+            <a:off x="2798064" y="2468880"/>
+            <a:ext cx="6583680" cy="3840480"/>
+          </a:xfrm>
+          <a:prstGeom prst="rect">
+            <a:avLst/>
+          </a:prstGeom>
+        </p:spPr>
+      </p:pic>
     </p:spTree>
   </p:cSld>
   <p:clrMapOvr>

</xml_diff>